<commit_message>
Rebuild HFCS poster in the MRKH/PMDD Liberty template layout
Methods table, stat row, numbered figures with captions, key takeaway,
fuller results/discussion/limitations and implications with AMA
citations, references panel, larger body text.

Co-Authored-By: Claude Opus 5.5 <noreply@anthropic.com>
Claude-Session: https://claude.ai/code/session_01GDCp9vaBDB24tAeq3Z16Kb
</commit_message>
<xml_diff>
--- a/HFCS_APHA_Poster_Revised.pptx
+++ b/HFCS_APHA_Poster_Revised.pptx
@@ -8,7 +8,7 @@
     <p:notesMasterId r:id="rId3"/>
   </p:notesMasterIdLst>
   <p:sldIdLst>
-    <p:sldId id="256" r:id="rId2"/>
+    <p:sldId id="258" r:id="rId2"/>
   </p:sldIdLst>
   <p:sldSz cx="43891200" cy="32918400"/>
   <p:notesSz cx="9144000" cy="6858000"/>
@@ -131,443 +131,6 @@
 </p:presentation>
 </file>
 
-<file path=ppt/authors.xml><?xml version="1.0" encoding="utf-8"?>
-<p188:authorLst xmlns:a="http://schemas.openxmlformats.org/drawingml/2006/main" xmlns:r="http://schemas.openxmlformats.org/officeDocument/2006/relationships" xmlns:p188="http://schemas.microsoft.com/office/powerpoint/2018/8/main">
-  <p188:author id="{9D3083AB-C36B-CFDC-FB20-ECBBB127C0CC}" name="Roberts, Miebaka F." initials="RM" userId="S::mfroberts@carilionclinic.org::4c0b39b9-6c11-4fa1-8e9a-3c411b555404" providerId="AD"/>
-</p188:authorLst>
-</file>
-
-<file path=ppt/revisionInfo.xml><?xml version="1.0" encoding="utf-8"?>
-<p1510:revInfo xmlns:a="http://schemas.openxmlformats.org/drawingml/2006/main" xmlns:r="http://schemas.openxmlformats.org/officeDocument/2006/relationships" xmlns:p1510="http://schemas.microsoft.com/office/powerpoint/2015/10/main">
-  <p1510:revLst>
-    <p1510:client id="{0B4B3479-727E-706F-BE3D-CADADAA5DF19}" v="4" dt="2026-09-24T00:56:01.312"/>
-  </p1510:revLst>
-</p1510:revInfo>
-</file>
-
-<file path=ppt/charts/chart1.xml><?xml version="1.0" encoding="utf-8"?>
-<c:chartSpace xmlns:c="http://schemas.openxmlformats.org/drawingml/2006/chart" xmlns:a="http://schemas.openxmlformats.org/drawingml/2006/main" xmlns:r="http://schemas.openxmlformats.org/officeDocument/2006/relationships" xmlns:c16r2="http://schemas.microsoft.com/office/drawing/2015/06/chart">
-  <c:date1904 val="0"/>
-  <c:lang val="en-US"/>
-  <c:roundedCorners val="0"/>
-  <mc:AlternateContent xmlns:mc="http://schemas.openxmlformats.org/markup-compatibility/2006">
-    <mc:Choice xmlns:c14="http://schemas.microsoft.com/office/drawing/2007/8/2/chart" Requires="c14">
-      <c14:style val="118"/>
-    </mc:Choice>
-    <mc:Fallback>
-      <c:style val="18"/>
-    </mc:Fallback>
-  </mc:AlternateContent>
-  <c:chart>
-    <c:autoTitleDeleted val="1"/>
-    <c:plotArea>
-      <c:layout/>
-      <c:lineChart>
-        <c:grouping val="standard"/>
-        <c:varyColors val="0"/>
-        <c:ser>
-          <c:idx val="2"/>
-          <c:order val="0"/>
-          <c:tx>
-            <c:strRef>
-              <c:f>Graph!$C$47</c:f>
-              <c:strCache>
-                <c:ptCount val="1"/>
-              </c:strCache>
-            </c:strRef>
-          </c:tx>
-          <c:cat>
-            <c:numRef>
-              <c:f>Graph!$B$48:$B$51</c:f>
-              <c:numCache>
-                <c:formatCode>General</c:formatCode>
-                <c:ptCount val="4"/>
-              </c:numCache>
-            </c:numRef>
-          </c:cat>
-          <c:val>
-            <c:numRef>
-              <c:f>Graph!$C$48:$C$51</c:f>
-              <c:numCache>
-                <c:formatCode>General</c:formatCode>
-                <c:ptCount val="4"/>
-              </c:numCache>
-            </c:numRef>
-          </c:val>
-          <c:smooth val="0"/>
-          <c:extLst>
-            <c:ext xmlns:c16="http://schemas.microsoft.com/office/drawing/2014/chart" uri="{C3380CC4-5D6E-409C-BE32-E72D297353CC}">
-              <c16:uniqueId val="{00000000-85B9-496C-A6E7-D46121A6D667}"/>
-            </c:ext>
-          </c:extLst>
-        </c:ser>
-        <c:ser>
-          <c:idx val="3"/>
-          <c:order val="1"/>
-          <c:tx>
-            <c:strRef>
-              <c:f>Graph!$D$47</c:f>
-              <c:strCache>
-                <c:ptCount val="1"/>
-              </c:strCache>
-            </c:strRef>
-          </c:tx>
-          <c:cat>
-            <c:numRef>
-              <c:f>Graph!$B$48:$B$51</c:f>
-              <c:numCache>
-                <c:formatCode>General</c:formatCode>
-                <c:ptCount val="4"/>
-              </c:numCache>
-            </c:numRef>
-          </c:cat>
-          <c:val>
-            <c:numRef>
-              <c:f>Graph!$D$48:$D$51</c:f>
-              <c:numCache>
-                <c:formatCode>General</c:formatCode>
-                <c:ptCount val="4"/>
-              </c:numCache>
-            </c:numRef>
-          </c:val>
-          <c:smooth val="0"/>
-          <c:extLst>
-            <c:ext xmlns:c16="http://schemas.microsoft.com/office/drawing/2014/chart" uri="{C3380CC4-5D6E-409C-BE32-E72D297353CC}">
-              <c16:uniqueId val="{00000001-85B9-496C-A6E7-D46121A6D667}"/>
-            </c:ext>
-          </c:extLst>
-        </c:ser>
-        <c:dLbls>
-          <c:showLegendKey val="0"/>
-          <c:showVal val="0"/>
-          <c:showCatName val="0"/>
-          <c:showSerName val="0"/>
-          <c:showPercent val="0"/>
-          <c:showBubbleSize val="0"/>
-        </c:dLbls>
-        <c:marker val="1"/>
-        <c:smooth val="0"/>
-        <c:axId val="2087559344"/>
-        <c:axId val="2086697360"/>
-      </c:lineChart>
-      <c:catAx>
-        <c:axId val="2087559344"/>
-        <c:scaling>
-          <c:orientation val="minMax"/>
-        </c:scaling>
-        <c:delete val="0"/>
-        <c:axPos val="b"/>
-        <c:title>
-          <c:tx>
-            <c:rich>
-              <a:bodyPr/>
-              <a:lstStyle/>
-              <a:p>
-                <a:pPr>
-                  <a:defRPr/>
-                </a:pPr>
-                <a:r>
-                  <a:rPr lang="en-US"/>
-                  <a:t>Days</a:t>
-                </a:r>
-              </a:p>
-            </c:rich>
-          </c:tx>
-          <c:overlay val="0"/>
-        </c:title>
-        <c:numFmt formatCode="General" sourceLinked="1"/>
-        <c:majorTickMark val="out"/>
-        <c:minorTickMark val="none"/>
-        <c:tickLblPos val="nextTo"/>
-        <c:crossAx val="2086697360"/>
-        <c:crosses val="autoZero"/>
-        <c:auto val="1"/>
-        <c:lblAlgn val="ctr"/>
-        <c:lblOffset val="100"/>
-        <c:noMultiLvlLbl val="0"/>
-      </c:catAx>
-      <c:valAx>
-        <c:axId val="2086697360"/>
-        <c:scaling>
-          <c:orientation val="minMax"/>
-        </c:scaling>
-        <c:delete val="0"/>
-        <c:axPos val="l"/>
-        <c:title>
-          <c:tx>
-            <c:rich>
-              <a:bodyPr rot="-5400000" vert="horz"/>
-              <a:lstStyle/>
-              <a:p>
-                <a:pPr>
-                  <a:defRPr/>
-                </a:pPr>
-                <a:r>
-                  <a:rPr lang="en-US"/>
-                  <a:t>Log CFU/G Feces</a:t>
-                </a:r>
-              </a:p>
-            </c:rich>
-          </c:tx>
-          <c:overlay val="0"/>
-        </c:title>
-        <c:numFmt formatCode="General" sourceLinked="1"/>
-        <c:majorTickMark val="out"/>
-        <c:minorTickMark val="none"/>
-        <c:tickLblPos val="nextTo"/>
-        <c:crossAx val="2087559344"/>
-        <c:crosses val="autoZero"/>
-        <c:crossBetween val="between"/>
-      </c:valAx>
-      <c:spPr>
-        <a:noFill/>
-        <a:ln w="25400">
-          <a:noFill/>
-        </a:ln>
-      </c:spPr>
-    </c:plotArea>
-    <c:legend>
-      <c:legendPos val="r"/>
-      <c:legendEntry>
-        <c:idx val="0"/>
-        <c:delete val="1"/>
-      </c:legendEntry>
-      <c:legendEntry>
-        <c:idx val="1"/>
-        <c:delete val="1"/>
-      </c:legendEntry>
-      <c:layout>
-        <c:manualLayout>
-          <c:xMode val="edge"/>
-          <c:yMode val="edge"/>
-          <c:x val="0.80384573311613805"/>
-          <c:y val="0.53612258863681606"/>
-          <c:w val="0.167304016632842"/>
-          <c:h val="0.22093414065816"/>
-        </c:manualLayout>
-      </c:layout>
-      <c:overlay val="1"/>
-    </c:legend>
-    <c:plotVisOnly val="1"/>
-    <c:dispBlanksAs val="gap"/>
-    <c:showDLblsOverMax val="0"/>
-  </c:chart>
-  <c:externalData r:id="rId1">
-    <c:autoUpdate val="0"/>
-  </c:externalData>
-</c:chartSpace>
-</file>
-
-<file path=ppt/charts/chart2.xml><?xml version="1.0" encoding="utf-8"?>
-<c:chartSpace xmlns:c="http://schemas.openxmlformats.org/drawingml/2006/chart" xmlns:a="http://schemas.openxmlformats.org/drawingml/2006/main" xmlns:r="http://schemas.openxmlformats.org/officeDocument/2006/relationships" xmlns:c16r2="http://schemas.microsoft.com/office/drawing/2015/06/chart">
-  <c:date1904 val="0"/>
-  <c:lang val="en-US"/>
-  <c:roundedCorners val="0"/>
-  <mc:AlternateContent xmlns:mc="http://schemas.openxmlformats.org/markup-compatibility/2006">
-    <mc:Choice xmlns:c14="http://schemas.microsoft.com/office/drawing/2007/8/2/chart" Requires="c14">
-      <c14:style val="118"/>
-    </mc:Choice>
-    <mc:Fallback>
-      <c:style val="18"/>
-    </mc:Fallback>
-  </mc:AlternateContent>
-  <c:chart>
-    <c:title>
-      <c:tx>
-        <c:rich>
-          <a:bodyPr/>
-          <a:lstStyle/>
-          <a:p>
-            <a:pPr>
-              <a:defRPr/>
-            </a:pPr>
-            <a:r>
-              <a:rPr lang="en-US" dirty="0"/>
-              <a:t>MG1655 µ on 0.02% Lactose</a:t>
-            </a:r>
-            <a:endParaRPr lang="en-US" baseline="0" dirty="0"/>
-          </a:p>
-        </c:rich>
-      </c:tx>
-      <c:overlay val="0"/>
-    </c:title>
-    <c:autoTitleDeleted val="0"/>
-    <c:plotArea>
-      <c:layout/>
-      <c:barChart>
-        <c:barDir val="col"/>
-        <c:grouping val="clustered"/>
-        <c:varyColors val="0"/>
-        <c:dLbls>
-          <c:showLegendKey val="0"/>
-          <c:showVal val="0"/>
-          <c:showCatName val="0"/>
-          <c:showSerName val="0"/>
-          <c:showPercent val="0"/>
-          <c:showBubbleSize val="0"/>
-        </c:dLbls>
-        <c:gapWidth val="150"/>
-        <c:axId val="2102178064"/>
-        <c:axId val="2102151680"/>
-      </c:barChart>
-      <c:catAx>
-        <c:axId val="2102178064"/>
-        <c:scaling>
-          <c:orientation val="minMax"/>
-        </c:scaling>
-        <c:delete val="1"/>
-        <c:axPos val="b"/>
-        <c:title>
-          <c:tx>
-            <c:rich>
-              <a:bodyPr/>
-              <a:lstStyle/>
-              <a:p>
-                <a:pPr>
-                  <a:defRPr/>
-                </a:pPr>
-                <a:r>
-                  <a:rPr lang="en-US" dirty="0"/>
-                  <a:t>MG1655</a:t>
-                </a:r>
-                <a:r>
-                  <a:rPr lang="en-US" baseline="0" dirty="0"/>
-                  <a:t>                                 MG1655∆</a:t>
-                </a:r>
-                <a:r>
-                  <a:rPr lang="en-US" i="1" baseline="0" dirty="0"/>
-                  <a:t>qseC</a:t>
-                </a:r>
-                <a:endParaRPr lang="en-US" i="1" dirty="0"/>
-              </a:p>
-            </c:rich>
-          </c:tx>
-          <c:layout>
-            <c:manualLayout>
-              <c:xMode val="edge"/>
-              <c:yMode val="edge"/>
-              <c:x val="0.22462529667505099"/>
-              <c:y val="0.88977695985336502"/>
-            </c:manualLayout>
-          </c:layout>
-          <c:overlay val="0"/>
-        </c:title>
-        <c:majorTickMark val="out"/>
-        <c:minorTickMark val="none"/>
-        <c:tickLblPos val="nextTo"/>
-        <c:crossAx val="2102151680"/>
-        <c:crosses val="autoZero"/>
-        <c:auto val="0"/>
-        <c:lblAlgn val="ctr"/>
-        <c:lblOffset val="100"/>
-        <c:noMultiLvlLbl val="0"/>
-      </c:catAx>
-      <c:valAx>
-        <c:axId val="2102151680"/>
-        <c:scaling>
-          <c:orientation val="minMax"/>
-        </c:scaling>
-        <c:delete val="0"/>
-        <c:axPos val="l"/>
-        <c:majorGridlines/>
-        <c:numFmt formatCode="General" sourceLinked="1"/>
-        <c:majorTickMark val="out"/>
-        <c:minorTickMark val="none"/>
-        <c:tickLblPos val="nextTo"/>
-        <c:crossAx val="2102178064"/>
-        <c:crosses val="autoZero"/>
-        <c:crossBetween val="between"/>
-      </c:valAx>
-      <c:spPr>
-        <a:noFill/>
-        <a:ln w="25400">
-          <a:noFill/>
-        </a:ln>
-      </c:spPr>
-    </c:plotArea>
-    <c:plotVisOnly val="1"/>
-    <c:dispBlanksAs val="gap"/>
-    <c:showDLblsOverMax val="0"/>
-  </c:chart>
-  <c:externalData r:id="rId1">
-    <c:autoUpdate val="0"/>
-  </c:externalData>
-</c:chartSpace>
-</file>
-
-<file path=ppt/comments/modernComment_100_C19419DD.xml><?xml version="1.0" encoding="utf-8"?>
-<p188:cmLst xmlns:a="http://schemas.openxmlformats.org/drawingml/2006/main" xmlns:r="http://schemas.openxmlformats.org/officeDocument/2006/relationships" xmlns:p188="http://schemas.microsoft.com/office/powerpoint/2018/8/main">
-  <p188:cm id="{FE5399A7-78A7-4B98-8D6D-01498BD19095}" authorId="{9D3083AB-C36B-CFDC-FB20-ECBBB127C0CC}" created="2026-09-24T00:51:49.550">
-    <ac:deMkLst xmlns:ac="http://schemas.microsoft.com/office/drawing/2013/main/command">
-      <pc:docMk xmlns:pc="http://schemas.microsoft.com/office/powerpoint/2013/main/command"/>
-      <pc:sldMk xmlns:pc="http://schemas.microsoft.com/office/powerpoint/2013/main/command" cId="3247708637" sldId="256"/>
-      <ac:spMk id="312" creationId="{00000000-0000-0000-0000-000000000000}"/>
-    </ac:deMkLst>
-    <p188:txBody>
-      <a:bodyPr/>
-      <a:lstStyle/>
-      <a:p>
-        <a:r>
-          <a:rPr lang="en-US"/>
-          <a:t>make the words larger nobody can read theses</a:t>
-        </a:r>
-      </a:p>
-    </p188:txBody>
-  </p188:cm>
-  <p188:cm id="{206FB453-9B99-496D-951F-CB8FAB06DCF2}" authorId="{9D3083AB-C36B-CFDC-FB20-ECBBB127C0CC}" created="2026-09-24T00:53:08.428">
-    <ac:deMkLst xmlns:ac="http://schemas.microsoft.com/office/drawing/2013/main/command">
-      <pc:docMk xmlns:pc="http://schemas.microsoft.com/office/powerpoint/2013/main/command"/>
-      <pc:sldMk xmlns:pc="http://schemas.microsoft.com/office/powerpoint/2013/main/command" cId="3247708637" sldId="256"/>
-      <ac:spMk id="4" creationId="{00000000-0000-0000-0000-000000000000}"/>
-    </ac:deMkLst>
-    <p188:txBody>
-      <a:bodyPr/>
-      <a:lstStyle/>
-      <a:p>
-        <a:r>
-          <a:rPr lang="en-US"/>
-          <a:t>where are our names</a:t>
-        </a:r>
-      </a:p>
-    </p188:txBody>
-  </p188:cm>
-  <p188:cm id="{3CEF1DBF-BC0A-48AB-A24B-C21412AE7222}" authorId="{9D3083AB-C36B-CFDC-FB20-ECBBB127C0CC}" created="2026-09-24T00:54:16.867">
-    <ac:deMkLst xmlns:ac="http://schemas.microsoft.com/office/drawing/2013/main/command">
-      <pc:docMk xmlns:pc="http://schemas.microsoft.com/office/powerpoint/2013/main/command"/>
-      <pc:sldMk xmlns:pc="http://schemas.microsoft.com/office/powerpoint/2013/main/command" cId="3247708637" sldId="256"/>
-      <ac:spMk id="323" creationId="{00000000-0000-0000-0000-000000000000}"/>
-    </ac:deMkLst>
-    <p188:txBody>
-      <a:bodyPr/>
-      <a:lstStyle/>
-      <a:p>
-        <a:r>
-          <a:rPr lang="en-US"/>
-          <a:t>you can remove the references nobody cares about this just remove it and make more space to enlarge the order text</a:t>
-        </a:r>
-      </a:p>
-    </p188:txBody>
-  </p188:cm>
-  <p188:cm id="{684E5393-9DAC-4548-BCBC-64CA5FEF00E0}" authorId="{9D3083AB-C36B-CFDC-FB20-ECBBB127C0CC}" created="2026-09-24T00:56:01.312">
-    <ac:deMkLst xmlns:ac="http://schemas.microsoft.com/office/drawing/2013/main/command">
-      <pc:docMk xmlns:pc="http://schemas.microsoft.com/office/powerpoint/2013/main/command"/>
-      <pc:sldMk xmlns:pc="http://schemas.microsoft.com/office/powerpoint/2013/main/command" cId="3247708637" sldId="256"/>
-      <ac:picMk id="3" creationId="{3F0560BD-D7F3-094E-AB70-54F1DF79AEB2}"/>
-    </ac:deMkLst>
-    <p188:txBody>
-      <a:bodyPr/>
-      <a:lstStyle/>
-      <a:p>
-        <a:r>
-          <a:rPr lang="en-US"/>
-          <a:t>remove this image its the same thing as the one beside it</a:t>
-        </a:r>
-      </a:p>
-    </p188:txBody>
-  </p188:cm>
-</p188:cmLst>
-</file>
-
 <file path=ppt/notesMasters/notesMaster1.xml><?xml version="1.0" encoding="utf-8"?>
 <p:notesMaster xmlns:a="http://schemas.openxmlformats.org/drawingml/2006/main" xmlns:r="http://schemas.openxmlformats.org/officeDocument/2006/relationships" xmlns:p="http://schemas.openxmlformats.org/presentationml/2006/main">
   <p:cSld>
@@ -650,7 +213,7 @@
           <a:p>
             <a:fld id="{36263FE2-9438-354A-B60A-5A471281E58B}" type="datetimeFigureOut">
               <a:rPr lang="en-US" smtClean="0"/>
-              <a:t>9/23/2026</a:t>
+              <a:t>9/3/2026</a:t>
             </a:fld>
             <a:endParaRPr lang="en-US"/>
           </a:p>
@@ -922,7 +485,13 @@
   <p:cSld>
     <p:spTree>
       <p:nvGrpSpPr>
-        <p:cNvPr id="1" name=""/>
+        <p:cNvPr id="1" name="">
+          <a:extLst>
+            <a:ext uri="{FF2B5EF4-FFF2-40B4-BE49-F238E27FC236}">
+              <a16:creationId xmlns:a16="http://schemas.microsoft.com/office/drawing/2014/main" id="{5A5EFD75-C664-C06B-8435-139272CD8BA1}"/>
+            </a:ext>
+          </a:extLst>
+        </p:cNvPr>
         <p:cNvGrpSpPr/>
         <p:nvPr/>
       </p:nvGrpSpPr>
@@ -936,7 +505,13 @@
       </p:grpSpPr>
       <p:sp>
         <p:nvSpPr>
-          <p:cNvPr id="2" name="Slide Image Placeholder 1"/>
+          <p:cNvPr id="2" name="Slide Image Placeholder 1">
+            <a:extLst>
+              <a:ext uri="{FF2B5EF4-FFF2-40B4-BE49-F238E27FC236}">
+                <a16:creationId xmlns:a16="http://schemas.microsoft.com/office/drawing/2014/main" id="{C5CFBF99-3EB2-AAD2-6F03-91E84EC7D2C9}"/>
+              </a:ext>
+            </a:extLst>
+          </p:cNvPr>
           <p:cNvSpPr>
             <a:spLocks noGrp="1" noRot="1" noChangeAspect="1"/>
           </p:cNvSpPr>
@@ -953,7 +528,13 @@
       </p:sp>
       <p:sp>
         <p:nvSpPr>
-          <p:cNvPr id="3" name="Notes Placeholder 2"/>
+          <p:cNvPr id="3" name="Notes Placeholder 2">
+            <a:extLst>
+              <a:ext uri="{FF2B5EF4-FFF2-40B4-BE49-F238E27FC236}">
+                <a16:creationId xmlns:a16="http://schemas.microsoft.com/office/drawing/2014/main" id="{DA8B7ED1-8F00-CF7C-FF86-F0BA76EF2151}"/>
+              </a:ext>
+            </a:extLst>
+          </p:cNvPr>
           <p:cNvSpPr>
             <a:spLocks noGrp="1"/>
           </p:cNvSpPr>
@@ -972,7 +553,13 @@
       </p:sp>
       <p:sp>
         <p:nvSpPr>
-          <p:cNvPr id="4" name="Slide Number Placeholder 3"/>
+          <p:cNvPr id="4" name="Slide Number Placeholder 3">
+            <a:extLst>
+              <a:ext uri="{FF2B5EF4-FFF2-40B4-BE49-F238E27FC236}">
+                <a16:creationId xmlns:a16="http://schemas.microsoft.com/office/drawing/2014/main" id="{5FC7187B-62FD-CA95-DAC6-813F753CB3B0}"/>
+              </a:ext>
+            </a:extLst>
+          </p:cNvPr>
           <p:cNvSpPr>
             <a:spLocks noGrp="1"/>
           </p:cNvSpPr>
@@ -996,7 +583,7 @@
     </p:spTree>
     <p:extLst>
       <p:ext uri="{BB962C8B-B14F-4D97-AF65-F5344CB8AC3E}">
-        <p14:creationId xmlns:p14="http://schemas.microsoft.com/office/powerpoint/2010/main" val="2332982677"/>
+        <p14:creationId xmlns:p14="http://schemas.microsoft.com/office/powerpoint/2010/main" val="425095891"/>
       </p:ext>
     </p:extLst>
   </p:cSld>
@@ -1191,7 +778,7 @@
           <a:p>
             <a:fld id="{163D97CC-475F-BE49-B579-6BFEF977A37E}" type="datetimeFigureOut">
               <a:rPr lang="en-US" smtClean="0"/>
-              <a:t>9/23/2026</a:t>
+              <a:t>9/3/2026</a:t>
             </a:fld>
             <a:endParaRPr lang="en-US"/>
           </a:p>
@@ -1494,7 +1081,7 @@
           <a:p>
             <a:fld id="{163D97CC-475F-BE49-B579-6BFEF977A37E}" type="datetimeFigureOut">
               <a:rPr lang="en-US" smtClean="0"/>
-              <a:t>9/23/2026</a:t>
+              <a:t>9/3/2026</a:t>
             </a:fld>
             <a:endParaRPr lang="en-US"/>
           </a:p>
@@ -1686,7 +1273,7 @@
           <a:p>
             <a:fld id="{163D97CC-475F-BE49-B579-6BFEF977A37E}" type="datetimeFigureOut">
               <a:rPr lang="en-US" smtClean="0"/>
-              <a:t>9/23/2026</a:t>
+              <a:t>9/3/2026</a:t>
             </a:fld>
             <a:endParaRPr lang="en-US"/>
           </a:p>
@@ -1947,7 +1534,7 @@
           <a:p>
             <a:fld id="{163D97CC-475F-BE49-B579-6BFEF977A37E}" type="datetimeFigureOut">
               <a:rPr lang="en-US" smtClean="0"/>
-              <a:t>9/23/2026</a:t>
+              <a:t>9/3/2026</a:t>
             </a:fld>
             <a:endParaRPr lang="en-US"/>
           </a:p>
@@ -2371,7 +1958,7 @@
           <a:p>
             <a:fld id="{163D97CC-475F-BE49-B579-6BFEF977A37E}" type="datetimeFigureOut">
               <a:rPr lang="en-US" smtClean="0"/>
-              <a:t>9/23/2026</a:t>
+              <a:t>9/3/2026</a:t>
             </a:fld>
             <a:endParaRPr lang="en-US"/>
           </a:p>
@@ -2908,7 +2495,7 @@
           <a:p>
             <a:fld id="{163D97CC-475F-BE49-B579-6BFEF977A37E}" type="datetimeFigureOut">
               <a:rPr lang="en-US" smtClean="0"/>
-              <a:t>9/23/2026</a:t>
+              <a:t>9/3/2026</a:t>
             </a:fld>
             <a:endParaRPr lang="en-US"/>
           </a:p>
@@ -3772,7 +3359,7 @@
           <a:p>
             <a:fld id="{163D97CC-475F-BE49-B579-6BFEF977A37E}" type="datetimeFigureOut">
               <a:rPr lang="en-US" smtClean="0"/>
-              <a:t>9/23/2026</a:t>
+              <a:t>9/3/2026</a:t>
             </a:fld>
             <a:endParaRPr lang="en-US"/>
           </a:p>
@@ -3942,7 +3529,7 @@
           <a:p>
             <a:fld id="{163D97CC-475F-BE49-B579-6BFEF977A37E}" type="datetimeFigureOut">
               <a:rPr lang="en-US" smtClean="0"/>
-              <a:t>9/23/2026</a:t>
+              <a:t>9/3/2026</a:t>
             </a:fld>
             <a:endParaRPr lang="en-US"/>
           </a:p>
@@ -4126,7 +3713,7 @@
           <a:p>
             <a:fld id="{163D97CC-475F-BE49-B579-6BFEF977A37E}" type="datetimeFigureOut">
               <a:rPr lang="en-US" smtClean="0"/>
-              <a:t>9/23/2026</a:t>
+              <a:t>9/3/2026</a:t>
             </a:fld>
             <a:endParaRPr lang="en-US"/>
           </a:p>
@@ -4301,7 +3888,7 @@
           <a:p>
             <a:fld id="{163D97CC-475F-BE49-B579-6BFEF977A37E}" type="datetimeFigureOut">
               <a:rPr lang="en-US" smtClean="0"/>
-              <a:t>9/23/2026</a:t>
+              <a:t>9/3/2026</a:t>
             </a:fld>
             <a:endParaRPr lang="en-US"/>
           </a:p>
@@ -4545,7 +4132,7 @@
           <a:p>
             <a:fld id="{163D97CC-475F-BE49-B579-6BFEF977A37E}" type="datetimeFigureOut">
               <a:rPr lang="en-US" smtClean="0"/>
-              <a:t>9/23/2026</a:t>
+              <a:t>9/3/2026</a:t>
             </a:fld>
             <a:endParaRPr lang="en-US"/>
           </a:p>
@@ -4781,7 +4368,7 @@
           <a:p>
             <a:fld id="{163D97CC-475F-BE49-B579-6BFEF977A37E}" type="datetimeFigureOut">
               <a:rPr lang="en-US" smtClean="0"/>
-              <a:t>9/23/2026</a:t>
+              <a:t>9/3/2026</a:t>
             </a:fld>
             <a:endParaRPr lang="en-US"/>
           </a:p>
@@ -5247,7 +4834,7 @@
           <a:p>
             <a:fld id="{163D97CC-475F-BE49-B579-6BFEF977A37E}" type="datetimeFigureOut">
               <a:rPr lang="en-US" smtClean="0"/>
-              <a:t>9/23/2026</a:t>
+              <a:t>9/3/2026</a:t>
             </a:fld>
             <a:endParaRPr lang="en-US"/>
           </a:p>
@@ -5365,7 +4952,7 @@
           <a:p>
             <a:fld id="{163D97CC-475F-BE49-B579-6BFEF977A37E}" type="datetimeFigureOut">
               <a:rPr lang="en-US" smtClean="0"/>
-              <a:t>9/23/2026</a:t>
+              <a:t>9/3/2026</a:t>
             </a:fld>
             <a:endParaRPr lang="en-US"/>
           </a:p>
@@ -5460,7 +5047,7 @@
           <a:p>
             <a:fld id="{163D97CC-475F-BE49-B579-6BFEF977A37E}" type="datetimeFigureOut">
               <a:rPr lang="en-US" smtClean="0"/>
-              <a:t>9/23/2026</a:t>
+              <a:t>9/3/2026</a:t>
             </a:fld>
             <a:endParaRPr lang="en-US"/>
           </a:p>
@@ -5720,7 +5307,7 @@
           <a:p>
             <a:fld id="{163D97CC-475F-BE49-B579-6BFEF977A37E}" type="datetimeFigureOut">
               <a:rPr lang="en-US" smtClean="0"/>
-              <a:t>9/23/2026</a:t>
+              <a:t>9/3/2026</a:t>
             </a:fld>
             <a:endParaRPr lang="en-US"/>
           </a:p>
@@ -6025,7 +5612,7 @@
           <a:p>
             <a:fld id="{163D97CC-475F-BE49-B579-6BFEF977A37E}" type="datetimeFigureOut">
               <a:rPr lang="en-US" smtClean="0"/>
-              <a:t>9/23/2026</a:t>
+              <a:t>9/3/2026</a:t>
             </a:fld>
             <a:endParaRPr lang="en-US"/>
           </a:p>
@@ -6259,7 +5846,7 @@
           <a:p>
             <a:fld id="{163D97CC-475F-BE49-B579-6BFEF977A37E}" type="datetimeFigureOut">
               <a:rPr lang="en-US" smtClean="0"/>
-              <a:t>9/23/2026</a:t>
+              <a:t>9/3/2026</a:t>
             </a:fld>
             <a:endParaRPr lang="en-US"/>
           </a:p>
@@ -6926,7 +6513,13 @@
   <p:cSld>
     <p:spTree>
       <p:nvGrpSpPr>
-        <p:cNvPr id="1" name=""/>
+        <p:cNvPr id="1" name="">
+          <a:extLst>
+            <a:ext uri="{FF2B5EF4-FFF2-40B4-BE49-F238E27FC236}">
+              <a16:creationId xmlns:a16="http://schemas.microsoft.com/office/drawing/2014/main" id="{1268F610-5E25-C02F-4785-351AC651288F}"/>
+            </a:ext>
+          </a:extLst>
+        </p:cNvPr>
         <p:cNvGrpSpPr/>
         <p:nvPr/>
       </p:nvGrpSpPr>
@@ -6940,14 +6533,20 @@
       </p:grpSpPr>
       <p:sp>
         <p:nvSpPr>
-          <p:cNvPr id="4" name="TextBox 3"/>
+          <p:cNvPr id="4" name="TextBox 3">
+            <a:extLst>
+              <a:ext uri="{FF2B5EF4-FFF2-40B4-BE49-F238E27FC236}">
+                <a16:creationId xmlns:a16="http://schemas.microsoft.com/office/drawing/2014/main" id="{B3039183-8738-C635-5157-3D9EC402F895}"/>
+              </a:ext>
+            </a:extLst>
+          </p:cNvPr>
           <p:cNvSpPr txBox="1"/>
           <p:nvPr/>
         </p:nvSpPr>
         <p:spPr>
           <a:xfrm>
-            <a:off x="806973" y="504527"/>
-            <a:ext cx="42469186" cy="3157850"/>
+            <a:off x="685278" y="278782"/>
+            <a:ext cx="42721119" cy="3619515"/>
           </a:xfrm>
           <a:prstGeom prst="rect">
             <a:avLst/>
@@ -6980,38 +6579,87 @@
           </a:bodyPr>
           <a:lstStyle/>
           <a:p>
-            <a:pPr algn="ctr"/>
-            <a:r>
-              <a:rPr lang="en-US" sz="6000" dirty="0"/>
-              <a:t>Prevalence of High-Fructose Corn Syrup in the U.S. Branded Food Supply: A Cross-Sectional Analysis of the USDA Global Branded Food Products Database</a:t>
-            </a:r>
-            <a:endParaRPr lang="en-US" sz="6000" b="1" dirty="0">
-              <a:latin typeface="Times New Roman"/>
-              <a:cs typeface="Times New Roman"/>
-            </a:endParaRPr>
-          </a:p>
-          <a:p>
-            <a:pPr algn="ctr"/>
-            <a:r>
-              <a:rPr lang="en-US" sz="5800" b="1" dirty="0">
-                <a:latin typeface="Times New Roman"/>
-                <a:cs typeface="Times New Roman"/>
-              </a:rPr>
-              <a:t>Name of Student(s)</a:t>
+            <a:pPr algn="ctr">
+              <a:lnSpc>
+                <a:spcPct val="100000"/>
+              </a:lnSpc>
+            </a:pPr>
+            <a:r>
+              <a:rPr sz="5200" b="1" i="0">
+                <a:solidFill>
+                  <a:srgbClr val="000000"/>
+                </a:solidFill>
+                <a:latin typeface="Times New Roman"/>
+              </a:rPr>
+              <a:t>PREVALENCE OF HIGH-FRUCTOSE CORN SYRUP IN THE U.S. BRANDED FOOD SUPPLY:</a:t>
+            </a:r>
+          </a:p>
+          <a:p>
+            <a:pPr algn="ctr">
+              <a:lnSpc>
+                <a:spcPct val="100000"/>
+              </a:lnSpc>
+            </a:pPr>
+            <a:r>
+              <a:rPr sz="5200" b="1" i="0">
+                <a:solidFill>
+                  <a:srgbClr val="000000"/>
+                </a:solidFill>
+                <a:latin typeface="Times New Roman"/>
+              </a:rPr>
+              <a:t>A CROSS-SECTIONAL ANALYSIS OF THE USDA GLOBAL BRANDED FOOD PRODUCTS DATABASE</a:t>
+            </a:r>
+          </a:p>
+          <a:p>
+            <a:pPr algn="ctr">
+              <a:lnSpc>
+                <a:spcPct val="100000"/>
+              </a:lnSpc>
+            </a:pPr>
+            <a:r>
+              <a:rPr sz="4400" b="0" i="0">
+                <a:solidFill>
+                  <a:srgbClr val="000000"/>
+                </a:solidFill>
+                <a:latin typeface="Times New Roman"/>
+              </a:rPr>
+              <a:t>[Author Name, Credentials; Author Name, Credentials; Author Name, Credentials]</a:t>
+            </a:r>
+          </a:p>
+          <a:p>
+            <a:pPr algn="ctr">
+              <a:lnSpc>
+                <a:spcPct val="100000"/>
+              </a:lnSpc>
+            </a:pPr>
+            <a:r>
+              <a:rPr sz="3400" b="0" i="0">
+                <a:solidFill>
+                  <a:srgbClr val="000000"/>
+                </a:solidFill>
+                <a:latin typeface="Times New Roman"/>
+              </a:rPr>
+              <a:t>[Department], Liberty University</a:t>
             </a:r>
           </a:p>
         </p:txBody>
       </p:sp>
       <p:pic>
         <p:nvPicPr>
-          <p:cNvPr id="77" name="Picture 76"/>
+          <p:cNvPr id="77" name="Picture 76">
+            <a:extLst>
+              <a:ext uri="{FF2B5EF4-FFF2-40B4-BE49-F238E27FC236}">
+                <a16:creationId xmlns:a16="http://schemas.microsoft.com/office/drawing/2014/main" id="{8C9C05FA-58BE-53E6-927D-097819D54A23}"/>
+              </a:ext>
+            </a:extLst>
+          </p:cNvPr>
           <p:cNvPicPr>
             <a:picLocks noChangeAspect="1"/>
           </p:cNvPicPr>
           <p:nvPr/>
         </p:nvPicPr>
         <p:blipFill>
-          <a:blip r:embed="rId4">
+          <a:blip r:embed="rId3">
             <a:extLst>
               <a:ext uri="{28A0092B-C50C-407E-A947-70E740481C1C}">
                 <a14:useLocalDpi xmlns:a14="http://schemas.microsoft.com/office/drawing/2010/main" val="0"/>
@@ -7024,76 +6672,76 @@
         </p:blipFill>
         <p:spPr>
           <a:xfrm>
-            <a:off x="1590313" y="1913925"/>
-            <a:ext cx="4840224" cy="1377696"/>
+            <a:off x="1316561" y="949846"/>
+            <a:ext cx="4580142" cy="1486682"/>
           </a:xfrm>
           <a:prstGeom prst="rect">
             <a:avLst/>
           </a:prstGeom>
         </p:spPr>
       </p:pic>
-      <p:grpSp>
-        <p:nvGrpSpPr>
-          <p:cNvPr id="304" name="Group 303"/>
-          <p:cNvGrpSpPr/>
+      <p:sp>
+        <p:nvSpPr>
+          <p:cNvPr id="305" name="TextBox 304">
+            <a:extLst>
+              <a:ext uri="{FF2B5EF4-FFF2-40B4-BE49-F238E27FC236}">
+                <a16:creationId xmlns:a16="http://schemas.microsoft.com/office/drawing/2014/main" id="{A065416B-4327-02A8-9591-8B9DE4E9BA73}"/>
+              </a:ext>
+            </a:extLst>
+          </p:cNvPr>
+          <p:cNvSpPr txBox="1"/>
           <p:nvPr/>
-        </p:nvGrpSpPr>
-        <p:grpSpPr>
+        </p:nvSpPr>
+        <p:spPr>
           <a:xfrm>
-            <a:off x="10980125" y="3934552"/>
-            <a:ext cx="22440303" cy="28100713"/>
-            <a:chOff x="12513023" y="6861775"/>
-            <a:chExt cx="26180354" cy="25277327"/>
+            <a:off x="10871631" y="4220388"/>
+            <a:ext cx="22559807" cy="28137863"/>
           </a:xfrm>
-        </p:grpSpPr>
-        <p:sp>
-          <p:nvSpPr>
-            <p:cNvPr id="305" name="TextBox 304"/>
-            <p:cNvSpPr txBox="1"/>
-            <p:nvPr/>
-          </p:nvSpPr>
-          <p:spPr>
-            <a:xfrm>
-              <a:off x="12513023" y="6861775"/>
-              <a:ext cx="26180354" cy="25277327"/>
-            </a:xfrm>
-            <a:prstGeom prst="rect">
-              <a:avLst/>
-            </a:prstGeom>
+          <a:prstGeom prst="rect">
+            <a:avLst/>
+          </a:prstGeom>
+          <a:solidFill>
+            <a:srgbClr val="FFFFFF"/>
+          </a:solidFill>
+          <a:ln cap="rnd">
             <a:solidFill>
-              <a:srgbClr val="FFFFFF"/>
+              <a:schemeClr val="bg1"/>
             </a:solidFill>
-            <a:ln cap="rnd">
+          </a:ln>
+        </p:spPr>
+        <p:txBody>
+          <a:bodyPr wrap="square" lIns="182880" rIns="182880" rtlCol="0">
+            <a:noAutofit/>
+          </a:bodyPr>
+          <a:lstStyle/>
+          <a:p>
+            <a:pPr algn="just"/>
+            <a:endParaRPr lang="en-US" sz="1800" dirty="0">
               <a:solidFill>
                 <a:schemeClr val="bg1"/>
               </a:solidFill>
-            </a:ln>
-          </p:spPr>
-          <p:txBody>
-            <a:bodyPr wrap="square" lIns="182880" rIns="182880" rtlCol="0">
-              <a:noAutofit/>
-            </a:bodyPr>
-            <a:lstStyle/>
-            <a:p>
-              <a:pPr algn="just"/>
-              <a:endParaRPr lang="en-US" sz="1800" dirty="0">
-                <a:latin typeface="Times New Roman"/>
-                <a:cs typeface="Times New Roman"/>
-              </a:endParaRPr>
-            </a:p>
-          </p:txBody>
-        </p:sp>
-      </p:grpSp>
-      <p:sp>
-        <p:nvSpPr>
-          <p:cNvPr id="309" name="TextBox 308"/>
+              <a:latin typeface="Times New Roman"/>
+              <a:cs typeface="Times New Roman"/>
+            </a:endParaRPr>
+          </a:p>
+        </p:txBody>
+      </p:sp>
+      <p:sp>
+        <p:nvSpPr>
+          <p:cNvPr id="309" name="TextBox 308">
+            <a:extLst>
+              <a:ext uri="{FF2B5EF4-FFF2-40B4-BE49-F238E27FC236}">
+                <a16:creationId xmlns:a16="http://schemas.microsoft.com/office/drawing/2014/main" id="{E262B778-3A7B-F270-6B03-864EB2DE932B}"/>
+              </a:ext>
+            </a:extLst>
+          </p:cNvPr>
           <p:cNvSpPr txBox="1"/>
           <p:nvPr/>
         </p:nvSpPr>
         <p:spPr>
           <a:xfrm>
-            <a:off x="795528" y="4846320"/>
-            <a:ext cx="9308592" cy="7223760"/>
+            <a:off x="685800" y="4956048"/>
+            <a:ext cx="9427464" cy="7772400"/>
           </a:xfrm>
           <a:prstGeom prst="rect">
             <a:avLst/>
@@ -7108,140 +6756,205 @@
           </a:ln>
         </p:spPr>
         <p:txBody>
-          <a:bodyPr wrap="square" lIns="182880" tIns="91440" rIns="182880" bIns="91440" rtlCol="0">
+          <a:bodyPr wrap="square" lIns="131445" tIns="65723" rIns="131445" bIns="65723" rtlCol="0" anchor="t">
             <a:noAutofit/>
           </a:bodyPr>
           <a:lstStyle/>
           <a:p>
-            <a:r>
-              <a:rPr lang="en-US" sz="2000" b="1" dirty="0">
-                <a:solidFill>
-                  <a:schemeClr val="bg1"/>
-                </a:solidFill>
-                <a:latin typeface="Arial"/>
+            <a:pPr marL="0" indent="0" algn="just">
+              <a:lnSpc>
+                <a:spcPct val="100000"/>
+              </a:lnSpc>
+              <a:spcAft>
+                <a:spcPts val="300"/>
+              </a:spcAft>
+            </a:pPr>
+            <a:r>
+              <a:rPr sz="2100" b="1" i="0">
+                <a:solidFill>
+                  <a:srgbClr val="000000"/>
+                </a:solidFill>
+                <a:latin typeface="Times New Roman"/>
               </a:rPr>
               <a:t>Background:</a:t>
             </a:r>
             <a:r>
-              <a:rPr lang="en-US" sz="2000" dirty="0">
-                <a:solidFill>
-                  <a:schemeClr val="bg1"/>
-                </a:solidFill>
-                <a:latin typeface="Arial"/>
+              <a:rPr sz="2100" b="0" i="0">
+                <a:solidFill>
+                  <a:srgbClr val="000000"/>
+                </a:solidFill>
+                <a:latin typeface="Times New Roman"/>
               </a:rPr>
               <a:t> High-fructose corn syrup (HFCS) is a widely used caloric sweetener in the U.S. food supply, but product-level data on its prevalence are limited. Ingredient lists do not specify amounts, and nutrient databases do not distinguish among types of added sugars.</a:t>
             </a:r>
           </a:p>
           <a:p>
-            <a:r>
-              <a:rPr lang="en-US" sz="2000" b="1" dirty="0">
-                <a:solidFill>
-                  <a:schemeClr val="bg1"/>
-                </a:solidFill>
-                <a:latin typeface="Arial"/>
+            <a:pPr marL="0" indent="0" algn="just">
+              <a:lnSpc>
+                <a:spcPct val="100000"/>
+              </a:lnSpc>
+              <a:spcAft>
+                <a:spcPts val="300"/>
+              </a:spcAft>
+            </a:pPr>
+            <a:r>
+              <a:rPr sz="2100" b="1" i="0">
+                <a:solidFill>
+                  <a:srgbClr val="000000"/>
+                </a:solidFill>
+                <a:latin typeface="Times New Roman"/>
               </a:rPr>
               <a:t>Objectives:</a:t>
             </a:r>
             <a:r>
-              <a:rPr lang="en-US" sz="2000" dirty="0">
-                <a:solidFill>
-                  <a:schemeClr val="bg1"/>
-                </a:solidFill>
-                <a:latin typeface="Arial"/>
+              <a:rPr sz="2100" b="0" i="0">
+                <a:solidFill>
+                  <a:srgbClr val="000000"/>
+                </a:solidFill>
+                <a:latin typeface="Times New Roman"/>
               </a:rPr>
               <a:t> To estimate the prevalence of HFCS as a listed ingredient in U.S. branded food products and to establish a reproducible baseline for future surveillance.</a:t>
             </a:r>
           </a:p>
           <a:p>
-            <a:r>
-              <a:rPr lang="en-US" sz="2000" b="1" dirty="0">
-                <a:solidFill>
-                  <a:schemeClr val="bg1"/>
-                </a:solidFill>
-                <a:latin typeface="Arial"/>
+            <a:pPr marL="0" indent="0" algn="just">
+              <a:lnSpc>
+                <a:spcPct val="100000"/>
+              </a:lnSpc>
+              <a:spcAft>
+                <a:spcPts val="300"/>
+              </a:spcAft>
+            </a:pPr>
+            <a:r>
+              <a:rPr sz="2100" b="1" i="0">
+                <a:solidFill>
+                  <a:srgbClr val="000000"/>
+                </a:solidFill>
+                <a:latin typeface="Times New Roman"/>
               </a:rPr>
               <a:t>Methods:</a:t>
             </a:r>
             <a:r>
-              <a:rPr lang="en-US" sz="2000" dirty="0">
-                <a:solidFill>
-                  <a:schemeClr val="bg1"/>
-                </a:solidFill>
-                <a:latin typeface="Arial"/>
-              </a:rPr>
-              <a:t> We conducted a retrospective, cross-sectional, descriptive analysis of the USDA </a:t>
-            </a:r>
-            <a:r>
-              <a:rPr lang="en-US" sz="2000" dirty="0" err="1">
-                <a:solidFill>
-                  <a:schemeClr val="bg1"/>
-                </a:solidFill>
-                <a:latin typeface="Arial"/>
-              </a:rPr>
-              <a:t>FoodData</a:t>
-            </a:r>
-            <a:r>
-              <a:rPr lang="en-US" sz="2000" dirty="0">
-                <a:solidFill>
-                  <a:schemeClr val="bg1"/>
-                </a:solidFill>
-                <a:latin typeface="Arial"/>
-              </a:rPr>
-              <a:t> Central Global Branded Food Products Database (GBFPD), covering products published between April 13, 2019, and December 13, 2025. The primary outcome was the proportion of eligible products listing HFCS as an ingredient. We used descriptive statistics (counts and percentages).</a:t>
-            </a:r>
-          </a:p>
-          <a:p>
-            <a:r>
-              <a:rPr lang="en-US" sz="2000" b="1" dirty="0">
-                <a:solidFill>
-                  <a:schemeClr val="bg1"/>
-                </a:solidFill>
-                <a:latin typeface="Arial"/>
+              <a:rPr sz="2100" b="0" i="0">
+                <a:solidFill>
+                  <a:srgbClr val="000000"/>
+                </a:solidFill>
+                <a:latin typeface="Times New Roman"/>
+              </a:rPr>
+              <a:t> We conducted a retrospective, cross-sectional, descriptive analysis of the USDA FoodData Central Global Branded Food Products Database (GBFPD), covering products published between April 13, 2019, and December 13, 2025. The primary outcome was the proportion of eligible products listing HFCS as an ingredient. We used descriptive statistics (counts and percentages).</a:t>
+            </a:r>
+          </a:p>
+          <a:p>
+            <a:pPr marL="0" indent="0" algn="just">
+              <a:lnSpc>
+                <a:spcPct val="100000"/>
+              </a:lnSpc>
+              <a:spcAft>
+                <a:spcPts val="300"/>
+              </a:spcAft>
+            </a:pPr>
+            <a:r>
+              <a:rPr sz="2100" b="1" i="0">
+                <a:solidFill>
+                  <a:srgbClr val="000000"/>
+                </a:solidFill>
+                <a:latin typeface="Times New Roman"/>
               </a:rPr>
               <a:t>Results:</a:t>
             </a:r>
             <a:r>
-              <a:rPr lang="en-US" sz="2000" dirty="0">
-                <a:solidFill>
-                  <a:schemeClr val="bg1"/>
-                </a:solidFill>
-                <a:latin typeface="Arial"/>
+              <a:rPr sz="2100" b="0" i="0">
+                <a:solidFill>
+                  <a:srgbClr val="000000"/>
+                </a:solidFill>
+                <a:latin typeface="Times New Roman"/>
               </a:rPr>
               <a:t> Of 454,324 products identified, 447,607 were eligible for analysis. HFCS was listed as an ingredient in 29,503 products (6.6%), or about 1 in 15. The remaining 418,104 products (93.4%) did not list HFCS.</a:t>
             </a:r>
           </a:p>
           <a:p>
-            <a:r>
-              <a:rPr lang="en-US" sz="2000" b="1" dirty="0">
-                <a:solidFill>
-                  <a:schemeClr val="bg1"/>
-                </a:solidFill>
-                <a:latin typeface="Arial"/>
+            <a:pPr marL="0" indent="0" algn="just">
+              <a:lnSpc>
+                <a:spcPct val="100000"/>
+              </a:lnSpc>
+              <a:spcAft>
+                <a:spcPts val="300"/>
+              </a:spcAft>
+            </a:pPr>
+            <a:r>
+              <a:rPr sz="2100" b="1" i="0">
+                <a:solidFill>
+                  <a:srgbClr val="000000"/>
+                </a:solidFill>
+                <a:latin typeface="Times New Roman"/>
               </a:rPr>
               <a:t>Conclusions:</a:t>
             </a:r>
             <a:r>
-              <a:rPr lang="en-US" sz="2000" dirty="0">
-                <a:solidFill>
-                  <a:schemeClr val="bg1"/>
-                </a:solidFill>
-                <a:latin typeface="Arial"/>
+              <a:rPr sz="2100" b="0" i="0">
+                <a:solidFill>
+                  <a:srgbClr val="000000"/>
+                </a:solidFill>
+                <a:latin typeface="Times New Roman"/>
               </a:rPr>
               <a:t> HFCS remains present in roughly 30,000 U.S. branded food products. Because we measured prevalence by product count rather than weighted by sales or intake, and could not quantify HFCS per product, these findings do not directly measure population exposure. They provide a reproducible baseline for monitoring reformulation and market change. Future work should link ingredient data to sales-weighted datasets and stratify by food category and trade channel.</a:t>
             </a:r>
           </a:p>
-        </p:txBody>
-      </p:sp>
-      <p:sp>
-        <p:nvSpPr>
-          <p:cNvPr id="310" name="TextBox 309"/>
+          <a:p>
+            <a:pPr marL="0" indent="0" algn="just">
+              <a:lnSpc>
+                <a:spcPct val="100000"/>
+              </a:lnSpc>
+              <a:spcAft>
+                <a:spcPts val="300"/>
+              </a:spcAft>
+            </a:pPr>
+            <a:r>
+              <a:rPr sz="2100" b="1" i="0">
+                <a:solidFill>
+                  <a:srgbClr val="000000"/>
+                </a:solidFill>
+                <a:latin typeface="Times New Roman"/>
+              </a:rPr>
+              <a:t>Keywords:</a:t>
+            </a:r>
+            <a:r>
+              <a:rPr sz="2100" b="0" i="0">
+                <a:solidFill>
+                  <a:srgbClr val="000000"/>
+                </a:solidFill>
+                <a:latin typeface="Times New Roman"/>
+              </a:rPr>
+              <a:t> </a:t>
+            </a:r>
+            <a:r>
+              <a:rPr sz="2100" b="0" i="1">
+                <a:solidFill>
+                  <a:srgbClr val="000000"/>
+                </a:solidFill>
+                <a:latin typeface="Times New Roman"/>
+              </a:rPr>
+              <a:t>high-fructose corn syrup; added sugars; branded foods; FoodData Central; food supply surveillance</a:t>
+            </a:r>
+          </a:p>
+        </p:txBody>
+      </p:sp>
+      <p:sp>
+        <p:nvSpPr>
+          <p:cNvPr id="310" name="TextBox 309">
+            <a:extLst>
+              <a:ext uri="{FF2B5EF4-FFF2-40B4-BE49-F238E27FC236}">
+                <a16:creationId xmlns:a16="http://schemas.microsoft.com/office/drawing/2014/main" id="{1747F5FB-C0E0-9E78-F84B-1D512F83536E}"/>
+              </a:ext>
+            </a:extLst>
+          </p:cNvPr>
           <p:cNvSpPr txBox="1"/>
           <p:nvPr/>
         </p:nvSpPr>
         <p:spPr>
           <a:xfrm>
-            <a:off x="795528" y="3931920"/>
-            <a:ext cx="9308592" cy="914400"/>
+            <a:off x="685800" y="4087368"/>
+            <a:ext cx="9427464" cy="868680"/>
           </a:xfrm>
           <a:prstGeom prst="rect">
             <a:avLst/>
@@ -7256,20 +6969,20 @@
           </a:ln>
         </p:spPr>
         <p:txBody>
-          <a:bodyPr wrap="square" lIns="131445" tIns="65723" rIns="131445" bIns="65723" rtlCol="0" anchor="ctr">
-            <a:noAutofit/>
+          <a:bodyPr wrap="square" lIns="131445" tIns="65723" rIns="131445" bIns="65723" rtlCol="0">
+            <a:spAutoFit/>
           </a:bodyPr>
           <a:lstStyle/>
           <a:p>
             <a:pPr algn="ctr"/>
             <a:r>
-              <a:rPr lang="en-US" sz="4400" dirty="0">
+              <a:rPr lang="en-US" sz="4800" dirty="0">
                 <a:latin typeface="Times New Roman"/>
                 <a:cs typeface="Times New Roman"/>
               </a:rPr>
               <a:t>Abstract</a:t>
             </a:r>
-            <a:endParaRPr lang="en-US" sz="4400" dirty="0">
+            <a:endParaRPr lang="en-US" sz="6000" dirty="0">
               <a:latin typeface="Times New Roman"/>
               <a:cs typeface="Times New Roman"/>
             </a:endParaRPr>
@@ -7278,14 +6991,20 @@
       </p:sp>
       <p:sp>
         <p:nvSpPr>
-          <p:cNvPr id="312" name="TextBox 311"/>
+          <p:cNvPr id="312" name="TextBox 311">
+            <a:extLst>
+              <a:ext uri="{FF2B5EF4-FFF2-40B4-BE49-F238E27FC236}">
+                <a16:creationId xmlns:a16="http://schemas.microsoft.com/office/drawing/2014/main" id="{746F674E-FB28-8348-72E3-A91916401D8C}"/>
+              </a:ext>
+            </a:extLst>
+          </p:cNvPr>
           <p:cNvSpPr txBox="1"/>
           <p:nvPr/>
         </p:nvSpPr>
         <p:spPr>
           <a:xfrm>
-            <a:off x="795528" y="13304520"/>
-            <a:ext cx="9308592" cy="9784080"/>
+            <a:off x="685800" y="14374368"/>
+            <a:ext cx="9427464" cy="7360920"/>
           </a:xfrm>
           <a:prstGeom prst="rect">
             <a:avLst/>
@@ -7300,171 +7019,250 @@
           </a:ln>
         </p:spPr>
         <p:txBody>
-          <a:bodyPr wrap="square" lIns="182880" tIns="91440" rIns="182880" bIns="91440" rtlCol="0">
+          <a:bodyPr wrap="square" lIns="131445" tIns="65723" rIns="131445" bIns="65723" rtlCol="0" anchor="t">
             <a:noAutofit/>
           </a:bodyPr>
           <a:lstStyle/>
           <a:p>
-            <a:pPr marL="342900" indent="-342900">
-              <a:spcBef>
-                <a:spcPts val="0"/>
-              </a:spcBef>
-              <a:buFont typeface="Arial"/>
-              <a:buChar char="•"/>
+            <a:pPr algn="just" marL="0" indent="0">
+              <a:lnSpc>
+                <a:spcPct val="100000"/>
+              </a:lnSpc>
+              <a:spcAft>
+                <a:spcPts val="300"/>
+              </a:spcAft>
             </a:pPr>
             <a:r>
-              <a:rPr lang="en-US" sz="2800" dirty="0">
-                <a:solidFill>
-                  <a:schemeClr val="bg1"/>
-                </a:solidFill>
-                <a:latin typeface="Arial"/>
-                <a:cs typeface="Arial"/>
-              </a:rPr>
-              <a:t>HFCS is a widely used caloric sweetener, especially in soft drinks, baked goods, ready-to-eat meals, and condiments.</a:t>
-            </a:r>
-          </a:p>
-          <a:p>
-            <a:pPr marL="342900" indent="-342900">
-              <a:spcBef>
-                <a:spcPts val="600"/>
-              </a:spcBef>
-              <a:buFont typeface="Arial"/>
-              <a:buChar char="•"/>
+              <a:rPr sz="2400" b="1" i="0">
+                <a:solidFill>
+                  <a:srgbClr val="000000"/>
+                </a:solidFill>
+                <a:latin typeface="Times New Roman"/>
+              </a:rPr>
+              <a:t>Introduction</a:t>
+            </a:r>
+          </a:p>
+          <a:p>
+            <a:pPr marL="0" indent="0" algn="just">
+              <a:lnSpc>
+                <a:spcPct val="100000"/>
+              </a:lnSpc>
+              <a:spcAft>
+                <a:spcPts val="300"/>
+              </a:spcAft>
             </a:pPr>
             <a:r>
-              <a:rPr lang="en-US" sz="2800" dirty="0">
-                <a:solidFill>
-                  <a:schemeClr val="bg1"/>
-                </a:solidFill>
-                <a:latin typeface="Arial"/>
-                <a:cs typeface="Arial"/>
-              </a:rPr>
-              <a:t>Excess added sugar is linked to obesity, type 2 diabetes, and cardiometabolic disease. The 2025–2030 Dietary Guidelines state that no amount of added sugars is recommended as part of a healthy diet.</a:t>
-            </a:r>
-          </a:p>
-          <a:p>
-            <a:pPr marL="342900" indent="-342900">
-              <a:spcBef>
-                <a:spcPts val="600"/>
-              </a:spcBef>
-              <a:buFont typeface="Arial"/>
-              <a:buChar char="•"/>
+              <a:rPr sz="2400" b="0" i="0">
+                <a:solidFill>
+                  <a:srgbClr val="000000"/>
+                </a:solidFill>
+                <a:latin typeface="Times New Roman"/>
+              </a:rPr>
+              <a:t>High-fructose corn syrup (HFCS) is a caloric sweetener made by enzymatically converting cornstarch into free fructose and glucose, used widely in soft drinks, baked goods, ready-to-eat meals, and condiments.</a:t>
+            </a:r>
+            <a:r>
+              <a:rPr sz="2400" b="0" i="0" baseline="30000">
+                <a:solidFill>
+                  <a:srgbClr val="000000"/>
+                </a:solidFill>
+                <a:latin typeface="Times New Roman"/>
+              </a:rPr>
+              <a:t>1,2</a:t>
+            </a:r>
+            <a:r>
+              <a:rPr sz="2400" b="0" i="0">
+                <a:solidFill>
+                  <a:srgbClr val="000000"/>
+                </a:solidFill>
+                <a:latin typeface="Times New Roman"/>
+              </a:rPr>
+              <a:t> Common blends are HFCS-55, mainly in soft drinks, and HFCS-42, mainly in processed foods.</a:t>
+            </a:r>
+            <a:r>
+              <a:rPr sz="2400" b="0" i="0" baseline="30000">
+                <a:solidFill>
+                  <a:srgbClr val="000000"/>
+                </a:solidFill>
+                <a:latin typeface="Times New Roman"/>
+              </a:rPr>
+              <a:t>3</a:t>
+            </a:r>
+            <a:r>
+              <a:rPr sz="2400" b="0" i="0">
+                <a:solidFill>
+                  <a:srgbClr val="000000"/>
+                </a:solidFill>
+                <a:latin typeface="Times New Roman"/>
+              </a:rPr>
+              <a:t> Low cost linked to domestic corn production drove its adoption in the U.S. food supply.</a:t>
+            </a:r>
+            <a:r>
+              <a:rPr sz="2400" b="0" i="0" baseline="30000">
+                <a:solidFill>
+                  <a:srgbClr val="000000"/>
+                </a:solidFill>
+                <a:latin typeface="Times New Roman"/>
+              </a:rPr>
+              <a:t>4</a:t>
+            </a:r>
+            <a:r>
+              <a:rPr sz="2400" b="0" i="0">
+                <a:solidFill>
+                  <a:srgbClr val="000000"/>
+                </a:solidFill>
+                <a:latin typeface="Times New Roman"/>
+              </a:rPr>
+              <a:t> HFCS-sweetened beverages increase liver fat and reduce insulin sensitivity,</a:t>
+            </a:r>
+            <a:r>
+              <a:rPr sz="2400" b="0" i="0" baseline="30000">
+                <a:solidFill>
+                  <a:srgbClr val="000000"/>
+                </a:solidFill>
+                <a:latin typeface="Times New Roman"/>
+              </a:rPr>
+              <a:t>5</a:t>
+            </a:r>
+            <a:r>
+              <a:rPr sz="2400" b="0" i="0">
+                <a:solidFill>
+                  <a:srgbClr val="000000"/>
+                </a:solidFill>
+                <a:latin typeface="Times New Roman"/>
+              </a:rPr>
+              <a:t> and excess free fructose may affect gut and metabolic health.</a:t>
+            </a:r>
+            <a:r>
+              <a:rPr sz="2400" b="0" i="0" baseline="30000">
+                <a:solidFill>
+                  <a:srgbClr val="000000"/>
+                </a:solidFill>
+                <a:latin typeface="Times New Roman"/>
+              </a:rPr>
+              <a:t>6</a:t>
+            </a:r>
+            <a:r>
+              <a:rPr sz="2400" b="0" i="0">
+                <a:solidFill>
+                  <a:srgbClr val="000000"/>
+                </a:solidFill>
+                <a:latin typeface="Times New Roman"/>
+              </a:rPr>
+              <a:t> The 2025–2030 Dietary Guidelines state that no amount of added sugars is recommended as part of a healthy diet.</a:t>
+            </a:r>
+            <a:r>
+              <a:rPr sz="2400" b="0" i="0" baseline="30000">
+                <a:solidFill>
+                  <a:srgbClr val="000000"/>
+                </a:solidFill>
+                <a:latin typeface="Times New Roman"/>
+              </a:rPr>
+              <a:t>7</a:t>
+            </a:r>
+            <a:r>
+              <a:rPr sz="2400" b="0" i="0">
+                <a:solidFill>
+                  <a:srgbClr val="000000"/>
+                </a:solidFill>
+                <a:latin typeface="Times New Roman"/>
+              </a:rPr>
+              <a:t> Yet ingredient lists do not give HFCS amounts, and nutrient databases do not separate types of added sugar, so product-level HFCS data are limited.</a:t>
+            </a:r>
+          </a:p>
+          <a:p>
+            <a:pPr marL="0" indent="0" algn="just">
+              <a:lnSpc>
+                <a:spcPct val="100000"/>
+              </a:lnSpc>
+              <a:spcAft>
+                <a:spcPts val="300"/>
+              </a:spcAft>
             </a:pPr>
             <a:r>
-              <a:rPr lang="en-US" sz="2800" dirty="0">
-                <a:solidFill>
-                  <a:schemeClr val="bg1"/>
-                </a:solidFill>
-                <a:latin typeface="Arial"/>
-                <a:cs typeface="Arial"/>
-              </a:rPr>
-              <a:t>Product-level HFCS data are limited: ingredient lists give no amounts, and nutrient databases do not separate types of added sugars.</a:t>
-            </a:r>
-          </a:p>
-          <a:p>
-            <a:pPr>
-              <a:spcBef>
-                <a:spcPts val="1000"/>
-              </a:spcBef>
-              <a:buNone/>
+              <a:rPr sz="2400" b="1" i="0">
+                <a:solidFill>
+                  <a:srgbClr val="000000"/>
+                </a:solidFill>
+                <a:latin typeface="Times New Roman"/>
+              </a:rPr>
+              <a:t>Objective</a:t>
+            </a:r>
+          </a:p>
+          <a:p>
+            <a:pPr marL="0" indent="0" algn="just">
+              <a:lnSpc>
+                <a:spcPct val="100000"/>
+              </a:lnSpc>
+              <a:spcAft>
+                <a:spcPts val="300"/>
+              </a:spcAft>
             </a:pPr>
             <a:r>
-              <a:rPr lang="en-US" sz="2800" dirty="0" b="1">
-                <a:solidFill>
-                  <a:schemeClr val="bg1"/>
-                </a:solidFill>
-                <a:latin typeface="Arial"/>
-                <a:cs typeface="Arial"/>
-              </a:rPr>
-              <a:t>Research question</a:t>
-            </a:r>
-          </a:p>
-          <a:p>
-            <a:pPr>
-              <a:spcBef>
-                <a:spcPts val="600"/>
-              </a:spcBef>
-              <a:buNone/>
+              <a:rPr sz="2400" b="0" i="0">
+                <a:solidFill>
+                  <a:srgbClr val="000000"/>
+                </a:solidFill>
+                <a:latin typeface="Times New Roman"/>
+              </a:rPr>
+              <a:t>To estimate the prevalence of HFCS as a listed ingredient in U.S. branded food products and establish a reproducible baseline for future surveillance.</a:t>
+            </a:r>
+          </a:p>
+          <a:p>
+            <a:pPr marL="0" indent="0" algn="just">
+              <a:lnSpc>
+                <a:spcPct val="100000"/>
+              </a:lnSpc>
+              <a:spcAft>
+                <a:spcPts val="300"/>
+              </a:spcAft>
             </a:pPr>
             <a:r>
-              <a:rPr lang="en-US" sz="2800" dirty="0">
-                <a:solidFill>
-                  <a:schemeClr val="bg1"/>
-                </a:solidFill>
-                <a:latin typeface="Arial"/>
-                <a:cs typeface="Arial"/>
+              <a:rPr sz="2400" b="1" i="0">
+                <a:solidFill>
+                  <a:srgbClr val="000000"/>
+                </a:solidFill>
+                <a:latin typeface="Times New Roman"/>
+              </a:rPr>
+              <a:t>Research Question</a:t>
+            </a:r>
+          </a:p>
+          <a:p>
+            <a:pPr marL="0" indent="0" algn="just">
+              <a:lnSpc>
+                <a:spcPct val="100000"/>
+              </a:lnSpc>
+              <a:spcAft>
+                <a:spcPts val="300"/>
+              </a:spcAft>
+            </a:pPr>
+            <a:r>
+              <a:rPr sz="2400" b="0" i="0">
+                <a:solidFill>
+                  <a:srgbClr val="000000"/>
+                </a:solidFill>
+                <a:latin typeface="Times New Roman"/>
               </a:rPr>
               <a:t>What proportion of U.S. branded food products list HFCS as an ingredient?</a:t>
             </a:r>
           </a:p>
-          <a:p>
-            <a:pPr>
-              <a:spcBef>
-                <a:spcPts val="1000"/>
-              </a:spcBef>
-              <a:buNone/>
-            </a:pPr>
-            <a:r>
-              <a:rPr lang="en-US" sz="2800" dirty="0" b="1">
-                <a:solidFill>
-                  <a:schemeClr val="bg1"/>
-                </a:solidFill>
-                <a:latin typeface="Arial"/>
-                <a:cs typeface="Arial"/>
-              </a:rPr>
-              <a:t>Objectives</a:t>
-            </a:r>
-          </a:p>
-          <a:p>
-            <a:pPr marL="342900" indent="-342900">
-              <a:spcBef>
-                <a:spcPts val="600"/>
-              </a:spcBef>
-              <a:buFont typeface="Arial"/>
-              <a:buChar char="•"/>
-            </a:pPr>
-            <a:r>
-              <a:rPr lang="en-US" sz="2800" dirty="0">
-                <a:solidFill>
-                  <a:schemeClr val="bg1"/>
-                </a:solidFill>
-                <a:latin typeface="Arial"/>
-                <a:cs typeface="Arial"/>
-              </a:rPr>
-              <a:t>Estimate HFCS prevalence in U.S. branded food products</a:t>
-            </a:r>
-          </a:p>
-          <a:p>
-            <a:pPr marL="342900" indent="-342900">
-              <a:spcBef>
-                <a:spcPts val="600"/>
-              </a:spcBef>
-              <a:buFont typeface="Arial"/>
-              <a:buChar char="•"/>
-            </a:pPr>
-            <a:r>
-              <a:rPr lang="en-US" sz="2800" dirty="0">
-                <a:solidFill>
-                  <a:schemeClr val="bg1"/>
-                </a:solidFill>
-                <a:latin typeface="Arial"/>
-                <a:cs typeface="Arial"/>
-              </a:rPr>
-              <a:t>Establish a reproducible baseline for future surveillance</a:t>
-            </a:r>
-          </a:p>
-        </p:txBody>
-      </p:sp>
-      <p:sp>
-        <p:nvSpPr>
-          <p:cNvPr id="313" name="TextBox 312"/>
+        </p:txBody>
+      </p:sp>
+      <p:sp>
+        <p:nvSpPr>
+          <p:cNvPr id="313" name="TextBox 312">
+            <a:extLst>
+              <a:ext uri="{FF2B5EF4-FFF2-40B4-BE49-F238E27FC236}">
+                <a16:creationId xmlns:a16="http://schemas.microsoft.com/office/drawing/2014/main" id="{6DDFC9D8-2135-B804-986E-91DCE8E7F20A}"/>
+              </a:ext>
+            </a:extLst>
+          </p:cNvPr>
           <p:cNvSpPr txBox="1"/>
           <p:nvPr/>
         </p:nvSpPr>
         <p:spPr>
           <a:xfrm>
-            <a:off x="795528" y="12390120"/>
-            <a:ext cx="9308592" cy="914400"/>
+            <a:off x="685800" y="13002768"/>
+            <a:ext cx="9427464" cy="1371600"/>
           </a:xfrm>
           <a:prstGeom prst="rect">
             <a:avLst/>
@@ -7486,13 +7284,13 @@
           <a:p>
             <a:pPr algn="ctr"/>
             <a:r>
-              <a:rPr lang="en-US" sz="4400" dirty="0">
+              <a:rPr lang="en-US" sz="4800" dirty="0">
                 <a:latin typeface="Times New Roman"/>
                 <a:cs typeface="Times New Roman"/>
               </a:rPr>
-              <a:t>Introduction</a:t>
-            </a:r>
-            <a:endParaRPr lang="en-US" sz="4400" dirty="0">
+              <a:t>Introduction, Objective, and Research Question</a:t>
+            </a:r>
+            <a:endParaRPr lang="en-US" sz="6000" dirty="0">
               <a:latin typeface="Times New Roman"/>
               <a:cs typeface="Times New Roman"/>
             </a:endParaRPr>
@@ -7501,247 +7299,20 @@
       </p:sp>
       <p:sp>
         <p:nvSpPr>
-          <p:cNvPr id="315" name="TextBox 314"/>
+          <p:cNvPr id="316" name="TextBox 315">
+            <a:extLst>
+              <a:ext uri="{FF2B5EF4-FFF2-40B4-BE49-F238E27FC236}">
+                <a16:creationId xmlns:a16="http://schemas.microsoft.com/office/drawing/2014/main" id="{BC19B682-B6AF-9A71-5C4D-B2D1BE476405}"/>
+              </a:ext>
+            </a:extLst>
+          </p:cNvPr>
           <p:cNvSpPr txBox="1"/>
           <p:nvPr/>
         </p:nvSpPr>
         <p:spPr>
           <a:xfrm>
-            <a:off x="795528" y="24323040"/>
-            <a:ext cx="9308592" cy="7708392"/>
-          </a:xfrm>
-          <a:prstGeom prst="rect">
-            <a:avLst/>
-          </a:prstGeom>
-          <a:solidFill>
-            <a:schemeClr val="tx1"/>
-          </a:solidFill>
-          <a:ln cap="rnd">
-            <a:solidFill>
-              <a:schemeClr val="bg1"/>
-            </a:solidFill>
-          </a:ln>
-        </p:spPr>
-        <p:txBody>
-          <a:bodyPr wrap="square" lIns="182880" rIns="182880" rtlCol="0" tIns="91440" bIns="91440">
-            <a:noAutofit/>
-          </a:bodyPr>
-          <a:lstStyle/>
-          <a:p>
-            <a:pPr marL="342900" indent="-342900">
-              <a:spcBef>
-                <a:spcPts val="0"/>
-              </a:spcBef>
-              <a:buFont typeface="Arial"/>
-              <a:buChar char="•"/>
-            </a:pPr>
-            <a:r>
-              <a:rPr lang="en-US" sz="2800" dirty="0" b="1">
-                <a:solidFill>
-                  <a:schemeClr val="bg1"/>
-                </a:solidFill>
-                <a:latin typeface="Arial"/>
-                <a:cs typeface="Arial"/>
-              </a:rPr>
-              <a:t>Design:</a:t>
-            </a:r>
-            <a:r>
-              <a:rPr lang="en-US" sz="2800" dirty="0">
-                <a:solidFill>
-                  <a:schemeClr val="bg1"/>
-                </a:solidFill>
-                <a:latin typeface="Arial"/>
-                <a:cs typeface="Arial"/>
-              </a:rPr>
-              <a:t> retrospective, cross-sectional, descriptive</a:t>
-            </a:r>
-          </a:p>
-          <a:p>
-            <a:pPr marL="342900" indent="-342900">
-              <a:spcBef>
-                <a:spcPts val="600"/>
-              </a:spcBef>
-              <a:buFont typeface="Arial"/>
-              <a:buChar char="•"/>
-            </a:pPr>
-            <a:r>
-              <a:rPr lang="en-US" sz="2800" dirty="0" b="1">
-                <a:solidFill>
-                  <a:schemeClr val="bg1"/>
-                </a:solidFill>
-                <a:latin typeface="Arial"/>
-                <a:cs typeface="Arial"/>
-              </a:rPr>
-              <a:t>Data:</a:t>
-            </a:r>
-            <a:r>
-              <a:rPr lang="en-US" sz="2800" dirty="0">
-                <a:solidFill>
-                  <a:schemeClr val="bg1"/>
-                </a:solidFill>
-                <a:latin typeface="Arial"/>
-                <a:cs typeface="Arial"/>
-              </a:rPr>
-              <a:t> USDA FoodData Central Global Branded Food Products Database (GBFPD); 400,000+ industry-supplied products, updated monthly</a:t>
-            </a:r>
-          </a:p>
-          <a:p>
-            <a:pPr marL="342900" indent="-342900">
-              <a:spcBef>
-                <a:spcPts val="600"/>
-              </a:spcBef>
-              <a:buFont typeface="Arial"/>
-              <a:buChar char="•"/>
-            </a:pPr>
-            <a:r>
-              <a:rPr lang="en-US" sz="2800" dirty="0" b="1">
-                <a:solidFill>
-                  <a:schemeClr val="bg1"/>
-                </a:solidFill>
-                <a:latin typeface="Arial"/>
-                <a:cs typeface="Arial"/>
-              </a:rPr>
-              <a:t>Search window:</a:t>
-            </a:r>
-            <a:r>
-              <a:rPr lang="en-US" sz="2800" dirty="0">
-                <a:solidFill>
-                  <a:schemeClr val="bg1"/>
-                </a:solidFill>
-                <a:latin typeface="Arial"/>
-                <a:cs typeface="Arial"/>
-              </a:rPr>
-              <a:t> April 13, 2019 – December 13, 2025 (FDC published date)</a:t>
-            </a:r>
-          </a:p>
-          <a:p>
-            <a:pPr marL="342900" indent="-342900">
-              <a:spcBef>
-                <a:spcPts val="600"/>
-              </a:spcBef>
-              <a:buFont typeface="Arial"/>
-              <a:buChar char="•"/>
-            </a:pPr>
-            <a:r>
-              <a:rPr lang="en-US" sz="2800" dirty="0" b="1">
-                <a:solidFill>
-                  <a:schemeClr val="bg1"/>
-                </a:solidFill>
-                <a:latin typeface="Arial"/>
-                <a:cs typeface="Arial"/>
-              </a:rPr>
-              <a:t>Trade channels:</a:t>
-            </a:r>
-            <a:r>
-              <a:rPr lang="en-US" sz="2800" dirty="0">
-                <a:solidFill>
-                  <a:schemeClr val="bg1"/>
-                </a:solidFill>
-                <a:latin typeface="Arial"/>
-                <a:cs typeface="Arial"/>
-              </a:rPr>
-              <a:t> grocery, convenience, mass merchandising, food service, vending, online, military, child nutrition programs, none</a:t>
-            </a:r>
-          </a:p>
-          <a:p>
-            <a:pPr marL="342900" indent="-342900">
-              <a:spcBef>
-                <a:spcPts val="600"/>
-              </a:spcBef>
-              <a:buFont typeface="Arial"/>
-              <a:buChar char="•"/>
-            </a:pPr>
-            <a:r>
-              <a:rPr lang="en-US" sz="2800" dirty="0" b="1">
-                <a:solidFill>
-                  <a:schemeClr val="bg1"/>
-                </a:solidFill>
-                <a:latin typeface="Arial"/>
-                <a:cs typeface="Arial"/>
-              </a:rPr>
-              <a:t>Excluded:</a:t>
-            </a:r>
-            <a:r>
-              <a:rPr lang="en-US" sz="2800" dirty="0">
-                <a:solidFill>
-                  <a:schemeClr val="bg1"/>
-                </a:solidFill>
-                <a:latin typeface="Arial"/>
-                <a:cs typeface="Arial"/>
-              </a:rPr>
-              <a:t> “Drug” category and New Zealand market (n = 6,717)</a:t>
-            </a:r>
-          </a:p>
-          <a:p>
-            <a:pPr marL="342900" indent="-342900">
-              <a:spcBef>
-                <a:spcPts val="600"/>
-              </a:spcBef>
-              <a:buFont typeface="Arial"/>
-              <a:buChar char="•"/>
-            </a:pPr>
-            <a:r>
-              <a:rPr lang="en-US" sz="2800" dirty="0" b="1">
-                <a:solidFill>
-                  <a:schemeClr val="bg1"/>
-                </a:solidFill>
-                <a:latin typeface="Arial"/>
-                <a:cs typeface="Arial"/>
-              </a:rPr>
-              <a:t>HFCS search:</a:t>
-            </a:r>
-            <a:r>
-              <a:rPr lang="en-US" sz="2800" dirty="0">
-                <a:solidFill>
-                  <a:schemeClr val="bg1"/>
-                </a:solidFill>
-                <a:latin typeface="Arial"/>
-                <a:cs typeface="Arial"/>
-              </a:rPr>
-              <a:t> ingredients containing “High” AND “Fructose” AND “Corn” AND “Syrup”</a:t>
-            </a:r>
-          </a:p>
-          <a:p>
-            <a:pPr marL="342900" indent="-342900">
-              <a:spcBef>
-                <a:spcPts val="600"/>
-              </a:spcBef>
-              <a:buFont typeface="Arial"/>
-              <a:buChar char="•"/>
-            </a:pPr>
-            <a:r>
-              <a:rPr lang="en-US" sz="2800" dirty="0" b="1">
-                <a:solidFill>
-                  <a:schemeClr val="bg1"/>
-                </a:solidFill>
-                <a:latin typeface="Arial"/>
-                <a:cs typeface="Arial"/>
-              </a:rPr>
-              <a:t>Analysis:</a:t>
-            </a:r>
-            <a:r>
-              <a:rPr lang="en-US" sz="2800" dirty="0">
-                <a:solidFill>
-                  <a:schemeClr val="bg1"/>
-                </a:solidFill>
-                <a:latin typeface="Arial"/>
-                <a:cs typeface="Arial"/>
-              </a:rPr>
-              <a:t> % of eligible products listing HFCS (Excel)</a:t>
-            </a:r>
-          </a:p>
-        </p:txBody>
-      </p:sp>
-      <p:sp>
-        <p:nvSpPr>
-          <p:cNvPr id="316" name="TextBox 315"/>
-          <p:cNvSpPr txBox="1"/>
-          <p:nvPr/>
-        </p:nvSpPr>
-        <p:spPr>
-          <a:xfrm>
-            <a:off x="795528" y="23408640"/>
-            <a:ext cx="9308592" cy="914400"/>
+            <a:off x="685800" y="22009608"/>
+            <a:ext cx="9427464" cy="868680"/>
           </a:xfrm>
           <a:prstGeom prst="rect">
             <a:avLst/>
@@ -7763,13 +7334,13 @@
           <a:p>
             <a:pPr algn="ctr"/>
             <a:r>
-              <a:rPr lang="en-US" sz="4400" dirty="0">
+              <a:rPr lang="en-US" sz="4800" dirty="0">
                 <a:latin typeface="Times New Roman"/>
                 <a:cs typeface="Times New Roman"/>
               </a:rPr>
               <a:t>Methods</a:t>
             </a:r>
-            <a:endParaRPr lang="en-US" sz="4400" dirty="0">
+            <a:endParaRPr lang="en-US" sz="6000" dirty="0">
               <a:latin typeface="Times New Roman"/>
               <a:cs typeface="Times New Roman"/>
             </a:endParaRPr>
@@ -7778,14 +7349,20 @@
       </p:sp>
       <p:sp>
         <p:nvSpPr>
-          <p:cNvPr id="321" name="TextBox 320"/>
+          <p:cNvPr id="321" name="TextBox 320">
+            <a:extLst>
+              <a:ext uri="{FF2B5EF4-FFF2-40B4-BE49-F238E27FC236}">
+                <a16:creationId xmlns:a16="http://schemas.microsoft.com/office/drawing/2014/main" id="{CB19DFF1-BA24-B68B-4652-0F80775C03FA}"/>
+              </a:ext>
+            </a:extLst>
+          </p:cNvPr>
           <p:cNvSpPr txBox="1"/>
           <p:nvPr/>
         </p:nvSpPr>
         <p:spPr>
           <a:xfrm>
-            <a:off x="34033968" y="22174200"/>
-            <a:ext cx="9326880" cy="9857231"/>
+            <a:off x="34006536" y="21369528"/>
+            <a:ext cx="9253728" cy="5669280"/>
           </a:xfrm>
           <a:prstGeom prst="rect">
             <a:avLst/>
@@ -7800,138 +7377,207 @@
           </a:ln>
         </p:spPr>
         <p:txBody>
-          <a:bodyPr wrap="square" lIns="182880" rIns="182880" rtlCol="0" tIns="91440" bIns="91440">
+          <a:bodyPr wrap="square" lIns="182880" rIns="182880" rtlCol="0" anchor="t">
             <a:noAutofit/>
           </a:bodyPr>
           <a:lstStyle/>
           <a:p>
-            <a:pPr marL="548640" indent="-548640">
-              <a:spcBef>
-                <a:spcPts val="0"/>
-              </a:spcBef>
-              <a:buFont typeface="Arial"/>
-              <a:buAutoNum type="arabicPeriod"/>
+            <a:pPr marL="0" indent="0" algn="just">
+              <a:lnSpc>
+                <a:spcPct val="100000"/>
+              </a:lnSpc>
+              <a:spcAft>
+                <a:spcPts val="300"/>
+              </a:spcAft>
             </a:pPr>
             <a:r>
-              <a:rPr lang="en-US" sz="3600" dirty="0" b="1">
-                <a:solidFill>
-                  <a:schemeClr val="bg1"/>
-                </a:solidFill>
-                <a:latin typeface="Arial"/>
-                <a:cs typeface="Arial"/>
-              </a:rPr>
-              <a:t>Estimate consumer exposure.</a:t>
-            </a:r>
-            <a:r>
-              <a:rPr lang="en-US" sz="3600" dirty="0">
-                <a:solidFill>
-                  <a:schemeClr val="bg1"/>
-                </a:solidFill>
-                <a:latin typeface="Arial"/>
-                <a:cs typeface="Arial"/>
-              </a:rPr>
-              <a:t> Link ingredient data to sales-weighted or scanner data, so prevalence reflects what people buy.</a:t>
-            </a:r>
-          </a:p>
-          <a:p>
-            <a:pPr marL="548640" indent="-548640">
-              <a:spcBef>
-                <a:spcPts val="600"/>
-              </a:spcBef>
-              <a:buFont typeface="Arial"/>
-              <a:buAutoNum type="arabicPeriod"/>
+              <a:rPr sz="2500" b="1" i="0">
+                <a:solidFill>
+                  <a:srgbClr val="000000"/>
+                </a:solidFill>
+                <a:latin typeface="Times New Roman"/>
+              </a:rPr>
+              <a:t>Public Health Implications</a:t>
+            </a:r>
+          </a:p>
+          <a:p>
+            <a:pPr algn="l" marL="274320" indent="-274320">
+              <a:lnSpc>
+                <a:spcPct val="100000"/>
+              </a:lnSpc>
+              <a:spcAft>
+                <a:spcPts val="300"/>
+              </a:spcAft>
             </a:pPr>
             <a:r>
-              <a:rPr lang="en-US" sz="3600" dirty="0" b="1">
-                <a:solidFill>
-                  <a:schemeClr val="bg1"/>
-                </a:solidFill>
-                <a:latin typeface="Arial"/>
-                <a:cs typeface="Arial"/>
-              </a:rPr>
-              <a:t>Find where HFCS is concentrated.</a:t>
-            </a:r>
-            <a:r>
-              <a:rPr lang="en-US" sz="3600" dirty="0">
-                <a:solidFill>
-                  <a:schemeClr val="bg1"/>
-                </a:solidFill>
-                <a:latin typeface="Arial"/>
-                <a:cs typeface="Arial"/>
-              </a:rPr>
-              <a:t> Break down prevalence by food category and trade channel.</a:t>
-            </a:r>
-          </a:p>
-          <a:p>
-            <a:pPr marL="548640" indent="-548640">
-              <a:spcBef>
-                <a:spcPts val="600"/>
-              </a:spcBef>
-              <a:buFont typeface="Arial"/>
-              <a:buAutoNum type="arabicPeriod"/>
+              <a:rPr sz="2500" b="0" i="0">
+                <a:solidFill>
+                  <a:srgbClr val="000000"/>
+                </a:solidFill>
+                <a:latin typeface="Times New Roman"/>
+              </a:rPr>
+              <a:t>• Use ingredient-level surveillance to track HFCS and added sugars in branded foods</a:t>
+            </a:r>
+          </a:p>
+          <a:p>
+            <a:pPr algn="l" marL="274320" indent="-274320">
+              <a:lnSpc>
+                <a:spcPct val="100000"/>
+              </a:lnSpc>
+              <a:spcAft>
+                <a:spcPts val="300"/>
+              </a:spcAft>
             </a:pPr>
             <a:r>
-              <a:rPr lang="en-US" sz="3600" dirty="0" b="1">
-                <a:solidFill>
-                  <a:schemeClr val="bg1"/>
-                </a:solidFill>
-                <a:latin typeface="Arial"/>
-                <a:cs typeface="Arial"/>
-              </a:rPr>
-              <a:t>Strengthen monitoring.</a:t>
-            </a:r>
-            <a:r>
-              <a:rPr lang="en-US" sz="3600" dirty="0">
-                <a:solidFill>
-                  <a:schemeClr val="bg1"/>
-                </a:solidFill>
-                <a:latin typeface="Arial"/>
-                <a:cs typeface="Arial"/>
-              </a:rPr>
-              <a:t> Combine ingredient data with Nutrition Facts added-sugar labeling.</a:t>
-            </a:r>
-          </a:p>
-          <a:p>
-            <a:pPr marL="548640" indent="-548640">
-              <a:spcBef>
-                <a:spcPts val="600"/>
-              </a:spcBef>
-              <a:buFont typeface="Arial"/>
-              <a:buAutoNum type="arabicPeriod"/>
+              <a:rPr sz="2500" b="0" i="0">
+                <a:solidFill>
+                  <a:srgbClr val="000000"/>
+                </a:solidFill>
+                <a:latin typeface="Times New Roman"/>
+              </a:rPr>
+              <a:t>• Target reformulation where HFCS is concentrated</a:t>
+            </a:r>
+          </a:p>
+          <a:p>
+            <a:pPr algn="l" marL="274320" indent="-274320">
+              <a:lnSpc>
+                <a:spcPct val="100000"/>
+              </a:lnSpc>
+              <a:spcAft>
+                <a:spcPts val="300"/>
+              </a:spcAft>
             </a:pPr>
             <a:r>
-              <a:rPr lang="en-US" sz="3600" dirty="0" b="1">
-                <a:solidFill>
-                  <a:schemeClr val="bg1"/>
-                </a:solidFill>
-                <a:latin typeface="Arial"/>
-                <a:cs typeface="Arial"/>
-              </a:rPr>
-              <a:t>Track change over time.</a:t>
-            </a:r>
-            <a:r>
-              <a:rPr lang="en-US" sz="3600" dirty="0">
-                <a:solidFill>
-                  <a:schemeClr val="bg1"/>
-                </a:solidFill>
-                <a:latin typeface="Arial"/>
-                <a:cs typeface="Arial"/>
-              </a:rPr>
-              <a:t> Repeat the analysis to detect reformulation and market shifts.</a:t>
-            </a:r>
-          </a:p>
-        </p:txBody>
-      </p:sp>
-      <p:sp>
-        <p:nvSpPr>
-          <p:cNvPr id="322" name="TextBox 321"/>
+              <a:rPr sz="2500" b="0" i="0">
+                <a:solidFill>
+                  <a:srgbClr val="000000"/>
+                </a:solidFill>
+                <a:latin typeface="Times New Roman"/>
+              </a:rPr>
+              <a:t>• Align monitoring with the 2025–2030 Dietary Guidelines</a:t>
+            </a:r>
+            <a:r>
+              <a:rPr sz="2500" b="0" i="0" baseline="30000">
+                <a:solidFill>
+                  <a:srgbClr val="000000"/>
+                </a:solidFill>
+                <a:latin typeface="Times New Roman"/>
+              </a:rPr>
+              <a:t>7</a:t>
+            </a:r>
+            <a:r>
+              <a:rPr sz="2500" b="0" i="0">
+                <a:solidFill>
+                  <a:srgbClr val="000000"/>
+                </a:solidFill>
+                <a:latin typeface="Times New Roman"/>
+              </a:rPr>
+              <a:t> and added-sugar labeling</a:t>
+            </a:r>
+            <a:r>
+              <a:rPr sz="2500" b="0" i="0" baseline="30000">
+                <a:solidFill>
+                  <a:srgbClr val="000000"/>
+                </a:solidFill>
+                <a:latin typeface="Times New Roman"/>
+              </a:rPr>
+              <a:t>14</a:t>
+            </a:r>
+          </a:p>
+          <a:p>
+            <a:pPr marL="0" indent="0" algn="just">
+              <a:lnSpc>
+                <a:spcPct val="100000"/>
+              </a:lnSpc>
+              <a:spcAft>
+                <a:spcPts val="300"/>
+              </a:spcAft>
+            </a:pPr>
+            <a:r>
+              <a:rPr sz="2500" b="1" i="0">
+                <a:solidFill>
+                  <a:srgbClr val="000000"/>
+                </a:solidFill>
+                <a:latin typeface="Times New Roman"/>
+              </a:rPr>
+              <a:t>Future Work</a:t>
+            </a:r>
+          </a:p>
+          <a:p>
+            <a:pPr algn="l" marL="274320" indent="-274320">
+              <a:lnSpc>
+                <a:spcPct val="100000"/>
+              </a:lnSpc>
+              <a:spcAft>
+                <a:spcPts val="300"/>
+              </a:spcAft>
+            </a:pPr>
+            <a:r>
+              <a:rPr sz="2500" b="0" i="0">
+                <a:solidFill>
+                  <a:srgbClr val="000000"/>
+                </a:solidFill>
+                <a:latin typeface="Times New Roman"/>
+              </a:rPr>
+              <a:t>• Link ingredient data to sales-weighted or scanner data to estimate exposure</a:t>
+            </a:r>
+          </a:p>
+          <a:p>
+            <a:pPr algn="l" marL="274320" indent="-274320">
+              <a:lnSpc>
+                <a:spcPct val="100000"/>
+              </a:lnSpc>
+              <a:spcAft>
+                <a:spcPts val="300"/>
+              </a:spcAft>
+            </a:pPr>
+            <a:r>
+              <a:rPr sz="2500" b="0" i="0">
+                <a:solidFill>
+                  <a:srgbClr val="000000"/>
+                </a:solidFill>
+                <a:latin typeface="Times New Roman"/>
+              </a:rPr>
+              <a:t>• Stratify prevalence by food category and trade channel</a:t>
+            </a:r>
+          </a:p>
+          <a:p>
+            <a:pPr algn="l" marL="274320" indent="-274320">
+              <a:lnSpc>
+                <a:spcPct val="100000"/>
+              </a:lnSpc>
+              <a:spcAft>
+                <a:spcPts val="300"/>
+              </a:spcAft>
+            </a:pPr>
+            <a:r>
+              <a:rPr sz="2500" b="0" i="0">
+                <a:solidFill>
+                  <a:srgbClr val="000000"/>
+                </a:solidFill>
+                <a:latin typeface="Times New Roman"/>
+              </a:rPr>
+              <a:t>• Repeat over time and validate a random sample of records</a:t>
+            </a:r>
+          </a:p>
+        </p:txBody>
+      </p:sp>
+      <p:sp>
+        <p:nvSpPr>
+          <p:cNvPr id="322" name="TextBox 321">
+            <a:extLst>
+              <a:ext uri="{FF2B5EF4-FFF2-40B4-BE49-F238E27FC236}">
+                <a16:creationId xmlns:a16="http://schemas.microsoft.com/office/drawing/2014/main" id="{FF9BD680-0755-89B6-9224-48721A47729A}"/>
+              </a:ext>
+            </a:extLst>
+          </p:cNvPr>
           <p:cNvSpPr txBox="1"/>
           <p:nvPr/>
         </p:nvSpPr>
         <p:spPr>
           <a:xfrm>
-            <a:off x="34033968" y="21259800"/>
-            <a:ext cx="9326880" cy="914400"/>
+            <a:off x="34006536" y="19997928"/>
+            <a:ext cx="9253728" cy="1371600"/>
           </a:xfrm>
           <a:prstGeom prst="rect">
             <a:avLst/>
@@ -7953,13 +7599,13 @@
           <a:p>
             <a:pPr algn="ctr"/>
             <a:r>
-              <a:rPr lang="en-US" sz="4400" dirty="0">
-                <a:latin typeface="Garamond"/>
+              <a:rPr lang="en-US" sz="4800" dirty="0">
+                <a:latin typeface="Times New Roman"/>
                 <a:cs typeface="Garamond"/>
               </a:rPr>
-              <a:t>Future Work</a:t>
-            </a:r>
-            <a:endParaRPr lang="en-US" sz="4400" dirty="0">
+              <a:t>Public Health Implications and Future Work</a:t>
+            </a:r>
+            <a:endParaRPr lang="en-US" sz="6000" dirty="0">
               <a:latin typeface="Garamond"/>
               <a:cs typeface="Garamond"/>
             </a:endParaRPr>
@@ -7968,14 +7614,20 @@
       </p:sp>
       <p:sp>
         <p:nvSpPr>
-          <p:cNvPr id="326" name="TextBox 325"/>
+          <p:cNvPr id="323" name="TextBox 322">
+            <a:extLst>
+              <a:ext uri="{FF2B5EF4-FFF2-40B4-BE49-F238E27FC236}">
+                <a16:creationId xmlns:a16="http://schemas.microsoft.com/office/drawing/2014/main" id="{791F62C8-B471-7647-1C58-7FE1BB1C1D01}"/>
+              </a:ext>
+            </a:extLst>
+          </p:cNvPr>
           <p:cNvSpPr txBox="1"/>
           <p:nvPr/>
         </p:nvSpPr>
         <p:spPr>
           <a:xfrm>
-            <a:off x="34033968" y="3931920"/>
-            <a:ext cx="9326880" cy="914400"/>
+            <a:off x="34006536" y="27313128"/>
+            <a:ext cx="9253728" cy="868680"/>
           </a:xfrm>
           <a:prstGeom prst="rect">
             <a:avLst/>
@@ -7997,13 +7649,13 @@
           <a:p>
             <a:pPr algn="ctr"/>
             <a:r>
-              <a:rPr lang="en-US" sz="4400" dirty="0">
+              <a:rPr lang="en-US" sz="4800" dirty="0">
                 <a:latin typeface="Times New Roman"/>
                 <a:cs typeface="Times New Roman"/>
               </a:rPr>
-              <a:t>Results &amp; Conclusions</a:t>
-            </a:r>
-            <a:endParaRPr lang="en-US" sz="4400" dirty="0">
+              <a:t>References</a:t>
+            </a:r>
+            <a:endParaRPr lang="en-US" sz="6000" dirty="0">
               <a:latin typeface="Times New Roman"/>
               <a:cs typeface="Times New Roman"/>
             </a:endParaRPr>
@@ -8012,20 +7664,437 @@
       </p:sp>
       <p:sp>
         <p:nvSpPr>
-          <p:cNvPr id="327" name="Rectangle 326"/>
-          <p:cNvSpPr/>
+          <p:cNvPr id="325" name="TextBox 324">
+            <a:extLst>
+              <a:ext uri="{FF2B5EF4-FFF2-40B4-BE49-F238E27FC236}">
+                <a16:creationId xmlns:a16="http://schemas.microsoft.com/office/drawing/2014/main" id="{C035F57E-62DB-372A-C78A-9EAA827DE73E}"/>
+              </a:ext>
+            </a:extLst>
+          </p:cNvPr>
+          <p:cNvSpPr txBox="1"/>
           <p:nvPr/>
         </p:nvSpPr>
         <p:spPr>
           <a:xfrm>
-            <a:off x="34033968" y="4846320"/>
-            <a:ext cx="9326880" cy="16093440"/>
+            <a:off x="34006536" y="5458968"/>
+            <a:ext cx="9253728" cy="14264640"/>
           </a:xfrm>
           <a:prstGeom prst="rect">
             <a:avLst/>
           </a:prstGeom>
           <a:solidFill>
-            <a:schemeClr val="tx1"/>
+            <a:srgbClr val="FFFFFF"/>
+          </a:solidFill>
+          <a:ln cap="rnd">
+            <a:solidFill>
+              <a:schemeClr val="bg1"/>
+            </a:solidFill>
+          </a:ln>
+        </p:spPr>
+        <p:txBody>
+          <a:bodyPr wrap="square" lIns="182880" rIns="182880" rtlCol="0" anchor="t">
+            <a:noAutofit/>
+          </a:bodyPr>
+          <a:lstStyle/>
+          <a:p>
+            <a:pPr algn="just" marL="0" indent="0">
+              <a:lnSpc>
+                <a:spcPct val="100000"/>
+              </a:lnSpc>
+              <a:spcAft>
+                <a:spcPts val="300"/>
+              </a:spcAft>
+            </a:pPr>
+            <a:r>
+              <a:rPr sz="2600" b="1" i="0">
+                <a:solidFill>
+                  <a:srgbClr val="000000"/>
+                </a:solidFill>
+                <a:latin typeface="Times New Roman"/>
+              </a:rPr>
+              <a:t>Results</a:t>
+            </a:r>
+            <a:endParaRPr lang="en-US" sz="1800" dirty="0">
+              <a:latin typeface="Garamond"/>
+              <a:cs typeface="Garamond"/>
+            </a:endParaRPr>
+          </a:p>
+          <a:p>
+            <a:pPr marL="0" indent="0" algn="just">
+              <a:lnSpc>
+                <a:spcPct val="100000"/>
+              </a:lnSpc>
+              <a:spcAft>
+                <a:spcPts val="300"/>
+              </a:spcAft>
+            </a:pPr>
+            <a:r>
+              <a:rPr sz="2600" b="0" i="0">
+                <a:solidFill>
+                  <a:srgbClr val="000000"/>
+                </a:solidFill>
+                <a:latin typeface="Times New Roman"/>
+              </a:rPr>
+              <a:t>Of 454,324 products identified, 6,717 were excluded, leaving 447,607 eligible U.S. branded products (Figure 1). HFCS was listed in </a:t>
+            </a:r>
+            <a:r>
+              <a:rPr sz="2600" b="1" i="0">
+                <a:solidFill>
+                  <a:srgbClr val="000000"/>
+                </a:solidFill>
+                <a:latin typeface="Times New Roman"/>
+              </a:rPr>
+              <a:t>29,503 products (6.6%)</a:t>
+            </a:r>
+            <a:r>
+              <a:rPr sz="2600" b="0" i="0">
+                <a:solidFill>
+                  <a:srgbClr val="000000"/>
+                </a:solidFill>
+                <a:latin typeface="Times New Roman"/>
+              </a:rPr>
+              <a:t>, about 1 in every 15; 418,104 (93.4%) did not list HFCS (Figure 2).</a:t>
+            </a:r>
+          </a:p>
+          <a:p>
+            <a:pPr marL="0" indent="0" algn="just">
+              <a:lnSpc>
+                <a:spcPct val="100000"/>
+              </a:lnSpc>
+              <a:spcAft>
+                <a:spcPts val="300"/>
+              </a:spcAft>
+            </a:pPr>
+            <a:r>
+              <a:rPr sz="2600" b="1" i="0">
+                <a:solidFill>
+                  <a:srgbClr val="000000"/>
+                </a:solidFill>
+                <a:latin typeface="Times New Roman"/>
+              </a:rPr>
+              <a:t>Discussion</a:t>
+            </a:r>
+          </a:p>
+          <a:p>
+            <a:pPr marL="0" indent="0" algn="just">
+              <a:lnSpc>
+                <a:spcPct val="100000"/>
+              </a:lnSpc>
+              <a:spcAft>
+                <a:spcPts val="300"/>
+              </a:spcAft>
+            </a:pPr>
+            <a:r>
+              <a:rPr sz="2600" b="0" i="0">
+                <a:solidFill>
+                  <a:srgbClr val="000000"/>
+                </a:solidFill>
+                <a:latin typeface="Times New Roman"/>
+              </a:rPr>
+              <a:t>HFCS appeared in a minority of products, yet its presence in nearly 30,000 items shows it remains embedded in the U.S. food supply. A 6.6% product share is not low exposure: counts are not sales-weighted, and HFCS may cluster in high-consumption foods such as sweetened beverages, desserts, and condiments (Figure 3). HFCS availability peaked in 1999 and has declined since.</a:t>
+            </a:r>
+            <a:r>
+              <a:rPr sz="2600" b="0" i="0" baseline="30000">
+                <a:solidFill>
+                  <a:srgbClr val="000000"/>
+                </a:solidFill>
+                <a:latin typeface="Times New Roman"/>
+              </a:rPr>
+              <a:t>10</a:t>
+            </a:r>
+            <a:r>
+              <a:rPr sz="2600" b="0" i="0">
+                <a:solidFill>
+                  <a:srgbClr val="000000"/>
+                </a:solidFill>
+                <a:latin typeface="Times New Roman"/>
+              </a:rPr>
+              <a:t> Ultra-processed foods supply most added sugar in the U.S. diet,</a:t>
+            </a:r>
+            <a:r>
+              <a:rPr sz="2600" b="0" i="0" baseline="30000">
+                <a:solidFill>
+                  <a:srgbClr val="000000"/>
+                </a:solidFill>
+                <a:latin typeface="Times New Roman"/>
+              </a:rPr>
+              <a:t>11</a:t>
+            </a:r>
+            <a:r>
+              <a:rPr sz="2600" b="0" i="0">
+                <a:solidFill>
+                  <a:srgbClr val="000000"/>
+                </a:solidFill>
+                <a:latin typeface="Times New Roman"/>
+              </a:rPr>
+              <a:t> and sugar-sweetened beverages are linked to weight gain in children and adults.</a:t>
+            </a:r>
+            <a:r>
+              <a:rPr sz="2600" b="0" i="0" baseline="30000">
+                <a:solidFill>
+                  <a:srgbClr val="000000"/>
+                </a:solidFill>
+                <a:latin typeface="Times New Roman"/>
+              </a:rPr>
+              <a:t>12</a:t>
+            </a:r>
+            <a:r>
+              <a:rPr sz="2600" b="0" i="0">
+                <a:solidFill>
+                  <a:srgbClr val="000000"/>
+                </a:solidFill>
+                <a:latin typeface="Times New Roman"/>
+              </a:rPr>
+              <a:t> HFCS and sucrose have similar metabolic effects at equal intake,</a:t>
+            </a:r>
+            <a:r>
+              <a:rPr sz="2600" b="0" i="0" baseline="30000">
+                <a:solidFill>
+                  <a:srgbClr val="000000"/>
+                </a:solidFill>
+                <a:latin typeface="Times New Roman"/>
+              </a:rPr>
+              <a:t>13</a:t>
+            </a:r>
+            <a:r>
+              <a:rPr sz="2600" b="0" i="0">
+                <a:solidFill>
+                  <a:srgbClr val="000000"/>
+                </a:solidFill>
+                <a:latin typeface="Times New Roman"/>
+              </a:rPr>
+              <a:t> so total added sugar is the core concern.</a:t>
+            </a:r>
+          </a:p>
+          <a:p>
+            <a:pPr marL="0" indent="0" algn="just">
+              <a:lnSpc>
+                <a:spcPct val="100000"/>
+              </a:lnSpc>
+              <a:spcAft>
+                <a:spcPts val="300"/>
+              </a:spcAft>
+            </a:pPr>
+            <a:r>
+              <a:rPr sz="2600" b="1" i="0">
+                <a:solidFill>
+                  <a:srgbClr val="000000"/>
+                </a:solidFill>
+                <a:latin typeface="Times New Roman"/>
+              </a:rPr>
+              <a:t>Conclusion</a:t>
+            </a:r>
+          </a:p>
+          <a:p>
+            <a:pPr marL="0" indent="0" algn="just">
+              <a:lnSpc>
+                <a:spcPct val="100000"/>
+              </a:lnSpc>
+              <a:spcAft>
+                <a:spcPts val="300"/>
+              </a:spcAft>
+            </a:pPr>
+            <a:r>
+              <a:rPr sz="2600" b="0" i="0">
+                <a:solidFill>
+                  <a:srgbClr val="000000"/>
+                </a:solidFill>
+                <a:latin typeface="Times New Roman"/>
+              </a:rPr>
+              <a:t>HFCS is listed in 6.6% of U.S. branded food products, nearly 30,000 items. This reproducible baseline supports surveillance of HFCS and added sugars, evaluation of reformulation, and policy efforts to reduce added sugar.</a:t>
+            </a:r>
+          </a:p>
+          <a:p>
+            <a:pPr marL="0" indent="0" algn="just">
+              <a:lnSpc>
+                <a:spcPct val="100000"/>
+              </a:lnSpc>
+              <a:spcAft>
+                <a:spcPts val="300"/>
+              </a:spcAft>
+            </a:pPr>
+            <a:r>
+              <a:rPr sz="2600" b="1" i="0">
+                <a:solidFill>
+                  <a:srgbClr val="000000"/>
+                </a:solidFill>
+                <a:latin typeface="Times New Roman"/>
+              </a:rPr>
+              <a:t>Limitations</a:t>
+            </a:r>
+          </a:p>
+          <a:p>
+            <a:pPr algn="l" marL="274320" indent="-274320">
+              <a:lnSpc>
+                <a:spcPct val="100000"/>
+              </a:lnSpc>
+              <a:spcAft>
+                <a:spcPts val="300"/>
+              </a:spcAft>
+            </a:pPr>
+            <a:r>
+              <a:rPr sz="2600" b="0" i="0">
+                <a:solidFill>
+                  <a:srgbClr val="000000"/>
+                </a:solidFill>
+                <a:latin typeface="Times New Roman"/>
+              </a:rPr>
+              <a:t>• </a:t>
+            </a:r>
+            <a:r>
+              <a:rPr sz="2600" b="1" i="0">
+                <a:solidFill>
+                  <a:srgbClr val="000000"/>
+                </a:solidFill>
+                <a:latin typeface="Times New Roman"/>
+              </a:rPr>
+              <a:t>Presence only:</a:t>
+            </a:r>
+            <a:r>
+              <a:rPr sz="2600" b="0" i="0">
+                <a:solidFill>
+                  <a:srgbClr val="000000"/>
+                </a:solidFill>
+                <a:latin typeface="Times New Roman"/>
+              </a:rPr>
+              <a:t> no amount per product or intake; counts are not sales-weighted</a:t>
+            </a:r>
+          </a:p>
+          <a:p>
+            <a:pPr algn="l" marL="274320" indent="-274320">
+              <a:lnSpc>
+                <a:spcPct val="100000"/>
+              </a:lnSpc>
+              <a:spcAft>
+                <a:spcPts val="300"/>
+              </a:spcAft>
+            </a:pPr>
+            <a:r>
+              <a:rPr sz="2600" b="0" i="0">
+                <a:solidFill>
+                  <a:srgbClr val="000000"/>
+                </a:solidFill>
+                <a:latin typeface="Times New Roman"/>
+              </a:rPr>
+              <a:t>• </a:t>
+            </a:r>
+            <a:r>
+              <a:rPr sz="2600" b="1" i="0">
+                <a:solidFill>
+                  <a:srgbClr val="000000"/>
+                </a:solidFill>
+                <a:latin typeface="Times New Roman"/>
+              </a:rPr>
+              <a:t>Industry-supplied data:</a:t>
+            </a:r>
+            <a:r>
+              <a:rPr sz="2600" b="0" i="0">
+                <a:solidFill>
+                  <a:srgbClr val="000000"/>
+                </a:solidFill>
+                <a:latin typeface="Times New Roman"/>
+              </a:rPr>
+              <a:t> quality and completeness vary by contributor</a:t>
+            </a:r>
+          </a:p>
+          <a:p>
+            <a:pPr algn="l" marL="274320" indent="-274320">
+              <a:lnSpc>
+                <a:spcPct val="100000"/>
+              </a:lnSpc>
+              <a:spcAft>
+                <a:spcPts val="300"/>
+              </a:spcAft>
+            </a:pPr>
+            <a:r>
+              <a:rPr sz="2600" b="0" i="0">
+                <a:solidFill>
+                  <a:srgbClr val="000000"/>
+                </a:solidFill>
+                <a:latin typeface="Times New Roman"/>
+              </a:rPr>
+              <a:t>• </a:t>
+            </a:r>
+            <a:r>
+              <a:rPr sz="2600" b="1" i="0">
+                <a:solidFill>
+                  <a:srgbClr val="000000"/>
+                </a:solidFill>
+                <a:latin typeface="Times New Roman"/>
+              </a:rPr>
+              <a:t>Search terms:</a:t>
+            </a:r>
+            <a:r>
+              <a:rPr sz="2600" b="0" i="0">
+                <a:solidFill>
+                  <a:srgbClr val="000000"/>
+                </a:solidFill>
+                <a:latin typeface="Times New Roman"/>
+              </a:rPr>
+              <a:t> words need not be adjacent (possible over-count); other names such as “glucose-fructose syrup” are missed (possible under-count)</a:t>
+            </a:r>
+          </a:p>
+          <a:p>
+            <a:pPr algn="l" marL="274320" indent="-274320">
+              <a:lnSpc>
+                <a:spcPct val="100000"/>
+              </a:lnSpc>
+              <a:spcAft>
+                <a:spcPts val="300"/>
+              </a:spcAft>
+            </a:pPr>
+            <a:r>
+              <a:rPr sz="2600" b="0" i="0">
+                <a:solidFill>
+                  <a:srgbClr val="000000"/>
+                </a:solidFill>
+                <a:latin typeface="Times New Roman"/>
+              </a:rPr>
+              <a:t>• </a:t>
+            </a:r>
+            <a:r>
+              <a:rPr sz="2600" b="1" i="0">
+                <a:solidFill>
+                  <a:srgbClr val="000000"/>
+                </a:solidFill>
+                <a:latin typeface="Times New Roman"/>
+              </a:rPr>
+              <a:t>Item-level records:</a:t>
+            </a:r>
+            <a:r>
+              <a:rPr sz="2600" b="0" i="0">
+                <a:solidFill>
+                  <a:srgbClr val="000000"/>
+                </a:solidFill>
+                <a:latin typeface="Times New Roman"/>
+              </a:rPr>
+              <a:t> package sizes counted separately; some products may be discontinued</a:t>
+            </a:r>
+          </a:p>
+        </p:txBody>
+      </p:sp>
+      <p:sp>
+        <p:nvSpPr>
+          <p:cNvPr id="326" name="TextBox 325">
+            <a:extLst>
+              <a:ext uri="{FF2B5EF4-FFF2-40B4-BE49-F238E27FC236}">
+                <a16:creationId xmlns:a16="http://schemas.microsoft.com/office/drawing/2014/main" id="{2270543F-2128-4E8D-CCFD-F12E4C7A64FC}"/>
+              </a:ext>
+            </a:extLst>
+          </p:cNvPr>
+          <p:cNvSpPr txBox="1"/>
+          <p:nvPr/>
+        </p:nvSpPr>
+        <p:spPr>
+          <a:xfrm>
+            <a:off x="34006536" y="4087368"/>
+            <a:ext cx="9253728" cy="1371600"/>
+          </a:xfrm>
+          <a:prstGeom prst="rect">
+            <a:avLst/>
+          </a:prstGeom>
+          <a:solidFill>
+            <a:srgbClr val="0A254E"/>
           </a:solidFill>
           <a:ln>
             <a:solidFill>
@@ -8034,435 +8103,1468 @@
           </a:ln>
         </p:spPr>
         <p:txBody>
-          <a:bodyPr wrap="square" lIns="182880" rIns="182880" tIns="91440" bIns="91440">
+          <a:bodyPr wrap="square" lIns="131445" tIns="65723" rIns="131445" bIns="65723" rtlCol="0" anchor="ctr">
             <a:noAutofit/>
           </a:bodyPr>
           <a:lstStyle/>
           <a:p>
-            <a:pPr>
-              <a:spcBef>
-                <a:spcPts val="0"/>
-              </a:spcBef>
-              <a:buNone/>
-            </a:pPr>
-            <a:r>
-              <a:rPr lang="en-US" sz="4000" dirty="0" b="1">
-                <a:solidFill>
-                  <a:schemeClr val="bg1"/>
-                </a:solidFill>
-                <a:latin typeface="Arial"/>
-                <a:cs typeface="Arial"/>
-              </a:rPr>
-              <a:t>Results</a:t>
-            </a:r>
-          </a:p>
-          <a:p>
-            <a:pPr marL="342900" indent="-342900">
-              <a:spcBef>
-                <a:spcPts val="600"/>
-              </a:spcBef>
-              <a:buFont typeface="Arial"/>
-              <a:buChar char="•"/>
-            </a:pPr>
-            <a:r>
-              <a:rPr lang="en-US" sz="4000" dirty="0" b="1">
-                <a:solidFill>
-                  <a:schemeClr val="bg1"/>
-                </a:solidFill>
-                <a:latin typeface="Arial"/>
-                <a:cs typeface="Arial"/>
-              </a:rPr>
-              <a:t>447,607</a:t>
-            </a:r>
-            <a:r>
-              <a:rPr lang="en-US" sz="4000" dirty="0">
-                <a:solidFill>
-                  <a:schemeClr val="bg1"/>
-                </a:solidFill>
-                <a:latin typeface="Arial"/>
-                <a:cs typeface="Arial"/>
-              </a:rPr>
-              <a:t> U.S. branded food products were eligible (454,324 identified before exclusions)</a:t>
-            </a:r>
-          </a:p>
-          <a:p>
-            <a:pPr marL="342900" indent="-342900">
-              <a:spcBef>
-                <a:spcPts val="600"/>
-              </a:spcBef>
-              <a:buFont typeface="Arial"/>
-              <a:buChar char="•"/>
-            </a:pPr>
-            <a:r>
-              <a:rPr lang="en-US" sz="4000" dirty="0" b="1">
-                <a:solidFill>
-                  <a:schemeClr val="bg1"/>
-                </a:solidFill>
-                <a:latin typeface="Arial"/>
-                <a:cs typeface="Arial"/>
-              </a:rPr>
-              <a:t>29,503 products (6.6%)</a:t>
-            </a:r>
-            <a:r>
-              <a:rPr lang="en-US" sz="4000" dirty="0">
-                <a:solidFill>
-                  <a:schemeClr val="bg1"/>
-                </a:solidFill>
-                <a:latin typeface="Arial"/>
-                <a:cs typeface="Arial"/>
-              </a:rPr>
-              <a:t> listed HFCS as an ingredient, about </a:t>
-            </a:r>
-            <a:r>
-              <a:rPr lang="en-US" sz="4000" dirty="0" b="1">
-                <a:solidFill>
-                  <a:schemeClr val="bg1"/>
-                </a:solidFill>
-                <a:latin typeface="Arial"/>
-                <a:cs typeface="Arial"/>
-              </a:rPr>
-              <a:t>1 in 15</a:t>
-            </a:r>
-          </a:p>
-          <a:p>
-            <a:pPr marL="342900" indent="-342900">
-              <a:spcBef>
-                <a:spcPts val="600"/>
-              </a:spcBef>
-              <a:buFont typeface="Arial"/>
-              <a:buChar char="•"/>
-            </a:pPr>
-            <a:r>
-              <a:rPr lang="en-US" sz="4000" dirty="0" b="1">
-                <a:solidFill>
-                  <a:schemeClr val="bg1"/>
-                </a:solidFill>
-                <a:latin typeface="Arial"/>
-                <a:cs typeface="Arial"/>
-              </a:rPr>
-              <a:t>418,104 products (93.4%)</a:t>
-            </a:r>
-            <a:r>
-              <a:rPr lang="en-US" sz="4000" dirty="0">
-                <a:solidFill>
-                  <a:schemeClr val="bg1"/>
-                </a:solidFill>
-                <a:latin typeface="Arial"/>
-                <a:cs typeface="Arial"/>
-              </a:rPr>
-              <a:t> did not list HFCS</a:t>
-            </a:r>
-          </a:p>
-          <a:p>
-            <a:pPr>
-              <a:spcBef>
-                <a:spcPts val="1000"/>
-              </a:spcBef>
-              <a:buNone/>
-            </a:pPr>
-            <a:r>
-              <a:rPr lang="en-US" sz="4000" dirty="0" b="1">
-                <a:solidFill>
-                  <a:schemeClr val="bg1"/>
-                </a:solidFill>
-                <a:latin typeface="Arial"/>
-                <a:cs typeface="Arial"/>
-              </a:rPr>
-              <a:t>Conclusions</a:t>
-            </a:r>
-          </a:p>
-          <a:p>
-            <a:pPr marL="342900" indent="-342900">
-              <a:spcBef>
-                <a:spcPts val="600"/>
-              </a:spcBef>
-              <a:buFont typeface="Arial"/>
-              <a:buChar char="•"/>
-            </a:pPr>
-            <a:r>
-              <a:rPr lang="en-US" sz="4000" dirty="0">
-                <a:solidFill>
-                  <a:schemeClr val="bg1"/>
-                </a:solidFill>
-                <a:latin typeface="Arial"/>
-                <a:cs typeface="Arial"/>
-              </a:rPr>
-              <a:t>HFCS is listed in </a:t>
-            </a:r>
-            <a:r>
-              <a:rPr lang="en-US" sz="4000" dirty="0" b="1">
-                <a:solidFill>
-                  <a:schemeClr val="bg1"/>
-                </a:solidFill>
-                <a:latin typeface="Arial"/>
-                <a:cs typeface="Arial"/>
-              </a:rPr>
-              <a:t>6.6%</a:t>
-            </a:r>
-            <a:r>
-              <a:rPr lang="en-US" sz="4000" dirty="0">
-                <a:solidFill>
-                  <a:schemeClr val="bg1"/>
-                </a:solidFill>
-                <a:latin typeface="Arial"/>
-                <a:cs typeface="Arial"/>
-              </a:rPr>
-              <a:t> of U.S. branded food products, nearly </a:t>
-            </a:r>
-            <a:r>
-              <a:rPr lang="en-US" sz="4000" dirty="0" b="1">
-                <a:solidFill>
-                  <a:schemeClr val="bg1"/>
-                </a:solidFill>
-                <a:latin typeface="Arial"/>
-                <a:cs typeface="Arial"/>
-              </a:rPr>
-              <a:t>30,000</a:t>
-            </a:r>
-            <a:r>
-              <a:rPr lang="en-US" sz="4000" dirty="0">
-                <a:solidFill>
-                  <a:schemeClr val="bg1"/>
-                </a:solidFill>
-                <a:latin typeface="Arial"/>
-                <a:cs typeface="Arial"/>
-              </a:rPr>
-              <a:t> items</a:t>
-            </a:r>
-          </a:p>
-          <a:p>
-            <a:pPr marL="342900" indent="-342900">
-              <a:spcBef>
-                <a:spcPts val="600"/>
-              </a:spcBef>
-              <a:buFont typeface="Arial"/>
-              <a:buChar char="•"/>
-            </a:pPr>
-            <a:r>
-              <a:rPr lang="en-US" sz="4000" dirty="0">
-                <a:solidFill>
-                  <a:schemeClr val="bg1"/>
-                </a:solidFill>
-                <a:latin typeface="Arial"/>
-                <a:cs typeface="Arial"/>
-              </a:rPr>
-              <a:t>It is a minority ingredient, but still a relevant part of the commercial food supply</a:t>
-            </a:r>
-          </a:p>
-          <a:p>
-            <a:pPr marL="342900" indent="-342900">
-              <a:spcBef>
-                <a:spcPts val="600"/>
-              </a:spcBef>
-              <a:buFont typeface="Arial"/>
-              <a:buChar char="•"/>
-            </a:pPr>
-            <a:r>
-              <a:rPr lang="en-US" sz="4000" dirty="0">
-                <a:solidFill>
-                  <a:schemeClr val="bg1"/>
-                </a:solidFill>
-                <a:latin typeface="Arial"/>
-                <a:cs typeface="Arial"/>
-              </a:rPr>
-              <a:t>Product counts do not reflect consumption volume or the amount of HFCS per product</a:t>
-            </a:r>
-          </a:p>
-          <a:p>
-            <a:pPr marL="342900" indent="-342900">
-              <a:spcBef>
-                <a:spcPts val="600"/>
-              </a:spcBef>
-              <a:buFont typeface="Arial"/>
-              <a:buChar char="•"/>
-            </a:pPr>
-            <a:r>
-              <a:rPr lang="en-US" sz="4000" dirty="0">
-                <a:solidFill>
-                  <a:schemeClr val="bg1"/>
-                </a:solidFill>
-                <a:latin typeface="Arial"/>
-                <a:cs typeface="Arial"/>
-              </a:rPr>
-              <a:t>Term-based searching may slightly over- or under-count HFCS products</a:t>
-            </a:r>
-          </a:p>
-          <a:p>
-            <a:pPr marL="342900" indent="-342900">
-              <a:spcBef>
-                <a:spcPts val="600"/>
-              </a:spcBef>
-              <a:buFont typeface="Arial"/>
-              <a:buChar char="•"/>
-            </a:pPr>
-            <a:r>
-              <a:rPr lang="en-US" sz="4000" dirty="0">
-                <a:solidFill>
-                  <a:schemeClr val="bg1"/>
-                </a:solidFill>
-                <a:latin typeface="Arial"/>
-                <a:cs typeface="Arial"/>
-              </a:rPr>
-              <a:t>This analysis provides a </a:t>
-            </a:r>
-            <a:r>
-              <a:rPr lang="en-US" sz="4000" dirty="0" b="1">
-                <a:solidFill>
-                  <a:schemeClr val="bg1"/>
-                </a:solidFill>
-                <a:latin typeface="Arial"/>
-                <a:cs typeface="Arial"/>
-              </a:rPr>
-              <a:t>reproducible baseline</a:t>
-            </a:r>
-            <a:r>
-              <a:rPr lang="en-US" sz="4000" dirty="0">
-                <a:solidFill>
-                  <a:schemeClr val="bg1"/>
-                </a:solidFill>
-                <a:latin typeface="Arial"/>
-                <a:cs typeface="Arial"/>
-              </a:rPr>
-              <a:t> for HFCS surveillance, policy evaluation, and efforts to reduce added sugars</a:t>
-            </a:r>
-          </a:p>
-        </p:txBody>
-      </p:sp>
-      <p:pic>
-        <p:nvPicPr>
-          <p:cNvPr id="6" name="Picture 5">
+            <a:pPr algn="ctr"/>
+            <a:r>
+              <a:rPr lang="en-US" sz="4800" dirty="0">
+                <a:latin typeface="Times New Roman"/>
+                <a:cs typeface="Times New Roman"/>
+              </a:rPr>
+              <a:t>Results, Discussion, Conclusion, and Limitations</a:t>
+            </a:r>
+            <a:endParaRPr lang="en-US" sz="6000" dirty="0">
+              <a:latin typeface="Times New Roman"/>
+              <a:cs typeface="Times New Roman"/>
+            </a:endParaRPr>
+          </a:p>
+        </p:txBody>
+      </p:sp>
+      <p:graphicFrame>
+        <p:nvGraphicFramePr>
+          <p:cNvPr id="10" name="Table 9">
             <a:extLst>
               <a:ext uri="{FF2B5EF4-FFF2-40B4-BE49-F238E27FC236}">
-                <a16:creationId xmlns:a16="http://schemas.microsoft.com/office/drawing/2014/main" id="{C7008DBC-76B4-3746-A8C9-59875E92D402}"/>
+                <a16:creationId xmlns:a16="http://schemas.microsoft.com/office/drawing/2014/main" id="{205B63F2-1A1A-2B15-C5FA-4705C2E0F0C2}"/>
               </a:ext>
             </a:extLst>
           </p:cNvPr>
+          <p:cNvGraphicFramePr>
+            <a:graphicFrameLocks noGrp="1"/>
+          </p:cNvGraphicFramePr>
+          <p:nvPr>
+            <p:extLst>
+              <p:ext uri="{D42A27DB-BD31-4B8C-83A1-F6EECF244321}">
+                <p14:modId xmlns:p14="http://schemas.microsoft.com/office/powerpoint/2010/main" val="2301284607"/>
+              </p:ext>
+            </p:extLst>
+          </p:nvPr>
+        </p:nvGraphicFramePr>
+        <p:xfrm>
+          <a:off x="685800" y="22924008"/>
+          <a:ext cx="9427464" cy="9473184"/>
+        </p:xfrm>
+        <a:graphic>
+          <a:graphicData uri="http://schemas.openxmlformats.org/drawingml/2006/table">
+            <a:tbl>
+              <a:tblPr firstRow="1" bandRow="1">
+                <a:tableStyleId>{5C22544A-7EE6-4342-B048-85BDC9FD1C3A}</a:tableStyleId>
+              </a:tblPr>
+              <a:tblGrid>
+                <a:gridCol w="2651760">
+                  <a:extLst>
+                    <a:ext uri="{9D8B030D-6E8A-4147-A177-3AD203B41FA5}">
+                      <a16:colId xmlns:a16="http://schemas.microsoft.com/office/drawing/2014/main" val="2846790296"/>
+                    </a:ext>
+                  </a:extLst>
+                </a:gridCol>
+                <a:gridCol w="6775704">
+                  <a:extLst>
+                    <a:ext uri="{9D8B030D-6E8A-4147-A177-3AD203B41FA5}">
+                      <a16:colId xmlns:a16="http://schemas.microsoft.com/office/drawing/2014/main" val="1015726853"/>
+                    </a:ext>
+                  </a:extLst>
+                </a:gridCol>
+              </a:tblGrid>
+              <a:tr h="603504">
+                <a:tc>
+                  <a:txBody>
+                    <a:bodyPr wrap="square"/>
+                    <a:lstStyle/>
+                    <a:p>
+                      <a:pPr algn="l"/>
+                      <a:r>
+                        <a:rPr sz="2600" b="1" i="0">
+                          <a:solidFill>
+                            <a:srgbClr val="FFFFFF"/>
+                          </a:solidFill>
+                          <a:latin typeface="Times New Roman"/>
+                        </a:rPr>
+                        <a:t>METHOD</a:t>
+                      </a:r>
+                    </a:p>
+                  </a:txBody>
+                  <a:tcPr/>
+                </a:tc>
+                <a:tc>
+                  <a:txBody>
+                    <a:bodyPr wrap="square"/>
+                    <a:lstStyle/>
+                    <a:p>
+                      <a:pPr algn="l"/>
+                      <a:r>
+                        <a:rPr sz="2600" b="1" i="0">
+                          <a:solidFill>
+                            <a:srgbClr val="FFFFFF"/>
+                          </a:solidFill>
+                          <a:latin typeface="Times New Roman"/>
+                        </a:rPr>
+                        <a:t>DESCRIPTION</a:t>
+                      </a:r>
+                    </a:p>
+                  </a:txBody>
+                  <a:tcPr/>
+                </a:tc>
+                <a:extLst>
+                  <a:ext uri="{0D108BD9-81ED-4DB2-BD59-A6C34878D82A}">
+                    <a16:rowId xmlns:a16="http://schemas.microsoft.com/office/drawing/2014/main" val="3897735149"/>
+                  </a:ext>
+                </a:extLst>
+              </a:tr>
+              <a:tr h="2651760">
+                <a:tc>
+                  <a:txBody>
+                    <a:bodyPr wrap="square"/>
+                    <a:lstStyle/>
+                    <a:p>
+                      <a:pPr algn="l"/>
+                      <a:r>
+                        <a:rPr sz="2400" b="1" i="0">
+                          <a:solidFill>
+                            <a:srgbClr val="000000"/>
+                          </a:solidFill>
+                          <a:latin typeface="Times New Roman"/>
+                        </a:rPr>
+                        <a:t>Design &amp; Data Source</a:t>
+                      </a:r>
+                    </a:p>
+                  </a:txBody>
+                  <a:tcPr/>
+                </a:tc>
+                <a:tc>
+                  <a:txBody>
+                    <a:bodyPr wrap="square"/>
+                    <a:lstStyle/>
+                    <a:p>
+                      <a:pPr algn="l"/>
+                      <a:r>
+                        <a:rPr sz="2400" b="0" i="0">
+                          <a:solidFill>
+                            <a:srgbClr val="000000"/>
+                          </a:solidFill>
+                          <a:latin typeface="Times New Roman"/>
+                        </a:rPr>
+                        <a:t>Retrospective, cross-sectional, descriptive analysis of the USDA FoodData Central (FDC) Global Branded Food Products Database (GBFPD): 400,000+ branded and private-label products, supplied by industry and updated monthly.</a:t>
+                      </a:r>
+                      <a:r>
+                        <a:rPr sz="2400" b="0" i="0" baseline="30000">
+                          <a:solidFill>
+                            <a:srgbClr val="000000"/>
+                          </a:solidFill>
+                          <a:latin typeface="Times New Roman"/>
+                        </a:rPr>
+                        <a:t>8,9</a:t>
+                      </a:r>
+                      <a:endParaRPr lang="en-US" sz="2400" dirty="0">
+                        <a:latin typeface="Times New Roman" panose="02020603050405020304" pitchFamily="18" charset="0"/>
+                        <a:cs typeface="Times New Roman" panose="02020603050405020304" pitchFamily="18" charset="0"/>
+                      </a:endParaRPr>
+                    </a:p>
+                  </a:txBody>
+                  <a:tcPr/>
+                </a:tc>
+                <a:extLst>
+                  <a:ext uri="{0D108BD9-81ED-4DB2-BD59-A6C34878D82A}">
+                    <a16:rowId xmlns:a16="http://schemas.microsoft.com/office/drawing/2014/main" val="1955808230"/>
+                  </a:ext>
+                </a:extLst>
+              </a:tr>
+              <a:tr h="3383280">
+                <a:tc>
+                  <a:txBody>
+                    <a:bodyPr wrap="square"/>
+                    <a:lstStyle/>
+                    <a:p>
+                      <a:pPr algn="l"/>
+                      <a:r>
+                        <a:rPr sz="2400" b="1" i="0">
+                          <a:solidFill>
+                            <a:srgbClr val="000000"/>
+                          </a:solidFill>
+                          <a:latin typeface="Times New Roman"/>
+                        </a:rPr>
+                        <a:t>Search &amp; Eligibility</a:t>
+                      </a:r>
+                    </a:p>
+                  </a:txBody>
+                  <a:tcPr/>
+                </a:tc>
+                <a:tc>
+                  <a:txBody>
+                    <a:bodyPr wrap="square"/>
+                    <a:lstStyle/>
+                    <a:p>
+                      <a:pPr algn="l"/>
+                      <a:r>
+                        <a:rPr sz="2400" b="0" i="0">
+                          <a:solidFill>
+                            <a:srgbClr val="000000"/>
+                          </a:solidFill>
+                          <a:latin typeface="Times New Roman"/>
+                        </a:rPr>
+                        <a:t>FDC published date April 13, 2019 (earliest available) to December 13, 2025 (search date). Trade channels: grocery, convenience, mass merchandising, food service, vending, online, military, child nutrition programs, and none. </a:t>
+                      </a:r>
+                      <a:r>
+                        <a:rPr sz="2400" b="1" i="0">
+                          <a:solidFill>
+                            <a:srgbClr val="000000"/>
+                          </a:solidFill>
+                          <a:latin typeface="Times New Roman"/>
+                        </a:rPr>
+                        <a:t>Excluded:</a:t>
+                      </a:r>
+                      <a:r>
+                        <a:rPr sz="2400" b="0" i="0">
+                          <a:solidFill>
+                            <a:srgbClr val="000000"/>
+                          </a:solidFill>
+                          <a:latin typeface="Times New Roman"/>
+                        </a:rPr>
+                        <a:t> “Drug” category and New Zealand market (n = 6,717).</a:t>
+                      </a:r>
+                      <a:endParaRPr lang="en-US" sz="2400" dirty="0">
+                        <a:latin typeface="Times New Roman" panose="02020603050405020304" pitchFamily="18" charset="0"/>
+                        <a:cs typeface="Times New Roman" panose="02020603050405020304" pitchFamily="18" charset="0"/>
+                      </a:endParaRPr>
+                    </a:p>
+                  </a:txBody>
+                  <a:tcPr/>
+                </a:tc>
+                <a:extLst>
+                  <a:ext uri="{0D108BD9-81ED-4DB2-BD59-A6C34878D82A}">
+                    <a16:rowId xmlns:a16="http://schemas.microsoft.com/office/drawing/2014/main" val="4271464298"/>
+                  </a:ext>
+                </a:extLst>
+              </a:tr>
+              <a:tr h="1463040">
+                <a:tc>
+                  <a:txBody>
+                    <a:bodyPr wrap="square"/>
+                    <a:lstStyle/>
+                    <a:p>
+                      <a:pPr algn="l"/>
+                      <a:r>
+                        <a:rPr sz="2400" b="1" i="0">
+                          <a:solidFill>
+                            <a:srgbClr val="000000"/>
+                          </a:solidFill>
+                          <a:latin typeface="Times New Roman"/>
+                        </a:rPr>
+                        <a:t>HFCS Identification</a:t>
+                      </a:r>
+                    </a:p>
+                  </a:txBody>
+                  <a:tcPr/>
+                </a:tc>
+                <a:tc>
+                  <a:txBody>
+                    <a:bodyPr wrap="square"/>
+                    <a:lstStyle/>
+                    <a:p>
+                      <a:pPr algn="l"/>
+                      <a:r>
+                        <a:rPr sz="2400" b="0" i="0">
+                          <a:solidFill>
+                            <a:srgbClr val="000000"/>
+                          </a:solidFill>
+                          <a:latin typeface="Times New Roman"/>
+                        </a:rPr>
+                        <a:t>Ingredients field searched for “High” AND “Fructose” AND “Corn” AND “Syrup” (all four terms required).</a:t>
+                      </a:r>
+                      <a:endParaRPr lang="en-US" sz="2400" dirty="0">
+                        <a:latin typeface="Times New Roman" panose="02020603050405020304" pitchFamily="18" charset="0"/>
+                        <a:cs typeface="Times New Roman" panose="02020603050405020304" pitchFamily="18" charset="0"/>
+                      </a:endParaRPr>
+                    </a:p>
+                  </a:txBody>
+                  <a:tcPr/>
+                </a:tc>
+                <a:extLst>
+                  <a:ext uri="{0D108BD9-81ED-4DB2-BD59-A6C34878D82A}">
+                    <a16:rowId xmlns:a16="http://schemas.microsoft.com/office/drawing/2014/main" val="4056894884"/>
+                  </a:ext>
+                </a:extLst>
+              </a:tr>
+              <a:tr h="1371600">
+                <a:tc>
+                  <a:txBody>
+                    <a:bodyPr wrap="square"/>
+                    <a:lstStyle/>
+                    <a:p>
+                      <a:pPr algn="l"/>
+                      <a:r>
+                        <a:rPr sz="2400" b="1" i="0">
+                          <a:solidFill>
+                            <a:srgbClr val="000000"/>
+                          </a:solidFill>
+                          <a:latin typeface="Times New Roman"/>
+                        </a:rPr>
+                        <a:t>Outcome &amp; Analysis</a:t>
+                      </a:r>
+                    </a:p>
+                  </a:txBody>
+                  <a:tcPr/>
+                </a:tc>
+                <a:tc>
+                  <a:txBody>
+                    <a:bodyPr wrap="square"/>
+                    <a:lstStyle/>
+                    <a:p>
+                      <a:pPr algn="l"/>
+                      <a:r>
+                        <a:rPr sz="2400" b="0" i="0">
+                          <a:solidFill>
+                            <a:srgbClr val="000000"/>
+                          </a:solidFill>
+                          <a:latin typeface="Times New Roman"/>
+                        </a:rPr>
+                        <a:t>Proportion of eligible products listing HFCS as an ingredient; counts and percentages in Microsoft Excel.</a:t>
+                      </a:r>
+                      <a:endParaRPr lang="en-US" sz="2400" dirty="0">
+                        <a:latin typeface="Times New Roman" panose="02020603050405020304" pitchFamily="18" charset="0"/>
+                        <a:cs typeface="Times New Roman" panose="02020603050405020304" pitchFamily="18" charset="0"/>
+                      </a:endParaRPr>
+                    </a:p>
+                  </a:txBody>
+                  <a:tcPr/>
+                </a:tc>
+                <a:extLst>
+                  <a:ext uri="{0D108BD9-81ED-4DB2-BD59-A6C34878D82A}">
+                    <a16:rowId xmlns:a16="http://schemas.microsoft.com/office/drawing/2014/main" val="3400023977"/>
+                  </a:ext>
+                </a:extLst>
+              </a:tr>
+            </a:tbl>
+          </a:graphicData>
+        </a:graphic>
+      </p:graphicFrame>
+      <p:cxnSp>
+        <p:nvCxnSpPr>
+          <p:cNvPr id="6" name="Straight Connector 5">
+            <a:extLst>
+              <a:ext uri="{FF2B5EF4-FFF2-40B4-BE49-F238E27FC236}">
+                <a16:creationId xmlns:a16="http://schemas.microsoft.com/office/drawing/2014/main" id="{27F635D7-8592-DF05-AA6D-AD2EB280C030}"/>
+              </a:ext>
+            </a:extLst>
+          </p:cNvPr>
+          <p:cNvCxnSpPr/>
+          <p:nvPr/>
+        </p:nvCxnSpPr>
+        <p:spPr>
+          <a:xfrm>
+            <a:off x="0" y="-26234"/>
+            <a:ext cx="43991438" cy="0"/>
+          </a:xfrm>
+          <a:prstGeom prst="line">
+            <a:avLst/>
+          </a:prstGeom>
+        </p:spPr>
+        <p:style>
+          <a:lnRef idx="1">
+            <a:schemeClr val="dk1"/>
+          </a:lnRef>
+          <a:fillRef idx="0">
+            <a:schemeClr val="dk1"/>
+          </a:fillRef>
+          <a:effectRef idx="0">
+            <a:schemeClr val="dk1"/>
+          </a:effectRef>
+          <a:fontRef idx="minor">
+            <a:schemeClr val="tx1"/>
+          </a:fontRef>
+        </p:style>
+      </p:cxnSp>
+      <p:sp>
+        <p:nvSpPr>
+          <p:cNvPr id="327" name="TextBox 326"/>
+          <p:cNvSpPr txBox="1"/>
+          <p:nvPr/>
+        </p:nvSpPr>
+        <p:spPr>
+          <a:xfrm>
+            <a:off x="34006536" y="28181808"/>
+            <a:ext cx="9253728" cy="4096511"/>
+          </a:xfrm>
+          <a:prstGeom prst="rect">
+            <a:avLst/>
+          </a:prstGeom>
+          <a:solidFill>
+            <a:srgbClr val="FFFFFF"/>
+          </a:solidFill>
+          <a:ln>
+            <a:solidFill>
+              <a:srgbClr val="0A254E"/>
+            </a:solidFill>
+          </a:ln>
+        </p:spPr>
+        <p:txBody>
+          <a:bodyPr wrap="square">
+            <a:noAutofit/>
+          </a:bodyPr>
+          <a:lstStyle/>
+          <a:p>
+            <a:pPr>
+              <a:spcAft>
+                <a:spcPts val="100"/>
+              </a:spcAft>
+            </a:pPr>
+            <a:r>
+              <a:rPr sz="1600" b="0" i="0">
+                <a:solidFill>
+                  <a:srgbClr val="000000"/>
+                </a:solidFill>
+                <a:latin typeface="Times New Roman"/>
+              </a:rPr>
+              <a:t>1. Wang X, et al. </a:t>
+            </a:r>
+            <a:r>
+              <a:rPr sz="1600" b="0" i="1">
+                <a:solidFill>
+                  <a:srgbClr val="000000"/>
+                </a:solidFill>
+                <a:latin typeface="Times New Roman"/>
+              </a:rPr>
+              <a:t>NPJ Sci Food</a:t>
+            </a:r>
+            <a:r>
+              <a:rPr sz="1600" b="0" i="0">
+                <a:solidFill>
+                  <a:srgbClr val="000000"/>
+                </a:solidFill>
+                <a:latin typeface="Times New Roman"/>
+              </a:rPr>
+              <a:t>. 2022;6(1):17.</a:t>
+            </a:r>
+          </a:p>
+          <a:p>
+            <a:pPr>
+              <a:spcAft>
+                <a:spcPts val="100"/>
+              </a:spcAft>
+            </a:pPr>
+            <a:r>
+              <a:rPr sz="1600" b="0" i="0">
+                <a:solidFill>
+                  <a:srgbClr val="000000"/>
+                </a:solidFill>
+                <a:latin typeface="Times New Roman"/>
+              </a:rPr>
+              <a:t>2. IndustryResearch.biz. HFCS market report [2034]. 2025.</a:t>
+            </a:r>
+          </a:p>
+          <a:p>
+            <a:pPr>
+              <a:spcAft>
+                <a:spcPts val="100"/>
+              </a:spcAft>
+            </a:pPr>
+            <a:r>
+              <a:rPr sz="1600" b="0" i="0">
+                <a:solidFill>
+                  <a:srgbClr val="000000"/>
+                </a:solidFill>
+                <a:latin typeface="Times New Roman"/>
+              </a:rPr>
+              <a:t>3. White JS. </a:t>
+            </a:r>
+            <a:r>
+              <a:rPr sz="1600" b="0" i="1">
+                <a:solidFill>
+                  <a:srgbClr val="000000"/>
+                </a:solidFill>
+                <a:latin typeface="Times New Roman"/>
+              </a:rPr>
+              <a:t>Am J Clin Nutr</a:t>
+            </a:r>
+            <a:r>
+              <a:rPr sz="1600" b="0" i="0">
+                <a:solidFill>
+                  <a:srgbClr val="000000"/>
+                </a:solidFill>
+                <a:latin typeface="Times New Roman"/>
+              </a:rPr>
+              <a:t>. 2008;88(6):1716S-1721S.</a:t>
+            </a:r>
+          </a:p>
+          <a:p>
+            <a:pPr>
+              <a:spcAft>
+                <a:spcPts val="100"/>
+              </a:spcAft>
+            </a:pPr>
+            <a:r>
+              <a:rPr sz="1600" b="0" i="0">
+                <a:solidFill>
+                  <a:srgbClr val="000000"/>
+                </a:solidFill>
+                <a:latin typeface="Times New Roman"/>
+              </a:rPr>
+              <a:t>4. Duffey KJ, Popkin BM. </a:t>
+            </a:r>
+            <a:r>
+              <a:rPr sz="1600" b="0" i="1">
+                <a:solidFill>
+                  <a:srgbClr val="000000"/>
+                </a:solidFill>
+                <a:latin typeface="Times New Roman"/>
+              </a:rPr>
+              <a:t>Am J Clin Nutr</a:t>
+            </a:r>
+            <a:r>
+              <a:rPr sz="1600" b="0" i="0">
+                <a:solidFill>
+                  <a:srgbClr val="000000"/>
+                </a:solidFill>
+                <a:latin typeface="Times New Roman"/>
+              </a:rPr>
+              <a:t>. 2008;88(6):1722S-1732S.</a:t>
+            </a:r>
+          </a:p>
+          <a:p>
+            <a:pPr>
+              <a:spcAft>
+                <a:spcPts val="100"/>
+              </a:spcAft>
+            </a:pPr>
+            <a:r>
+              <a:rPr sz="1600" b="0" i="0">
+                <a:solidFill>
+                  <a:srgbClr val="000000"/>
+                </a:solidFill>
+                <a:latin typeface="Times New Roman"/>
+              </a:rPr>
+              <a:t>5. Sigala DM, et al. </a:t>
+            </a:r>
+            <a:r>
+              <a:rPr sz="1600" b="0" i="1">
+                <a:solidFill>
+                  <a:srgbClr val="000000"/>
+                </a:solidFill>
+                <a:latin typeface="Times New Roman"/>
+              </a:rPr>
+              <a:t>J Clin Endocrinol Metab</a:t>
+            </a:r>
+            <a:r>
+              <a:rPr sz="1600" b="0" i="0">
+                <a:solidFill>
+                  <a:srgbClr val="000000"/>
+                </a:solidFill>
+                <a:latin typeface="Times New Roman"/>
+              </a:rPr>
+              <a:t>. 2021;106(11):3248-3264.</a:t>
+            </a:r>
+          </a:p>
+          <a:p>
+            <a:pPr>
+              <a:spcAft>
+                <a:spcPts val="100"/>
+              </a:spcAft>
+            </a:pPr>
+            <a:r>
+              <a:rPr sz="1600" b="0" i="0">
+                <a:solidFill>
+                  <a:srgbClr val="000000"/>
+                </a:solidFill>
+                <a:latin typeface="Times New Roman"/>
+              </a:rPr>
+              <a:t>6. DeChristopher LR. </a:t>
+            </a:r>
+            <a:r>
+              <a:rPr sz="1600" b="0" i="1">
+                <a:solidFill>
+                  <a:srgbClr val="000000"/>
+                </a:solidFill>
+                <a:latin typeface="Times New Roman"/>
+              </a:rPr>
+              <a:t>Nutr J</a:t>
+            </a:r>
+            <a:r>
+              <a:rPr sz="1600" b="0" i="0">
+                <a:solidFill>
+                  <a:srgbClr val="000000"/>
+                </a:solidFill>
+                <a:latin typeface="Times New Roman"/>
+              </a:rPr>
+              <a:t>. 2024;23(1):16.</a:t>
+            </a:r>
+          </a:p>
+          <a:p>
+            <a:pPr>
+              <a:spcAft>
+                <a:spcPts val="100"/>
+              </a:spcAft>
+            </a:pPr>
+            <a:r>
+              <a:rPr sz="1600" b="0" i="0">
+                <a:solidFill>
+                  <a:srgbClr val="000000"/>
+                </a:solidFill>
+                <a:latin typeface="Times New Roman"/>
+              </a:rPr>
+              <a:t>7. USDA, HHS. </a:t>
+            </a:r>
+            <a:r>
+              <a:rPr sz="1600" b="0" i="1">
+                <a:solidFill>
+                  <a:srgbClr val="000000"/>
+                </a:solidFill>
+                <a:latin typeface="Times New Roman"/>
+              </a:rPr>
+              <a:t>Dietary Guidelines for Americans, 2025–2030</a:t>
+            </a:r>
+            <a:r>
+              <a:rPr sz="1600" b="0" i="0">
+                <a:solidFill>
+                  <a:srgbClr val="000000"/>
+                </a:solidFill>
+                <a:latin typeface="Times New Roman"/>
+              </a:rPr>
+              <a:t>. 2026.</a:t>
+            </a:r>
+          </a:p>
+          <a:p>
+            <a:pPr>
+              <a:spcAft>
+                <a:spcPts val="100"/>
+              </a:spcAft>
+            </a:pPr>
+            <a:r>
+              <a:rPr sz="1600" b="0" i="0">
+                <a:solidFill>
+                  <a:srgbClr val="000000"/>
+                </a:solidFill>
+                <a:latin typeface="Times New Roman"/>
+              </a:rPr>
+              <a:t>8. Fukagawa NK, et al. </a:t>
+            </a:r>
+            <a:r>
+              <a:rPr sz="1600" b="0" i="1">
+                <a:solidFill>
+                  <a:srgbClr val="000000"/>
+                </a:solidFill>
+                <a:latin typeface="Times New Roman"/>
+              </a:rPr>
+              <a:t>Am J Clin Nutr</a:t>
+            </a:r>
+            <a:r>
+              <a:rPr sz="1600" b="0" i="0">
+                <a:solidFill>
+                  <a:srgbClr val="000000"/>
+                </a:solidFill>
+                <a:latin typeface="Times New Roman"/>
+              </a:rPr>
+              <a:t>. 2022;115(3):619-624.</a:t>
+            </a:r>
+          </a:p>
+          <a:p>
+            <a:pPr>
+              <a:spcAft>
+                <a:spcPts val="100"/>
+              </a:spcAft>
+            </a:pPr>
+            <a:r>
+              <a:rPr sz="1600" b="0" i="0">
+                <a:solidFill>
+                  <a:srgbClr val="000000"/>
+                </a:solidFill>
+                <a:latin typeface="Times New Roman"/>
+              </a:rPr>
+              <a:t>9. Larrick B, et al. </a:t>
+            </a:r>
+            <a:r>
+              <a:rPr sz="1600" b="0" i="1">
+                <a:solidFill>
+                  <a:srgbClr val="000000"/>
+                </a:solidFill>
+                <a:latin typeface="Times New Roman"/>
+              </a:rPr>
+              <a:t>J Food Compos Anal</a:t>
+            </a:r>
+            <a:r>
+              <a:rPr sz="1600" b="0" i="0">
+                <a:solidFill>
+                  <a:srgbClr val="000000"/>
+                </a:solidFill>
+                <a:latin typeface="Times New Roman"/>
+              </a:rPr>
+              <a:t>. 2022;105:104250.</a:t>
+            </a:r>
+          </a:p>
+          <a:p>
+            <a:pPr>
+              <a:spcAft>
+                <a:spcPts val="100"/>
+              </a:spcAft>
+            </a:pPr>
+            <a:r>
+              <a:rPr sz="1600" b="0" i="0">
+                <a:solidFill>
+                  <a:srgbClr val="000000"/>
+                </a:solidFill>
+                <a:latin typeface="Times New Roman"/>
+              </a:rPr>
+              <a:t>10. USDA Economic Research Service. HFCS availability peaked in 1999. 2013.</a:t>
+            </a:r>
+          </a:p>
+          <a:p>
+            <a:pPr>
+              <a:spcAft>
+                <a:spcPts val="100"/>
+              </a:spcAft>
+            </a:pPr>
+            <a:r>
+              <a:rPr sz="1600" b="0" i="0">
+                <a:solidFill>
+                  <a:srgbClr val="000000"/>
+                </a:solidFill>
+                <a:latin typeface="Times New Roman"/>
+              </a:rPr>
+              <a:t>11. Martínez Steele E, et al. </a:t>
+            </a:r>
+            <a:r>
+              <a:rPr sz="1600" b="0" i="1">
+                <a:solidFill>
+                  <a:srgbClr val="000000"/>
+                </a:solidFill>
+                <a:latin typeface="Times New Roman"/>
+              </a:rPr>
+              <a:t>BMJ Open</a:t>
+            </a:r>
+            <a:r>
+              <a:rPr sz="1600" b="0" i="0">
+                <a:solidFill>
+                  <a:srgbClr val="000000"/>
+                </a:solidFill>
+                <a:latin typeface="Times New Roman"/>
+              </a:rPr>
+              <a:t>. 2016;6(3):e009892.</a:t>
+            </a:r>
+          </a:p>
+          <a:p>
+            <a:pPr>
+              <a:spcAft>
+                <a:spcPts val="100"/>
+              </a:spcAft>
+            </a:pPr>
+            <a:r>
+              <a:rPr sz="1600" b="0" i="0">
+                <a:solidFill>
+                  <a:srgbClr val="000000"/>
+                </a:solidFill>
+                <a:latin typeface="Times New Roman"/>
+              </a:rPr>
+              <a:t>12. Nguyen M, et al. </a:t>
+            </a:r>
+            <a:r>
+              <a:rPr sz="1600" b="0" i="1">
+                <a:solidFill>
+                  <a:srgbClr val="000000"/>
+                </a:solidFill>
+                <a:latin typeface="Times New Roman"/>
+              </a:rPr>
+              <a:t>Am J Clin Nutr</a:t>
+            </a:r>
+            <a:r>
+              <a:rPr sz="1600" b="0" i="0">
+                <a:solidFill>
+                  <a:srgbClr val="000000"/>
+                </a:solidFill>
+                <a:latin typeface="Times New Roman"/>
+              </a:rPr>
+              <a:t>. 2023;117(1):160-174.</a:t>
+            </a:r>
+          </a:p>
+          <a:p>
+            <a:pPr>
+              <a:spcAft>
+                <a:spcPts val="100"/>
+              </a:spcAft>
+            </a:pPr>
+            <a:r>
+              <a:rPr sz="1600" b="0" i="0">
+                <a:solidFill>
+                  <a:srgbClr val="000000"/>
+                </a:solidFill>
+                <a:latin typeface="Times New Roman"/>
+              </a:rPr>
+              <a:t>13. Li X, et al. </a:t>
+            </a:r>
+            <a:r>
+              <a:rPr sz="1600" b="0" i="1">
+                <a:solidFill>
+                  <a:srgbClr val="000000"/>
+                </a:solidFill>
+                <a:latin typeface="Times New Roman"/>
+              </a:rPr>
+              <a:t>Front Nutr</a:t>
+            </a:r>
+            <a:r>
+              <a:rPr sz="1600" b="0" i="0">
+                <a:solidFill>
+                  <a:srgbClr val="000000"/>
+                </a:solidFill>
+                <a:latin typeface="Times New Roman"/>
+              </a:rPr>
+              <a:t>. 2022;9:1013310.</a:t>
+            </a:r>
+          </a:p>
+          <a:p>
+            <a:pPr>
+              <a:spcAft>
+                <a:spcPts val="100"/>
+              </a:spcAft>
+            </a:pPr>
+            <a:r>
+              <a:rPr sz="1600" b="0" i="0">
+                <a:solidFill>
+                  <a:srgbClr val="000000"/>
+                </a:solidFill>
+                <a:latin typeface="Times New Roman"/>
+              </a:rPr>
+              <a:t>14. FDA. Added sugars on the Nutrition Facts label. 2024.</a:t>
+            </a:r>
+          </a:p>
+        </p:txBody>
+      </p:sp>
+      <p:sp>
+        <p:nvSpPr>
+          <p:cNvPr id="328" name="TextBox 327"/>
+          <p:cNvSpPr txBox="1"/>
+          <p:nvPr/>
+        </p:nvSpPr>
+        <p:spPr>
+          <a:xfrm>
+            <a:off x="11329416" y="4572000"/>
+            <a:ext cx="5410962" cy="3383280"/>
+          </a:xfrm>
+          <a:prstGeom prst="rect">
+            <a:avLst/>
+          </a:prstGeom>
+          <a:noFill/>
+        </p:spPr>
+        <p:txBody>
+          <a:bodyPr wrap="square" anchor="t">
+            <a:noAutofit/>
+          </a:bodyPr>
+          <a:lstStyle/>
+          <a:p>
+            <a:pPr algn="ctr"/>
+            <a:r>
+              <a:rPr sz="8800" b="1" i="0">
+                <a:solidFill>
+                  <a:srgbClr val="0A254E"/>
+                </a:solidFill>
+                <a:latin typeface="Times New Roman"/>
+              </a:rPr>
+              <a:t>454,324</a:t>
+            </a:r>
+          </a:p>
+          <a:p>
+            <a:pPr algn="ctr"/>
+            <a:r>
+              <a:rPr sz="2800" b="0" i="0">
+                <a:solidFill>
+                  <a:srgbClr val="000000"/>
+                </a:solidFill>
+                <a:latin typeface="Times New Roman"/>
+              </a:rPr>
+              <a:t>products identified</a:t>
+            </a:r>
+          </a:p>
+          <a:p>
+            <a:pPr algn="ctr"/>
+            <a:r>
+              <a:rPr sz="2400" b="0" i="1">
+                <a:solidFill>
+                  <a:srgbClr val="595959"/>
+                </a:solidFill>
+                <a:latin typeface="Times New Roman"/>
+              </a:rPr>
+              <a:t>USDA GBFPD, 2019–2025</a:t>
+            </a:r>
+          </a:p>
+        </p:txBody>
+      </p:sp>
+      <p:sp>
+        <p:nvSpPr>
+          <p:cNvPr id="329" name="TextBox 328"/>
+          <p:cNvSpPr txBox="1"/>
+          <p:nvPr/>
+        </p:nvSpPr>
+        <p:spPr>
+          <a:xfrm>
+            <a:off x="16740378" y="4572000"/>
+            <a:ext cx="5410962" cy="3383280"/>
+          </a:xfrm>
+          <a:prstGeom prst="rect">
+            <a:avLst/>
+          </a:prstGeom>
+          <a:noFill/>
+        </p:spPr>
+        <p:txBody>
+          <a:bodyPr wrap="square" anchor="t">
+            <a:noAutofit/>
+          </a:bodyPr>
+          <a:lstStyle/>
+          <a:p>
+            <a:pPr algn="ctr"/>
+            <a:r>
+              <a:rPr sz="8800" b="1" i="0">
+                <a:solidFill>
+                  <a:srgbClr val="0A254E"/>
+                </a:solidFill>
+                <a:latin typeface="Times New Roman"/>
+              </a:rPr>
+              <a:t>447,607</a:t>
+            </a:r>
+          </a:p>
+          <a:p>
+            <a:pPr algn="ctr"/>
+            <a:r>
+              <a:rPr sz="2800" b="0" i="0">
+                <a:solidFill>
+                  <a:srgbClr val="000000"/>
+                </a:solidFill>
+                <a:latin typeface="Times New Roman"/>
+              </a:rPr>
+              <a:t>eligible U.S. products</a:t>
+            </a:r>
+          </a:p>
+          <a:p>
+            <a:pPr algn="ctr"/>
+            <a:r>
+              <a:rPr sz="2400" b="0" i="1">
+                <a:solidFill>
+                  <a:srgbClr val="595959"/>
+                </a:solidFill>
+                <a:latin typeface="Times New Roman"/>
+              </a:rPr>
+              <a:t>after 6,717 excluded</a:t>
+            </a:r>
+          </a:p>
+        </p:txBody>
+      </p:sp>
+      <p:cxnSp>
+        <p:nvCxnSpPr>
+          <p:cNvPr id="330" name="Connector 329"/>
+          <p:cNvCxnSpPr/>
+          <p:nvPr/>
+        </p:nvCxnSpPr>
+        <p:spPr>
+          <a:xfrm>
+            <a:off x="16740378" y="4846320"/>
+            <a:ext cx="0" cy="2834640"/>
+          </a:xfrm>
+          <a:prstGeom prst="line">
+            <a:avLst/>
+          </a:prstGeom>
+          <a:ln>
+            <a:solidFill>
+              <a:srgbClr val="BFBFBF"/>
+            </a:solidFill>
+          </a:ln>
+        </p:spPr>
+        <p:style>
+          <a:lnRef idx="2">
+            <a:schemeClr val="accent1"/>
+          </a:lnRef>
+          <a:fillRef idx="0">
+            <a:schemeClr val="accent1"/>
+          </a:fillRef>
+          <a:effectRef idx="1">
+            <a:schemeClr val="accent1"/>
+          </a:effectRef>
+          <a:fontRef idx="minor">
+            <a:schemeClr val="tx1"/>
+          </a:fontRef>
+        </p:style>
+      </p:cxnSp>
+      <p:sp>
+        <p:nvSpPr>
+          <p:cNvPr id="331" name="TextBox 330"/>
+          <p:cNvSpPr txBox="1"/>
+          <p:nvPr/>
+        </p:nvSpPr>
+        <p:spPr>
+          <a:xfrm>
+            <a:off x="22151340" y="4572000"/>
+            <a:ext cx="5410962" cy="3383280"/>
+          </a:xfrm>
+          <a:prstGeom prst="rect">
+            <a:avLst/>
+          </a:prstGeom>
+          <a:noFill/>
+        </p:spPr>
+        <p:txBody>
+          <a:bodyPr wrap="square" anchor="t">
+            <a:noAutofit/>
+          </a:bodyPr>
+          <a:lstStyle/>
+          <a:p>
+            <a:pPr algn="ctr"/>
+            <a:r>
+              <a:rPr sz="8800" b="1" i="0">
+                <a:solidFill>
+                  <a:srgbClr val="D55E00"/>
+                </a:solidFill>
+                <a:latin typeface="Times New Roman"/>
+              </a:rPr>
+              <a:t>29,503</a:t>
+            </a:r>
+          </a:p>
+          <a:p>
+            <a:pPr algn="ctr"/>
+            <a:r>
+              <a:rPr sz="2800" b="0" i="0">
+                <a:solidFill>
+                  <a:srgbClr val="000000"/>
+                </a:solidFill>
+                <a:latin typeface="Times New Roman"/>
+              </a:rPr>
+              <a:t>list HFCS</a:t>
+            </a:r>
+          </a:p>
+          <a:p>
+            <a:pPr algn="ctr"/>
+            <a:r>
+              <a:rPr sz="2400" b="0" i="1">
+                <a:solidFill>
+                  <a:srgbClr val="595959"/>
+                </a:solidFill>
+                <a:latin typeface="Times New Roman"/>
+              </a:rPr>
+              <a:t>as an ingredient</a:t>
+            </a:r>
+          </a:p>
+        </p:txBody>
+      </p:sp>
+      <p:cxnSp>
+        <p:nvCxnSpPr>
+          <p:cNvPr id="332" name="Connector 331"/>
+          <p:cNvCxnSpPr/>
+          <p:nvPr/>
+        </p:nvCxnSpPr>
+        <p:spPr>
+          <a:xfrm>
+            <a:off x="22151340" y="4846320"/>
+            <a:ext cx="0" cy="2834640"/>
+          </a:xfrm>
+          <a:prstGeom prst="line">
+            <a:avLst/>
+          </a:prstGeom>
+          <a:ln>
+            <a:solidFill>
+              <a:srgbClr val="BFBFBF"/>
+            </a:solidFill>
+          </a:ln>
+        </p:spPr>
+        <p:style>
+          <a:lnRef idx="2">
+            <a:schemeClr val="accent1"/>
+          </a:lnRef>
+          <a:fillRef idx="0">
+            <a:schemeClr val="accent1"/>
+          </a:fillRef>
+          <a:effectRef idx="1">
+            <a:schemeClr val="accent1"/>
+          </a:effectRef>
+          <a:fontRef idx="minor">
+            <a:schemeClr val="tx1"/>
+          </a:fontRef>
+        </p:style>
+      </p:cxnSp>
+      <p:sp>
+        <p:nvSpPr>
+          <p:cNvPr id="333" name="TextBox 332"/>
+          <p:cNvSpPr txBox="1"/>
+          <p:nvPr/>
+        </p:nvSpPr>
+        <p:spPr>
+          <a:xfrm>
+            <a:off x="27562302" y="4572000"/>
+            <a:ext cx="5410962" cy="3383280"/>
+          </a:xfrm>
+          <a:prstGeom prst="rect">
+            <a:avLst/>
+          </a:prstGeom>
+          <a:noFill/>
+        </p:spPr>
+        <p:txBody>
+          <a:bodyPr wrap="square" anchor="t">
+            <a:noAutofit/>
+          </a:bodyPr>
+          <a:lstStyle/>
+          <a:p>
+            <a:pPr algn="ctr"/>
+            <a:r>
+              <a:rPr sz="8800" b="1" i="0">
+                <a:solidFill>
+                  <a:srgbClr val="D55E00"/>
+                </a:solidFill>
+                <a:latin typeface="Times New Roman"/>
+              </a:rPr>
+              <a:t>6.6%</a:t>
+            </a:r>
+          </a:p>
+          <a:p>
+            <a:pPr algn="ctr"/>
+            <a:r>
+              <a:rPr sz="2800" b="0" i="0">
+                <a:solidFill>
+                  <a:srgbClr val="000000"/>
+                </a:solidFill>
+                <a:latin typeface="Times New Roman"/>
+              </a:rPr>
+              <a:t>of branded products</a:t>
+            </a:r>
+          </a:p>
+          <a:p>
+            <a:pPr algn="ctr"/>
+            <a:r>
+              <a:rPr sz="2400" b="0" i="1">
+                <a:solidFill>
+                  <a:srgbClr val="595959"/>
+                </a:solidFill>
+                <a:latin typeface="Times New Roman"/>
+              </a:rPr>
+              <a:t>about 1 in 15</a:t>
+            </a:r>
+          </a:p>
+        </p:txBody>
+      </p:sp>
+      <p:cxnSp>
+        <p:nvCxnSpPr>
+          <p:cNvPr id="334" name="Connector 333"/>
+          <p:cNvCxnSpPr/>
+          <p:nvPr/>
+        </p:nvCxnSpPr>
+        <p:spPr>
+          <a:xfrm>
+            <a:off x="27562302" y="4846320"/>
+            <a:ext cx="0" cy="2834640"/>
+          </a:xfrm>
+          <a:prstGeom prst="line">
+            <a:avLst/>
+          </a:prstGeom>
+          <a:ln>
+            <a:solidFill>
+              <a:srgbClr val="BFBFBF"/>
+            </a:solidFill>
+          </a:ln>
+        </p:spPr>
+        <p:style>
+          <a:lnRef idx="2">
+            <a:schemeClr val="accent1"/>
+          </a:lnRef>
+          <a:fillRef idx="0">
+            <a:schemeClr val="accent1"/>
+          </a:fillRef>
+          <a:effectRef idx="1">
+            <a:schemeClr val="accent1"/>
+          </a:effectRef>
+          <a:fontRef idx="minor">
+            <a:schemeClr val="tx1"/>
+          </a:fontRef>
+        </p:style>
+      </p:cxnSp>
+      <p:pic>
+        <p:nvPicPr>
+          <p:cNvPr id="335" name="Picture 334" descr="flow_new.png"/>
           <p:cNvPicPr>
             <a:picLocks noChangeAspect="1"/>
           </p:cNvPicPr>
           <p:nvPr/>
         </p:nvPicPr>
         <p:blipFill>
-          <a:blip r:embed="rId8"/>
+          <a:blip r:embed="rId4"/>
           <a:stretch>
             <a:fillRect/>
           </a:stretch>
         </p:blipFill>
         <p:spPr>
           <a:xfrm>
-            <a:off x="16179312" y="4526280"/>
-            <a:ext cx="11605726" cy="9326880"/>
+            <a:off x="11237976" y="8465635"/>
+            <a:ext cx="10424160" cy="8123288"/>
           </a:xfrm>
           <a:prstGeom prst="rect">
             <a:avLst/>
           </a:prstGeom>
         </p:spPr>
       </p:pic>
+      <p:sp>
+        <p:nvSpPr>
+          <p:cNvPr id="336" name="TextBox 335"/>
+          <p:cNvSpPr txBox="1"/>
+          <p:nvPr/>
+        </p:nvSpPr>
+        <p:spPr>
+          <a:xfrm>
+            <a:off x="11237976" y="16687800"/>
+            <a:ext cx="10424160" cy="1188720"/>
+          </a:xfrm>
+          <a:prstGeom prst="rect">
+            <a:avLst/>
+          </a:prstGeom>
+          <a:noFill/>
+        </p:spPr>
+        <p:txBody>
+          <a:bodyPr wrap="square" anchor="t">
+            <a:noAutofit/>
+          </a:bodyPr>
+          <a:lstStyle/>
+          <a:p>
+            <a:pPr algn="l"/>
+            <a:r>
+              <a:rPr sz="2200" b="1" i="0">
+                <a:solidFill>
+                  <a:srgbClr val="000000"/>
+                </a:solidFill>
+                <a:latin typeface="Times New Roman"/>
+              </a:rPr>
+              <a:t>Figure 1. Product Selection Flow.</a:t>
+            </a:r>
+            <a:r>
+              <a:rPr sz="2200" b="0" i="0">
+                <a:solidFill>
+                  <a:srgbClr val="000000"/>
+                </a:solidFill>
+                <a:latin typeface="Times New Roman"/>
+              </a:rPr>
+              <a:t> Products published in the USDA Global Branded Food Products Database, April 13, 2019–December 13, 2025.</a:t>
+            </a:r>
+          </a:p>
+        </p:txBody>
+      </p:sp>
       <p:pic>
         <p:nvPicPr>
-          <p:cNvPr id="8" name="Picture 7">
-            <a:extLst>
-              <a:ext uri="{FF2B5EF4-FFF2-40B4-BE49-F238E27FC236}">
-                <a16:creationId xmlns:a16="http://schemas.microsoft.com/office/drawing/2014/main" id="{4E24480C-1A26-DE68-7572-77A9C84FD54B}"/>
-              </a:ext>
-            </a:extLst>
-          </p:cNvPr>
+          <p:cNvPr id="337" name="Picture 336" descr="poster_Picture5.png"/>
           <p:cNvPicPr>
             <a:picLocks noChangeAspect="1"/>
           </p:cNvPicPr>
           <p:nvPr/>
         </p:nvPicPr>
         <p:blipFill>
-          <a:blip r:embed="rId9"/>
+          <a:blip r:embed="rId5"/>
           <a:stretch>
             <a:fillRect/>
           </a:stretch>
         </p:blipFill>
         <p:spPr>
           <a:xfrm>
-            <a:off x="11249026" y="21751260"/>
-            <a:ext cx="10352856" cy="9740316"/>
+            <a:off x="22439842" y="8412480"/>
+            <a:ext cx="10240346" cy="8229600"/>
           </a:xfrm>
           <a:prstGeom prst="rect">
             <a:avLst/>
           </a:prstGeom>
         </p:spPr>
       </p:pic>
+      <p:sp>
+        <p:nvSpPr>
+          <p:cNvPr id="338" name="TextBox 337"/>
+          <p:cNvSpPr txBox="1"/>
+          <p:nvPr/>
+        </p:nvSpPr>
+        <p:spPr>
+          <a:xfrm>
+            <a:off x="22119336" y="16687800"/>
+            <a:ext cx="10881360" cy="1188720"/>
+          </a:xfrm>
+          <a:prstGeom prst="rect">
+            <a:avLst/>
+          </a:prstGeom>
+          <a:noFill/>
+        </p:spPr>
+        <p:txBody>
+          <a:bodyPr wrap="square" anchor="t">
+            <a:noAutofit/>
+          </a:bodyPr>
+          <a:lstStyle/>
+          <a:p>
+            <a:pPr algn="l"/>
+            <a:r>
+              <a:rPr sz="2200" b="1" i="0">
+                <a:solidFill>
+                  <a:srgbClr val="000000"/>
+                </a:solidFill>
+                <a:latin typeface="Times New Roman"/>
+              </a:rPr>
+              <a:t>Figure 2. U.S. Branded Food Products With and Without HFCS (N = 447,607).</a:t>
+            </a:r>
+            <a:r>
+              <a:rPr sz="2200" b="0" i="0">
+                <a:solidFill>
+                  <a:srgbClr val="000000"/>
+                </a:solidFill>
+                <a:latin typeface="Times New Roman"/>
+              </a:rPr>
+              <a:t> HFCS was listed in 29,503 products (6.6%).</a:t>
+            </a:r>
+          </a:p>
+        </p:txBody>
+      </p:sp>
       <p:pic>
         <p:nvPicPr>
-          <p:cNvPr id="10" name="Picture 9">
-            <a:extLst>
-              <a:ext uri="{FF2B5EF4-FFF2-40B4-BE49-F238E27FC236}">
-                <a16:creationId xmlns:a16="http://schemas.microsoft.com/office/drawing/2014/main" id="{72CC88BC-922D-1070-5E41-EB5F97E62717}"/>
-              </a:ext>
-            </a:extLst>
-          </p:cNvPr>
+          <p:cNvPr id="339" name="Picture 338" descr="poster_Picture11.png"/>
           <p:cNvPicPr>
             <a:picLocks noChangeAspect="1"/>
           </p:cNvPicPr>
           <p:nvPr/>
         </p:nvPicPr>
         <p:blipFill>
-          <a:blip r:embed="rId10"/>
+          <a:blip r:embed="rId6"/>
           <a:stretch>
             <a:fillRect/>
           </a:stretch>
         </p:blipFill>
         <p:spPr>
           <a:xfrm>
-            <a:off x="22354159" y="21505039"/>
-            <a:ext cx="10616215" cy="9968254"/>
+            <a:off x="12317671" y="18196560"/>
+            <a:ext cx="19694769" cy="10241280"/>
           </a:xfrm>
           <a:prstGeom prst="rect">
             <a:avLst/>
           </a:prstGeom>
         </p:spPr>
       </p:pic>
-      <p:pic>
-        <p:nvPicPr>
-          <p:cNvPr id="12" name="Picture 11">
-            <a:extLst>
-              <a:ext uri="{FF2B5EF4-FFF2-40B4-BE49-F238E27FC236}">
-                <a16:creationId xmlns:a16="http://schemas.microsoft.com/office/drawing/2014/main" id="{73FB876D-E776-1703-435E-A01333372FDC}"/>
-              </a:ext>
-            </a:extLst>
-          </p:cNvPr>
-          <p:cNvPicPr>
-            <a:picLocks noChangeAspect="1"/>
-          </p:cNvPicPr>
+      <p:sp>
+        <p:nvSpPr>
+          <p:cNvPr id="340" name="TextBox 339"/>
+          <p:cNvSpPr txBox="1"/>
           <p:nvPr/>
-        </p:nvPicPr>
-        <p:blipFill>
-          <a:blip r:embed="rId11"/>
-          <a:stretch>
-            <a:fillRect/>
-          </a:stretch>
-        </p:blipFill>
+        </p:nvSpPr>
         <p:spPr>
           <a:xfrm>
-            <a:off x="11230760" y="14134650"/>
-            <a:ext cx="21503922" cy="7134398"/>
+            <a:off x="11420856" y="28483560"/>
+            <a:ext cx="21488400" cy="914400"/>
           </a:xfrm>
           <a:prstGeom prst="rect">
             <a:avLst/>
           </a:prstGeom>
+          <a:noFill/>
         </p:spPr>
-      </p:pic>
+        <p:txBody>
+          <a:bodyPr wrap="square" anchor="t">
+            <a:noAutofit/>
+          </a:bodyPr>
+          <a:lstStyle/>
+          <a:p>
+            <a:pPr algn="l"/>
+            <a:r>
+              <a:rPr sz="2200" b="1" i="0">
+                <a:solidFill>
+                  <a:srgbClr val="000000"/>
+                </a:solidFill>
+                <a:latin typeface="Times New Roman"/>
+              </a:rPr>
+              <a:t>Figure 3. Food Categories Where HFCS Is Commonly Used.</a:t>
+            </a:r>
+            <a:r>
+              <a:rPr sz="2200" b="0" i="0">
+                <a:solidFill>
+                  <a:srgbClr val="000000"/>
+                </a:solidFill>
+                <a:latin typeface="Times New Roman"/>
+              </a:rPr>
+              <a:t> Drawn from the study background;</a:t>
+            </a:r>
+            <a:r>
+              <a:rPr sz="2200" b="0" i="0" baseline="30000">
+                <a:solidFill>
+                  <a:srgbClr val="000000"/>
+                </a:solidFill>
+                <a:latin typeface="Times New Roman"/>
+              </a:rPr>
+              <a:t>1,2</a:t>
+            </a:r>
+            <a:r>
+              <a:rPr sz="2200" b="0" i="0">
+                <a:solidFill>
+                  <a:srgbClr val="000000"/>
+                </a:solidFill>
+                <a:latin typeface="Times New Roman"/>
+              </a:rPr>
+              <a:t> category-level prevalence was not analyzed.</a:t>
+            </a:r>
+          </a:p>
+        </p:txBody>
+      </p:sp>
+      <p:sp>
+        <p:nvSpPr>
+          <p:cNvPr id="341" name="Rounded Rectangle 340"/>
+          <p:cNvSpPr/>
+          <p:nvPr/>
+        </p:nvSpPr>
+        <p:spPr>
+          <a:xfrm>
+            <a:off x="11603736" y="29672280"/>
+            <a:ext cx="21095208" cy="2103120"/>
+          </a:xfrm>
+          <a:prstGeom prst="roundRect">
+            <a:avLst>
+              <a:gd name="adj" fmla="val 12000"/>
+            </a:avLst>
+          </a:prstGeom>
+          <a:solidFill>
+            <a:srgbClr val="0A254E"/>
+          </a:solidFill>
+          <a:ln>
+            <a:noFill/>
+          </a:ln>
+        </p:spPr>
+        <p:style>
+          <a:lnRef idx="1">
+            <a:schemeClr val="accent1"/>
+          </a:lnRef>
+          <a:fillRef idx="3">
+            <a:schemeClr val="accent1"/>
+          </a:fillRef>
+          <a:effectRef idx="2">
+            <a:schemeClr val="accent1"/>
+          </a:effectRef>
+          <a:fontRef idx="minor">
+            <a:schemeClr val="lt1"/>
+          </a:fontRef>
+        </p:style>
+        <p:txBody>
+          <a:bodyPr rtlCol="0" anchor="ctr" wrap="square" lIns="365760" rIns="365760"/>
+          <a:lstStyle/>
+          <a:p>
+            <a:pPr algn="ctr"/>
+            <a:r>
+              <a:rPr sz="3200" b="1" i="0">
+                <a:solidFill>
+                  <a:srgbClr val="F2C14E"/>
+                </a:solidFill>
+                <a:latin typeface="Times New Roman"/>
+              </a:rPr>
+              <a:t>KEY TAKEAWAY  </a:t>
+            </a:r>
+            <a:r>
+              <a:rPr sz="3200" b="0" i="0">
+                <a:solidFill>
+                  <a:srgbClr val="FFFFFF"/>
+                </a:solidFill>
+                <a:latin typeface="Times New Roman"/>
+              </a:rPr>
+              <a:t>About 1 in 15 U.S. branded food products still lists high-fructose corn syrup, a reproducible baseline for tracking added sugar in the food supply.</a:t>
+            </a:r>
+          </a:p>
+        </p:txBody>
+      </p:sp>
     </p:spTree>
     <p:extLst>
       <p:ext uri="{BB962C8B-B14F-4D97-AF65-F5344CB8AC3E}">
-        <p14:creationId xmlns:p14="http://schemas.microsoft.com/office/powerpoint/2010/main" val="3247708637"/>
+        <p14:creationId xmlns:p14="http://schemas.microsoft.com/office/powerpoint/2010/main" val="1113384405"/>
       </p:ext>
     </p:extLst>
   </p:cSld>
   <p:clrMapOvr>
     <a:masterClrMapping/>
   </p:clrMapOvr>
-  <p:extLst>
-    <p:ext uri="{6950BFC3-D8DA-4A85-94F7-54DA5524770B}">
-      <p188:commentRel xmlns:p188="http://schemas.microsoft.com/office/powerpoint/2018/8/main" r:id="rId3"/>
-    </p:ext>
-  </p:extLst>
 </p:sld>
 </file>
 

</xml_diff>

<commit_message>
Add AMA reference list for the HFCS poster QR code; QR spot replaces poster reference list
Poster citations numbered 1-14 in order of first appearance; caption
citation moved inside the semicolon per AMA style.

Co-Authored-By: Claude Opus 5.5 <noreply@anthropic.com>
Claude-Session: https://claude.ai/code/session_01GDCp9vaBDB24tAeq3Z16Kb
</commit_message>
<xml_diff>
--- a/HFCS_APHA_Poster_Revised.pptx
+++ b/HFCS_APHA_Poster_Revised.pptx
@@ -8479,14 +8479,14 @@
       </p:cxnSp>
       <p:sp>
         <p:nvSpPr>
-          <p:cNvPr id="327" name="TextBox 326"/>
-          <p:cNvSpPr txBox="1"/>
+          <p:cNvPr id="327" name="QR code spot"/>
+          <p:cNvSpPr/>
           <p:nvPr/>
         </p:nvSpPr>
         <p:spPr>
           <a:xfrm>
-            <a:off x="34006536" y="28181808"/>
-            <a:ext cx="9253728" cy="4096511"/>
+            <a:off x="36768024" y="28364688"/>
+            <a:ext cx="3730751" cy="3730751"/>
           </a:xfrm>
           <a:prstGeom prst="rect">
             <a:avLst/>
@@ -8494,437 +8494,51 @@
           <a:solidFill>
             <a:srgbClr val="FFFFFF"/>
           </a:solidFill>
-          <a:ln>
+          <a:ln w="19050">
             <a:solidFill>
-              <a:srgbClr val="0A254E"/>
+              <a:srgbClr val="BFBFBF"/>
             </a:solidFill>
           </a:ln>
         </p:spPr>
-        <p:txBody>
-          <a:bodyPr wrap="square">
-            <a:noAutofit/>
-          </a:bodyPr>
+        <p:style>
+          <a:lnRef idx="1">
+            <a:schemeClr val="accent1"/>
+          </a:lnRef>
+          <a:fillRef idx="3">
+            <a:schemeClr val="accent1"/>
+          </a:fillRef>
+          <a:effectRef idx="2">
+            <a:schemeClr val="accent1"/>
+          </a:effectRef>
+          <a:fontRef idx="minor">
+            <a:schemeClr val="lt1"/>
+          </a:fontRef>
+        </p:style>
+        <p:txBody>
+          <a:bodyPr rtlCol="0" anchor="ctr" wrap="square"/>
           <a:lstStyle/>
           <a:p>
-            <a:pPr>
-              <a:spcAft>
-                <a:spcPts val="100"/>
-              </a:spcAft>
-            </a:pPr>
-            <a:r>
-              <a:rPr sz="1600" b="0" i="0">
-                <a:solidFill>
-                  <a:srgbClr val="000000"/>
-                </a:solidFill>
-                <a:latin typeface="Times New Roman"/>
-              </a:rPr>
-              <a:t>1. Wang X, et al. </a:t>
-            </a:r>
-            <a:r>
-              <a:rPr sz="1600" b="0" i="1">
-                <a:solidFill>
-                  <a:srgbClr val="000000"/>
-                </a:solidFill>
-                <a:latin typeface="Times New Roman"/>
-              </a:rPr>
-              <a:t>NPJ Sci Food</a:t>
-            </a:r>
-            <a:r>
-              <a:rPr sz="1600" b="0" i="0">
-                <a:solidFill>
-                  <a:srgbClr val="000000"/>
-                </a:solidFill>
-                <a:latin typeface="Times New Roman"/>
-              </a:rPr>
-              <a:t>. 2022;6(1):17.</a:t>
-            </a:r>
-          </a:p>
-          <a:p>
-            <a:pPr>
-              <a:spcAft>
-                <a:spcPts val="100"/>
-              </a:spcAft>
-            </a:pPr>
-            <a:r>
-              <a:rPr sz="1600" b="0" i="0">
-                <a:solidFill>
-                  <a:srgbClr val="000000"/>
-                </a:solidFill>
-                <a:latin typeface="Times New Roman"/>
-              </a:rPr>
-              <a:t>2. IndustryResearch.biz. HFCS market report [2034]. 2025.</a:t>
-            </a:r>
-          </a:p>
-          <a:p>
-            <a:pPr>
-              <a:spcAft>
-                <a:spcPts val="100"/>
-              </a:spcAft>
-            </a:pPr>
-            <a:r>
-              <a:rPr sz="1600" b="0" i="0">
-                <a:solidFill>
-                  <a:srgbClr val="000000"/>
-                </a:solidFill>
-                <a:latin typeface="Times New Roman"/>
-              </a:rPr>
-              <a:t>3. White JS. </a:t>
-            </a:r>
-            <a:r>
-              <a:rPr sz="1600" b="0" i="1">
-                <a:solidFill>
-                  <a:srgbClr val="000000"/>
-                </a:solidFill>
-                <a:latin typeface="Times New Roman"/>
-              </a:rPr>
-              <a:t>Am J Clin Nutr</a:t>
-            </a:r>
-            <a:r>
-              <a:rPr sz="1600" b="0" i="0">
-                <a:solidFill>
-                  <a:srgbClr val="000000"/>
-                </a:solidFill>
-                <a:latin typeface="Times New Roman"/>
-              </a:rPr>
-              <a:t>. 2008;88(6):1716S-1721S.</a:t>
-            </a:r>
-          </a:p>
-          <a:p>
-            <a:pPr>
-              <a:spcAft>
-                <a:spcPts val="100"/>
-              </a:spcAft>
-            </a:pPr>
-            <a:r>
-              <a:rPr sz="1600" b="0" i="0">
-                <a:solidFill>
-                  <a:srgbClr val="000000"/>
-                </a:solidFill>
-                <a:latin typeface="Times New Roman"/>
-              </a:rPr>
-              <a:t>4. Duffey KJ, Popkin BM. </a:t>
-            </a:r>
-            <a:r>
-              <a:rPr sz="1600" b="0" i="1">
-                <a:solidFill>
-                  <a:srgbClr val="000000"/>
-                </a:solidFill>
-                <a:latin typeface="Times New Roman"/>
-              </a:rPr>
-              <a:t>Am J Clin Nutr</a:t>
-            </a:r>
-            <a:r>
-              <a:rPr sz="1600" b="0" i="0">
-                <a:solidFill>
-                  <a:srgbClr val="000000"/>
-                </a:solidFill>
-                <a:latin typeface="Times New Roman"/>
-              </a:rPr>
-              <a:t>. 2008;88(6):1722S-1732S.</a:t>
-            </a:r>
-          </a:p>
-          <a:p>
-            <a:pPr>
-              <a:spcAft>
-                <a:spcPts val="100"/>
-              </a:spcAft>
-            </a:pPr>
-            <a:r>
-              <a:rPr sz="1600" b="0" i="0">
-                <a:solidFill>
-                  <a:srgbClr val="000000"/>
-                </a:solidFill>
-                <a:latin typeface="Times New Roman"/>
-              </a:rPr>
-              <a:t>5. Sigala DM, et al. </a:t>
-            </a:r>
-            <a:r>
-              <a:rPr sz="1600" b="0" i="1">
-                <a:solidFill>
-                  <a:srgbClr val="000000"/>
-                </a:solidFill>
-                <a:latin typeface="Times New Roman"/>
-              </a:rPr>
-              <a:t>J Clin Endocrinol Metab</a:t>
-            </a:r>
-            <a:r>
-              <a:rPr sz="1600" b="0" i="0">
-                <a:solidFill>
-                  <a:srgbClr val="000000"/>
-                </a:solidFill>
-                <a:latin typeface="Times New Roman"/>
-              </a:rPr>
-              <a:t>. 2021;106(11):3248-3264.</a:t>
-            </a:r>
-          </a:p>
-          <a:p>
-            <a:pPr>
-              <a:spcAft>
-                <a:spcPts val="100"/>
-              </a:spcAft>
-            </a:pPr>
-            <a:r>
-              <a:rPr sz="1600" b="0" i="0">
-                <a:solidFill>
-                  <a:srgbClr val="000000"/>
-                </a:solidFill>
-                <a:latin typeface="Times New Roman"/>
-              </a:rPr>
-              <a:t>6. DeChristopher LR. </a:t>
-            </a:r>
-            <a:r>
-              <a:rPr sz="1600" b="0" i="1">
-                <a:solidFill>
-                  <a:srgbClr val="000000"/>
-                </a:solidFill>
-                <a:latin typeface="Times New Roman"/>
-              </a:rPr>
-              <a:t>Nutr J</a:t>
-            </a:r>
-            <a:r>
-              <a:rPr sz="1600" b="0" i="0">
-                <a:solidFill>
-                  <a:srgbClr val="000000"/>
-                </a:solidFill>
-                <a:latin typeface="Times New Roman"/>
-              </a:rPr>
-              <a:t>. 2024;23(1):16.</a:t>
-            </a:r>
-          </a:p>
-          <a:p>
-            <a:pPr>
-              <a:spcAft>
-                <a:spcPts val="100"/>
-              </a:spcAft>
-            </a:pPr>
-            <a:r>
-              <a:rPr sz="1600" b="0" i="0">
-                <a:solidFill>
-                  <a:srgbClr val="000000"/>
-                </a:solidFill>
-                <a:latin typeface="Times New Roman"/>
-              </a:rPr>
-              <a:t>7. USDA, HHS. </a:t>
-            </a:r>
-            <a:r>
-              <a:rPr sz="1600" b="0" i="1">
-                <a:solidFill>
-                  <a:srgbClr val="000000"/>
-                </a:solidFill>
-                <a:latin typeface="Times New Roman"/>
-              </a:rPr>
-              <a:t>Dietary Guidelines for Americans, 2025–2030</a:t>
-            </a:r>
-            <a:r>
-              <a:rPr sz="1600" b="0" i="0">
-                <a:solidFill>
-                  <a:srgbClr val="000000"/>
-                </a:solidFill>
-                <a:latin typeface="Times New Roman"/>
-              </a:rPr>
-              <a:t>. 2026.</a:t>
-            </a:r>
-          </a:p>
-          <a:p>
-            <a:pPr>
-              <a:spcAft>
-                <a:spcPts val="100"/>
-              </a:spcAft>
-            </a:pPr>
-            <a:r>
-              <a:rPr sz="1600" b="0" i="0">
-                <a:solidFill>
-                  <a:srgbClr val="000000"/>
-                </a:solidFill>
-                <a:latin typeface="Times New Roman"/>
-              </a:rPr>
-              <a:t>8. Fukagawa NK, et al. </a:t>
-            </a:r>
-            <a:r>
-              <a:rPr sz="1600" b="0" i="1">
-                <a:solidFill>
-                  <a:srgbClr val="000000"/>
-                </a:solidFill>
-                <a:latin typeface="Times New Roman"/>
-              </a:rPr>
-              <a:t>Am J Clin Nutr</a:t>
-            </a:r>
-            <a:r>
-              <a:rPr sz="1600" b="0" i="0">
-                <a:solidFill>
-                  <a:srgbClr val="000000"/>
-                </a:solidFill>
-                <a:latin typeface="Times New Roman"/>
-              </a:rPr>
-              <a:t>. 2022;115(3):619-624.</a:t>
-            </a:r>
-          </a:p>
-          <a:p>
-            <a:pPr>
-              <a:spcAft>
-                <a:spcPts val="100"/>
-              </a:spcAft>
-            </a:pPr>
-            <a:r>
-              <a:rPr sz="1600" b="0" i="0">
-                <a:solidFill>
-                  <a:srgbClr val="000000"/>
-                </a:solidFill>
-                <a:latin typeface="Times New Roman"/>
-              </a:rPr>
-              <a:t>9. Larrick B, et al. </a:t>
-            </a:r>
-            <a:r>
-              <a:rPr sz="1600" b="0" i="1">
-                <a:solidFill>
-                  <a:srgbClr val="000000"/>
-                </a:solidFill>
-                <a:latin typeface="Times New Roman"/>
-              </a:rPr>
-              <a:t>J Food Compos Anal</a:t>
-            </a:r>
-            <a:r>
-              <a:rPr sz="1600" b="0" i="0">
-                <a:solidFill>
-                  <a:srgbClr val="000000"/>
-                </a:solidFill>
-                <a:latin typeface="Times New Roman"/>
-              </a:rPr>
-              <a:t>. 2022;105:104250.</a:t>
-            </a:r>
-          </a:p>
-          <a:p>
-            <a:pPr>
-              <a:spcAft>
-                <a:spcPts val="100"/>
-              </a:spcAft>
-            </a:pPr>
-            <a:r>
-              <a:rPr sz="1600" b="0" i="0">
-                <a:solidFill>
-                  <a:srgbClr val="000000"/>
-                </a:solidFill>
-                <a:latin typeface="Times New Roman"/>
-              </a:rPr>
-              <a:t>10. USDA Economic Research Service. HFCS availability peaked in 1999. 2013.</a:t>
-            </a:r>
-          </a:p>
-          <a:p>
-            <a:pPr>
-              <a:spcAft>
-                <a:spcPts val="100"/>
-              </a:spcAft>
-            </a:pPr>
-            <a:r>
-              <a:rPr sz="1600" b="0" i="0">
-                <a:solidFill>
-                  <a:srgbClr val="000000"/>
-                </a:solidFill>
-                <a:latin typeface="Times New Roman"/>
-              </a:rPr>
-              <a:t>11. Martínez Steele E, et al. </a:t>
-            </a:r>
-            <a:r>
-              <a:rPr sz="1600" b="0" i="1">
-                <a:solidFill>
-                  <a:srgbClr val="000000"/>
-                </a:solidFill>
-                <a:latin typeface="Times New Roman"/>
-              </a:rPr>
-              <a:t>BMJ Open</a:t>
-            </a:r>
-            <a:r>
-              <a:rPr sz="1600" b="0" i="0">
-                <a:solidFill>
-                  <a:srgbClr val="000000"/>
-                </a:solidFill>
-                <a:latin typeface="Times New Roman"/>
-              </a:rPr>
-              <a:t>. 2016;6(3):e009892.</a:t>
-            </a:r>
-          </a:p>
-          <a:p>
-            <a:pPr>
-              <a:spcAft>
-                <a:spcPts val="100"/>
-              </a:spcAft>
-            </a:pPr>
-            <a:r>
-              <a:rPr sz="1600" b="0" i="0">
-                <a:solidFill>
-                  <a:srgbClr val="000000"/>
-                </a:solidFill>
-                <a:latin typeface="Times New Roman"/>
-              </a:rPr>
-              <a:t>12. Nguyen M, et al. </a:t>
-            </a:r>
-            <a:r>
-              <a:rPr sz="1600" b="0" i="1">
-                <a:solidFill>
-                  <a:srgbClr val="000000"/>
-                </a:solidFill>
-                <a:latin typeface="Times New Roman"/>
-              </a:rPr>
-              <a:t>Am J Clin Nutr</a:t>
-            </a:r>
-            <a:r>
-              <a:rPr sz="1600" b="0" i="0">
-                <a:solidFill>
-                  <a:srgbClr val="000000"/>
-                </a:solidFill>
-                <a:latin typeface="Times New Roman"/>
-              </a:rPr>
-              <a:t>. 2023;117(1):160-174.</a:t>
-            </a:r>
-          </a:p>
-          <a:p>
-            <a:pPr>
-              <a:spcAft>
-                <a:spcPts val="100"/>
-              </a:spcAft>
-            </a:pPr>
-            <a:r>
-              <a:rPr sz="1600" b="0" i="0">
-                <a:solidFill>
-                  <a:srgbClr val="000000"/>
-                </a:solidFill>
-                <a:latin typeface="Times New Roman"/>
-              </a:rPr>
-              <a:t>13. Li X, et al. </a:t>
-            </a:r>
-            <a:r>
-              <a:rPr sz="1600" b="0" i="1">
-                <a:solidFill>
-                  <a:srgbClr val="000000"/>
-                </a:solidFill>
-                <a:latin typeface="Times New Roman"/>
-              </a:rPr>
-              <a:t>Front Nutr</a:t>
-            </a:r>
-            <a:r>
-              <a:rPr sz="1600" b="0" i="0">
-                <a:solidFill>
-                  <a:srgbClr val="000000"/>
-                </a:solidFill>
-                <a:latin typeface="Times New Roman"/>
-              </a:rPr>
-              <a:t>. 2022;9:1013310.</a:t>
-            </a:r>
-          </a:p>
-          <a:p>
-            <a:pPr>
-              <a:spcAft>
-                <a:spcPts val="100"/>
-              </a:spcAft>
-            </a:pPr>
-            <a:r>
-              <a:rPr sz="1600" b="0" i="0">
-                <a:solidFill>
-                  <a:srgbClr val="000000"/>
-                </a:solidFill>
-                <a:latin typeface="Times New Roman"/>
-              </a:rPr>
-              <a:t>14. FDA. Added sugars on the Nutrition Facts label. 2024.</a:t>
+            <a:pPr algn="ctr"/>
+            <a:r>
+              <a:rPr sz="2800" b="0" i="0">
+                <a:solidFill>
+                  <a:srgbClr val="595959"/>
+                </a:solidFill>
+                <a:latin typeface="Times New Roman"/>
+              </a:rPr>
+              <a:t>Paste QR code here</a:t>
+            </a:r>
+          </a:p>
+          <a:p>
+            <a:pPr algn="ctr"/>
+            <a:r>
+              <a:rPr sz="1800" b="0" i="0">
+                <a:solidFill>
+                  <a:srgbClr val="595959"/>
+                </a:solidFill>
+                <a:latin typeface="Times New Roman"/>
+              </a:rPr>
+              <a:t>(4.1 × 4.1 in; links to the full AMA reference list)</a:t>
             </a:r>
           </a:p>
         </p:txBody>
@@ -9469,7 +9083,7 @@
                 </a:solidFill>
                 <a:latin typeface="Times New Roman"/>
               </a:rPr>
-              <a:t> Drawn from the study background;</a:t>
+              <a:t> Drawn from the study background</a:t>
             </a:r>
             <a:r>
               <a:rPr sz="2200" b="0" i="0" baseline="30000">
@@ -9487,7 +9101,7 @@
                 </a:solidFill>
                 <a:latin typeface="Times New Roman"/>
               </a:rPr>
-              <a:t> category-level prevalence was not analyzed.</a:t>
+              <a:t>; category-level prevalence was not analyzed.</a:t>
             </a:r>
           </a:p>
         </p:txBody>

</xml_diff>

<commit_message>
HFCS poster: add fructose-content and ERS availability figures, public health context tiles, fuller discussion; update AMA reference list
Co-Authored-By: Claude Opus 5.5 <noreply@anthropic.com>
Claude-Session: https://claude.ai/code/session_01GDCp9vaBDB24tAeq3Z16Kb
</commit_message>
<xml_diff>
--- a/HFCS_APHA_Poster_Revised.pptx
+++ b/HFCS_APHA_Poster_Revised.pptx
@@ -7361,8 +7361,8 @@
         </p:nvSpPr>
         <p:spPr>
           <a:xfrm>
-            <a:off x="34006536" y="21369528"/>
-            <a:ext cx="9253728" cy="5669280"/>
+            <a:off x="34006536" y="20729448"/>
+            <a:ext cx="9253728" cy="6126480"/>
           </a:xfrm>
           <a:prstGeom prst="rect">
             <a:avLst/>
@@ -7391,7 +7391,7 @@
               </a:spcAft>
             </a:pPr>
             <a:r>
-              <a:rPr sz="2500" b="1" i="0">
+              <a:rPr sz="2400" b="1" i="0">
                 <a:solidFill>
                   <a:srgbClr val="000000"/>
                 </a:solidFill>
@@ -7410,7 +7410,7 @@
               </a:spcAft>
             </a:pPr>
             <a:r>
-              <a:rPr sz="2500" b="0" i="0">
+              <a:rPr sz="2400" b="0" i="0">
                 <a:solidFill>
                   <a:srgbClr val="000000"/>
                 </a:solidFill>
@@ -7429,7 +7429,7 @@
               </a:spcAft>
             </a:pPr>
             <a:r>
-              <a:rPr sz="2500" b="0" i="0">
+              <a:rPr sz="2400" b="0" i="0">
                 <a:solidFill>
                   <a:srgbClr val="000000"/>
                 </a:solidFill>
@@ -7448,7 +7448,45 @@
               </a:spcAft>
             </a:pPr>
             <a:r>
-              <a:rPr sz="2500" b="0" i="0">
+              <a:rPr sz="2400" b="0" i="0">
+                <a:solidFill>
+                  <a:srgbClr val="000000"/>
+                </a:solidFill>
+                <a:latin typeface="Times New Roman"/>
+              </a:rPr>
+              <a:t>• Inform procurement standards in food service and child nutrition programs</a:t>
+            </a:r>
+          </a:p>
+          <a:p>
+            <a:pPr algn="l" marL="274320" indent="-274320">
+              <a:lnSpc>
+                <a:spcPct val="100000"/>
+              </a:lnSpc>
+              <a:spcAft>
+                <a:spcPts val="300"/>
+              </a:spcAft>
+            </a:pPr>
+            <a:r>
+              <a:rPr sz="2400" b="0" i="0">
+                <a:solidFill>
+                  <a:srgbClr val="000000"/>
+                </a:solidFill>
+                <a:latin typeface="Times New Roman"/>
+              </a:rPr>
+              <a:t>• Support consumer education on reading ingredient lists</a:t>
+            </a:r>
+          </a:p>
+          <a:p>
+            <a:pPr algn="l" marL="274320" indent="-274320">
+              <a:lnSpc>
+                <a:spcPct val="100000"/>
+              </a:lnSpc>
+              <a:spcAft>
+                <a:spcPts val="300"/>
+              </a:spcAft>
+            </a:pPr>
+            <a:r>
+              <a:rPr sz="2400" b="0" i="0">
                 <a:solidFill>
                   <a:srgbClr val="000000"/>
                 </a:solidFill>
@@ -7457,7 +7495,7 @@
               <a:t>• Align monitoring with the 2025–2030 Dietary Guidelines</a:t>
             </a:r>
             <a:r>
-              <a:rPr sz="2500" b="0" i="0" baseline="30000">
+              <a:rPr sz="2400" b="0" i="0" baseline="30000">
                 <a:solidFill>
                   <a:srgbClr val="000000"/>
                 </a:solidFill>
@@ -7466,7 +7504,7 @@
               <a:t>7</a:t>
             </a:r>
             <a:r>
-              <a:rPr sz="2500" b="0" i="0">
+              <a:rPr sz="2400" b="0" i="0">
                 <a:solidFill>
                   <a:srgbClr val="000000"/>
                 </a:solidFill>
@@ -7475,7 +7513,7 @@
               <a:t> and added-sugar labeling</a:t>
             </a:r>
             <a:r>
-              <a:rPr sz="2500" b="0" i="0" baseline="30000">
+              <a:rPr sz="2400" b="0" i="0" baseline="30000">
                 <a:solidFill>
                   <a:srgbClr val="000000"/>
                 </a:solidFill>
@@ -7494,7 +7532,7 @@
               </a:spcAft>
             </a:pPr>
             <a:r>
-              <a:rPr sz="2500" b="1" i="0">
+              <a:rPr sz="2400" b="1" i="0">
                 <a:solidFill>
                   <a:srgbClr val="000000"/>
                 </a:solidFill>
@@ -7513,7 +7551,7 @@
               </a:spcAft>
             </a:pPr>
             <a:r>
-              <a:rPr sz="2500" b="0" i="0">
+              <a:rPr sz="2400" b="0" i="0">
                 <a:solidFill>
                   <a:srgbClr val="000000"/>
                 </a:solidFill>
@@ -7532,7 +7570,7 @@
               </a:spcAft>
             </a:pPr>
             <a:r>
-              <a:rPr sz="2500" b="0" i="0">
+              <a:rPr sz="2400" b="0" i="0">
                 <a:solidFill>
                   <a:srgbClr val="000000"/>
                 </a:solidFill>
@@ -7551,7 +7589,26 @@
               </a:spcAft>
             </a:pPr>
             <a:r>
-              <a:rPr sz="2500" b="0" i="0">
+              <a:rPr sz="2400" b="0" i="0">
+                <a:solidFill>
+                  <a:srgbClr val="000000"/>
+                </a:solidFill>
+                <a:latin typeface="Times New Roman"/>
+              </a:rPr>
+              <a:t>• Compare HFCS with other added sugars in the same database</a:t>
+            </a:r>
+          </a:p>
+          <a:p>
+            <a:pPr algn="l" marL="274320" indent="-274320">
+              <a:lnSpc>
+                <a:spcPct val="100000"/>
+              </a:lnSpc>
+              <a:spcAft>
+                <a:spcPts val="300"/>
+              </a:spcAft>
+            </a:pPr>
+            <a:r>
+              <a:rPr sz="2400" b="0" i="0">
                 <a:solidFill>
                   <a:srgbClr val="000000"/>
                 </a:solidFill>
@@ -7576,7 +7633,7 @@
         </p:nvSpPr>
         <p:spPr>
           <a:xfrm>
-            <a:off x="34006536" y="19997928"/>
+            <a:off x="34006536" y="19357848"/>
             <a:ext cx="9253728" cy="1371600"/>
           </a:xfrm>
           <a:prstGeom prst="rect">
@@ -7626,7 +7683,7 @@
         </p:nvSpPr>
         <p:spPr>
           <a:xfrm>
-            <a:off x="34006536" y="27313128"/>
+            <a:off x="34006536" y="27130248"/>
             <a:ext cx="9253728" cy="868680"/>
           </a:xfrm>
           <a:prstGeom prst="rect">
@@ -7677,7 +7734,7 @@
         <p:spPr>
           <a:xfrm>
             <a:off x="34006536" y="5458968"/>
-            <a:ext cx="9253728" cy="14264640"/>
+            <a:ext cx="9253728" cy="13624560"/>
           </a:xfrm>
           <a:prstGeom prst="rect">
             <a:avLst/>
@@ -7706,7 +7763,7 @@
               </a:spcAft>
             </a:pPr>
             <a:r>
-              <a:rPr sz="2600" b="1" i="0">
+              <a:rPr sz="2500" b="1" i="0">
                 <a:solidFill>
                   <a:srgbClr val="000000"/>
                 </a:solidFill>
@@ -7729,7 +7786,7 @@
               </a:spcAft>
             </a:pPr>
             <a:r>
-              <a:rPr sz="2600" b="0" i="0">
+              <a:rPr sz="2500" b="0" i="0">
                 <a:solidFill>
                   <a:srgbClr val="000000"/>
                 </a:solidFill>
@@ -7738,7 +7795,7 @@
               <a:t>Of 454,324 products identified, 6,717 were excluded, leaving 447,607 eligible U.S. branded products (Figure 1). HFCS was listed in </a:t>
             </a:r>
             <a:r>
-              <a:rPr sz="2600" b="1" i="0">
+              <a:rPr sz="2500" b="1" i="0">
                 <a:solidFill>
                   <a:srgbClr val="000000"/>
                 </a:solidFill>
@@ -7747,13 +7804,13 @@
               <a:t>29,503 products (6.6%)</a:t>
             </a:r>
             <a:r>
-              <a:rPr sz="2600" b="0" i="0">
-                <a:solidFill>
-                  <a:srgbClr val="000000"/>
-                </a:solidFill>
-                <a:latin typeface="Times New Roman"/>
-              </a:rPr>
-              <a:t>, about 1 in every 15; 418,104 (93.4%) did not list HFCS (Figure 2).</a:t>
+              <a:rPr sz="2500" b="0" i="0">
+                <a:solidFill>
+                  <a:srgbClr val="000000"/>
+                </a:solidFill>
+                <a:latin typeface="Times New Roman"/>
+              </a:rPr>
+              <a:t>, about 1 in every 15; 418,104 (93.4%) did not list HFCS (Figure 2). Excluded records made up 1.5% of all products identified.</a:t>
             </a:r>
           </a:p>
           <a:p>
@@ -7766,7 +7823,7 @@
               </a:spcAft>
             </a:pPr>
             <a:r>
-              <a:rPr sz="2600" b="1" i="0">
+              <a:rPr sz="2500" b="1" i="0">
                 <a:solidFill>
                   <a:srgbClr val="000000"/>
                 </a:solidFill>
@@ -7785,16 +7842,34 @@
               </a:spcAft>
             </a:pPr>
             <a:r>
-              <a:rPr sz="2600" b="0" i="0">
-                <a:solidFill>
-                  <a:srgbClr val="000000"/>
-                </a:solidFill>
-                <a:latin typeface="Times New Roman"/>
-              </a:rPr>
-              <a:t>HFCS appeared in a minority of products, yet its presence in nearly 30,000 items shows it remains embedded in the U.S. food supply. A 6.6% product share is not low exposure: counts are not sales-weighted, and HFCS may cluster in high-consumption foods such as sweetened beverages, desserts, and condiments (Figure 3). HFCS availability peaked in 1999 and has declined since.</a:t>
-            </a:r>
-            <a:r>
-              <a:rPr sz="2600" b="0" i="0" baseline="30000">
+              <a:rPr sz="2500" b="0" i="0">
+                <a:solidFill>
+                  <a:srgbClr val="000000"/>
+                </a:solidFill>
+                <a:latin typeface="Times New Roman"/>
+              </a:rPr>
+              <a:t>HFCS appeared in a minority of products, yet its presence in nearly 30,000 items shows it remains embedded in the U.S. food supply. A 6.6% product share is not low exposure: counts are not sales-weighted, and HFCS may cluster in high-consumption foods such as sweetened beverages, desserts, and condiments (Figure 3). HFCS use grew rapidly after the 1970s,</a:t>
+            </a:r>
+            <a:r>
+              <a:rPr sz="2500" b="0" i="0" baseline="30000">
+                <a:solidFill>
+                  <a:srgbClr val="000000"/>
+                </a:solidFill>
+                <a:latin typeface="Times New Roman"/>
+              </a:rPr>
+              <a:t>4</a:t>
+            </a:r>
+            <a:r>
+              <a:rPr sz="2500" b="0" i="0">
+                <a:solidFill>
+                  <a:srgbClr val="000000"/>
+                </a:solidFill>
+                <a:latin typeface="Times New Roman"/>
+              </a:rPr>
+              <a:t> and although per capita corn sweetener availability has fallen 38% since its 1999 peak (Figure 5),</a:t>
+            </a:r>
+            <a:r>
+              <a:rPr sz="2500" b="0" i="0" baseline="30000">
                 <a:solidFill>
                   <a:srgbClr val="000000"/>
                 </a:solidFill>
@@ -7803,16 +7878,16 @@
               <a:t>10</a:t>
             </a:r>
             <a:r>
-              <a:rPr sz="2600" b="0" i="0">
-                <a:solidFill>
-                  <a:srgbClr val="000000"/>
-                </a:solidFill>
-                <a:latin typeface="Times New Roman"/>
-              </a:rPr>
-              <a:t> Ultra-processed foods supply most added sugar in the U.S. diet,</a:t>
-            </a:r>
-            <a:r>
-              <a:rPr sz="2600" b="0" i="0" baseline="30000">
+              <a:rPr sz="2500" b="0" i="0">
+                <a:solidFill>
+                  <a:srgbClr val="000000"/>
+                </a:solidFill>
+                <a:latin typeface="Times New Roman"/>
+              </a:rPr>
+              <a:t> HFCS remains common. Ultra-processed foods supply 89.7% of energy from added sugars in the U.S. diet,</a:t>
+            </a:r>
+            <a:r>
+              <a:rPr sz="2500" b="0" i="0" baseline="30000">
                 <a:solidFill>
                   <a:srgbClr val="000000"/>
                 </a:solidFill>
@@ -7821,7 +7896,7 @@
               <a:t>11</a:t>
             </a:r>
             <a:r>
-              <a:rPr sz="2600" b="0" i="0">
+              <a:rPr sz="2500" b="0" i="0">
                 <a:solidFill>
                   <a:srgbClr val="000000"/>
                 </a:solidFill>
@@ -7830,7 +7905,7 @@
               <a:t> and sugar-sweetened beverages are linked to weight gain in children and adults.</a:t>
             </a:r>
             <a:r>
-              <a:rPr sz="2600" b="0" i="0" baseline="30000">
+              <a:rPr sz="2500" b="0" i="0" baseline="30000">
                 <a:solidFill>
                   <a:srgbClr val="000000"/>
                 </a:solidFill>
@@ -7839,7 +7914,7 @@
               <a:t>12</a:t>
             </a:r>
             <a:r>
-              <a:rPr sz="2600" b="0" i="0">
+              <a:rPr sz="2500" b="0" i="0">
                 <a:solidFill>
                   <a:srgbClr val="000000"/>
                 </a:solidFill>
@@ -7848,7 +7923,7 @@
               <a:t> HFCS and sucrose have similar metabolic effects at equal intake,</a:t>
             </a:r>
             <a:r>
-              <a:rPr sz="2600" b="0" i="0" baseline="30000">
+              <a:rPr sz="2500" b="0" i="0" baseline="30000">
                 <a:solidFill>
                   <a:srgbClr val="000000"/>
                 </a:solidFill>
@@ -7857,7 +7932,7 @@
               <a:t>13</a:t>
             </a:r>
             <a:r>
-              <a:rPr sz="2600" b="0" i="0">
+              <a:rPr sz="2500" b="0" i="0">
                 <a:solidFill>
                   <a:srgbClr val="000000"/>
                 </a:solidFill>
@@ -7876,7 +7951,7 @@
               </a:spcAft>
             </a:pPr>
             <a:r>
-              <a:rPr sz="2600" b="1" i="0">
+              <a:rPr sz="2500" b="1" i="0">
                 <a:solidFill>
                   <a:srgbClr val="000000"/>
                 </a:solidFill>
@@ -7895,7 +7970,7 @@
               </a:spcAft>
             </a:pPr>
             <a:r>
-              <a:rPr sz="2600" b="0" i="0">
+              <a:rPr sz="2500" b="0" i="0">
                 <a:solidFill>
                   <a:srgbClr val="000000"/>
                 </a:solidFill>
@@ -7914,7 +7989,7 @@
               </a:spcAft>
             </a:pPr>
             <a:r>
-              <a:rPr sz="2600" b="1" i="0">
+              <a:rPr sz="2500" b="1" i="0">
                 <a:solidFill>
                   <a:srgbClr val="000000"/>
                 </a:solidFill>
@@ -7933,7 +8008,7 @@
               </a:spcAft>
             </a:pPr>
             <a:r>
-              <a:rPr sz="2600" b="0" i="0">
+              <a:rPr sz="2500" b="0" i="0">
                 <a:solidFill>
                   <a:srgbClr val="000000"/>
                 </a:solidFill>
@@ -7942,7 +8017,7 @@
               <a:t>• </a:t>
             </a:r>
             <a:r>
-              <a:rPr sz="2600" b="1" i="0">
+              <a:rPr sz="2500" b="1" i="0">
                 <a:solidFill>
                   <a:srgbClr val="000000"/>
                 </a:solidFill>
@@ -7951,7 +8026,7 @@
               <a:t>Presence only:</a:t>
             </a:r>
             <a:r>
-              <a:rPr sz="2600" b="0" i="0">
+              <a:rPr sz="2500" b="0" i="0">
                 <a:solidFill>
                   <a:srgbClr val="000000"/>
                 </a:solidFill>
@@ -7970,7 +8045,7 @@
               </a:spcAft>
             </a:pPr>
             <a:r>
-              <a:rPr sz="2600" b="0" i="0">
+              <a:rPr sz="2500" b="0" i="0">
                 <a:solidFill>
                   <a:srgbClr val="000000"/>
                 </a:solidFill>
@@ -7979,7 +8054,7 @@
               <a:t>• </a:t>
             </a:r>
             <a:r>
-              <a:rPr sz="2600" b="1" i="0">
+              <a:rPr sz="2500" b="1" i="0">
                 <a:solidFill>
                   <a:srgbClr val="000000"/>
                 </a:solidFill>
@@ -7988,7 +8063,7 @@
               <a:t>Industry-supplied data:</a:t>
             </a:r>
             <a:r>
-              <a:rPr sz="2600" b="0" i="0">
+              <a:rPr sz="2500" b="0" i="0">
                 <a:solidFill>
                   <a:srgbClr val="000000"/>
                 </a:solidFill>
@@ -8007,7 +8082,7 @@
               </a:spcAft>
             </a:pPr>
             <a:r>
-              <a:rPr sz="2600" b="0" i="0">
+              <a:rPr sz="2500" b="0" i="0">
                 <a:solidFill>
                   <a:srgbClr val="000000"/>
                 </a:solidFill>
@@ -8016,7 +8091,7 @@
               <a:t>• </a:t>
             </a:r>
             <a:r>
-              <a:rPr sz="2600" b="1" i="0">
+              <a:rPr sz="2500" b="1" i="0">
                 <a:solidFill>
                   <a:srgbClr val="000000"/>
                 </a:solidFill>
@@ -8025,7 +8100,7 @@
               <a:t>Search terms:</a:t>
             </a:r>
             <a:r>
-              <a:rPr sz="2600" b="0" i="0">
+              <a:rPr sz="2500" b="0" i="0">
                 <a:solidFill>
                   <a:srgbClr val="000000"/>
                 </a:solidFill>
@@ -8044,7 +8119,7 @@
               </a:spcAft>
             </a:pPr>
             <a:r>
-              <a:rPr sz="2600" b="0" i="0">
+              <a:rPr sz="2500" b="0" i="0">
                 <a:solidFill>
                   <a:srgbClr val="000000"/>
                 </a:solidFill>
@@ -8053,7 +8128,7 @@
               <a:t>• </a:t>
             </a:r>
             <a:r>
-              <a:rPr sz="2600" b="1" i="0">
+              <a:rPr sz="2500" b="1" i="0">
                 <a:solidFill>
                   <a:srgbClr val="000000"/>
                 </a:solidFill>
@@ -8062,7 +8137,7 @@
               <a:t>Item-level records:</a:t>
             </a:r>
             <a:r>
-              <a:rPr sz="2600" b="0" i="0">
+              <a:rPr sz="2500" b="0" i="0">
                 <a:solidFill>
                   <a:srgbClr val="000000"/>
                 </a:solidFill>
@@ -8485,8 +8560,8 @@
         </p:nvSpPr>
         <p:spPr>
           <a:xfrm>
-            <a:off x="36768024" y="28364688"/>
-            <a:ext cx="3730751" cy="3730751"/>
+            <a:off x="36676584" y="28181808"/>
+            <a:ext cx="3913631" cy="3913631"/>
           </a:xfrm>
           <a:prstGeom prst="rect">
             <a:avLst/>
@@ -8538,7 +8613,7 @@
                 </a:solidFill>
                 <a:latin typeface="Times New Roman"/>
               </a:rPr>
-              <a:t>(4.1 × 4.1 in; links to the full AMA reference list)</a:t>
+              <a:t>(4.3 × 4.3 in; links to the full AMA reference list)</a:t>
             </a:r>
           </a:p>
         </p:txBody>
@@ -8900,8 +8975,8 @@
         </p:blipFill>
         <p:spPr>
           <a:xfrm>
-            <a:off x="11237976" y="8465635"/>
-            <a:ext cx="10424160" cy="8123288"/>
+            <a:off x="12284504" y="8183879"/>
+            <a:ext cx="8683146" cy="6766560"/>
           </a:xfrm>
           <a:prstGeom prst="rect">
             <a:avLst/>
@@ -8916,8 +8991,8 @@
         </p:nvSpPr>
         <p:spPr>
           <a:xfrm>
-            <a:off x="11237976" y="16687800"/>
-            <a:ext cx="10424160" cy="1188720"/>
+            <a:off x="11237976" y="14996159"/>
+            <a:ext cx="10776204" cy="1097280"/>
           </a:xfrm>
           <a:prstGeom prst="rect">
             <a:avLst/>
@@ -8968,8 +9043,8 @@
         </p:blipFill>
         <p:spPr>
           <a:xfrm>
-            <a:off x="22439842" y="8412480"/>
-            <a:ext cx="10240346" cy="8229600"/>
+            <a:off x="23466681" y="8183879"/>
+            <a:ext cx="8419840" cy="6766560"/>
           </a:xfrm>
           <a:prstGeom prst="rect">
             <a:avLst/>
@@ -8984,8 +9059,8 @@
         </p:nvSpPr>
         <p:spPr>
           <a:xfrm>
-            <a:off x="22119336" y="16687800"/>
-            <a:ext cx="10881360" cy="1188720"/>
+            <a:off x="22288500" y="14996159"/>
+            <a:ext cx="10776204" cy="1097280"/>
           </a:xfrm>
           <a:prstGeom prst="rect">
             <a:avLst/>
@@ -9036,8 +9111,8 @@
         </p:blipFill>
         <p:spPr>
           <a:xfrm>
-            <a:off x="12317671" y="18196560"/>
-            <a:ext cx="19694769" cy="10241280"/>
+            <a:off x="11350693" y="16367759"/>
+            <a:ext cx="10550769" cy="5486400"/>
           </a:xfrm>
           <a:prstGeom prst="rect">
             <a:avLst/>
@@ -9052,8 +9127,8 @@
         </p:nvSpPr>
         <p:spPr>
           <a:xfrm>
-            <a:off x="11420856" y="28483560"/>
-            <a:ext cx="21488400" cy="914400"/>
+            <a:off x="11237976" y="21899880"/>
+            <a:ext cx="10776204" cy="1097280"/>
           </a:xfrm>
           <a:prstGeom prst="rect">
             <a:avLst/>
@@ -9106,27 +9181,218 @@
           </a:p>
         </p:txBody>
       </p:sp>
-      <p:sp>
-        <p:nvSpPr>
-          <p:cNvPr id="341" name="Rounded Rectangle 340"/>
+      <p:pic>
+        <p:nvPicPr>
+          <p:cNvPr id="341" name="Picture 340" descr="fig4_fructose.png"/>
+          <p:cNvPicPr>
+            <a:picLocks noChangeAspect="1"/>
+          </p:cNvPicPr>
+          <p:nvPr/>
+        </p:nvPicPr>
+        <p:blipFill>
+          <a:blip r:embed="rId7"/>
+          <a:stretch>
+            <a:fillRect/>
+          </a:stretch>
+        </p:blipFill>
+        <p:spPr>
+          <a:xfrm>
+            <a:off x="22288500" y="16367926"/>
+            <a:ext cx="10776204" cy="5486067"/>
+          </a:xfrm>
+          <a:prstGeom prst="rect">
+            <a:avLst/>
+          </a:prstGeom>
+        </p:spPr>
+      </p:pic>
+      <p:sp>
+        <p:nvSpPr>
+          <p:cNvPr id="342" name="TextBox 341"/>
+          <p:cNvSpPr txBox="1"/>
+          <p:nvPr/>
+        </p:nvSpPr>
+        <p:spPr>
+          <a:xfrm>
+            <a:off x="22288500" y="21899880"/>
+            <a:ext cx="10776204" cy="1097280"/>
+          </a:xfrm>
+          <a:prstGeom prst="rect">
+            <a:avLst/>
+          </a:prstGeom>
+          <a:noFill/>
+        </p:spPr>
+        <p:txBody>
+          <a:bodyPr wrap="square" anchor="t">
+            <a:noAutofit/>
+          </a:bodyPr>
+          <a:lstStyle/>
+          <a:p>
+            <a:pPr algn="l"/>
+            <a:r>
+              <a:rPr sz="2200" b="1" i="0">
+                <a:solidFill>
+                  <a:srgbClr val="000000"/>
+                </a:solidFill>
+                <a:latin typeface="Times New Roman"/>
+              </a:rPr>
+              <a:t>Figure 4. Fructose Content of HFCS and Sucrose.</a:t>
+            </a:r>
+            <a:r>
+              <a:rPr sz="2200" b="0" i="0">
+                <a:solidFill>
+                  <a:srgbClr val="000000"/>
+                </a:solidFill>
+                <a:latin typeface="Times New Roman"/>
+              </a:rPr>
+              <a:t> HFCS-42 and HFCS-55 bracket the 50% fructose of table sugar.</a:t>
+            </a:r>
+            <a:r>
+              <a:rPr sz="2200" b="0" i="0" baseline="30000">
+                <a:solidFill>
+                  <a:srgbClr val="000000"/>
+                </a:solidFill>
+                <a:latin typeface="Times New Roman"/>
+              </a:rPr>
+              <a:t>3</a:t>
+            </a:r>
+          </a:p>
+        </p:txBody>
+      </p:sp>
+      <p:pic>
+        <p:nvPicPr>
+          <p:cNvPr id="343" name="Picture 342" descr="fig5_ers.png"/>
+          <p:cNvPicPr>
+            <a:picLocks noChangeAspect="1"/>
+          </p:cNvPicPr>
+          <p:nvPr/>
+        </p:nvPicPr>
+        <p:blipFill>
+          <a:blip r:embed="rId8"/>
+          <a:stretch>
+            <a:fillRect/>
+          </a:stretch>
+        </p:blipFill>
+        <p:spPr>
+          <a:xfrm>
+            <a:off x="11596878" y="23271480"/>
+            <a:ext cx="10058400" cy="5120640"/>
+          </a:xfrm>
+          <a:prstGeom prst="rect">
+            <a:avLst/>
+          </a:prstGeom>
+        </p:spPr>
+      </p:pic>
+      <p:sp>
+        <p:nvSpPr>
+          <p:cNvPr id="344" name="TextBox 343"/>
+          <p:cNvSpPr txBox="1"/>
+          <p:nvPr/>
+        </p:nvSpPr>
+        <p:spPr>
+          <a:xfrm>
+            <a:off x="11237976" y="28437840"/>
+            <a:ext cx="10776204" cy="1097280"/>
+          </a:xfrm>
+          <a:prstGeom prst="rect">
+            <a:avLst/>
+          </a:prstGeom>
+          <a:noFill/>
+        </p:spPr>
+        <p:txBody>
+          <a:bodyPr wrap="square" anchor="t">
+            <a:noAutofit/>
+          </a:bodyPr>
+          <a:lstStyle/>
+          <a:p>
+            <a:pPr algn="l"/>
+            <a:r>
+              <a:rPr sz="2200" b="1" i="0">
+                <a:solidFill>
+                  <a:srgbClr val="000000"/>
+                </a:solidFill>
+                <a:latin typeface="Times New Roman"/>
+              </a:rPr>
+              <a:t>Figure 5. U.S. Per Capita Sweetener Availability, 1999 vs 2023.</a:t>
+            </a:r>
+            <a:r>
+              <a:rPr sz="2200" b="0" i="0">
+                <a:solidFill>
+                  <a:srgbClr val="000000"/>
+                </a:solidFill>
+                <a:latin typeface="Times New Roman"/>
+              </a:rPr>
+              <a:t> USDA Economic Research Service data; corn sweeteners include HFCS, glucose syrup, and dextrose.</a:t>
+            </a:r>
+            <a:r>
+              <a:rPr sz="2200" b="0" i="0" baseline="30000">
+                <a:solidFill>
+                  <a:srgbClr val="000000"/>
+                </a:solidFill>
+                <a:latin typeface="Times New Roman"/>
+              </a:rPr>
+              <a:t>10</a:t>
+            </a:r>
+          </a:p>
+        </p:txBody>
+      </p:sp>
+      <p:sp>
+        <p:nvSpPr>
+          <p:cNvPr id="345" name="TextBox 344"/>
+          <p:cNvSpPr txBox="1"/>
+          <p:nvPr/>
+        </p:nvSpPr>
+        <p:spPr>
+          <a:xfrm>
+            <a:off x="22288500" y="23134320"/>
+            <a:ext cx="10776204" cy="640080"/>
+          </a:xfrm>
+          <a:prstGeom prst="rect">
+            <a:avLst/>
+          </a:prstGeom>
+          <a:noFill/>
+        </p:spPr>
+        <p:txBody>
+          <a:bodyPr wrap="square" anchor="t">
+            <a:noAutofit/>
+          </a:bodyPr>
+          <a:lstStyle/>
+          <a:p>
+            <a:pPr algn="ctr"/>
+            <a:r>
+              <a:rPr sz="3000" b="1" i="0">
+                <a:solidFill>
+                  <a:srgbClr val="0A254E"/>
+                </a:solidFill>
+                <a:latin typeface="Times New Roman"/>
+              </a:rPr>
+              <a:t>Public Health Context</a:t>
+            </a:r>
+          </a:p>
+        </p:txBody>
+      </p:sp>
+      <p:sp>
+        <p:nvSpPr>
+          <p:cNvPr id="346" name="Rounded Rectangle 345"/>
           <p:cNvSpPr/>
           <p:nvPr/>
         </p:nvSpPr>
         <p:spPr>
           <a:xfrm>
-            <a:off x="11603736" y="29672280"/>
-            <a:ext cx="21095208" cy="2103120"/>
+            <a:off x="22288500" y="23865840"/>
+            <a:ext cx="5250942" cy="2697480"/>
           </a:xfrm>
           <a:prstGeom prst="roundRect">
             <a:avLst>
-              <a:gd name="adj" fmla="val 12000"/>
+              <a:gd name="adj" fmla="val 8000"/>
             </a:avLst>
           </a:prstGeom>
           <a:solidFill>
-            <a:srgbClr val="0A254E"/>
+            <a:srgbClr val="F2F4F8"/>
           </a:solidFill>
           <a:ln>
-            <a:noFill/>
+            <a:solidFill>
+              <a:srgbClr val="D0D6E0"/>
+            </a:solidFill>
           </a:ln>
         </p:spPr>
         <p:style>
@@ -9144,12 +9410,353 @@
           </a:fontRef>
         </p:style>
         <p:txBody>
+          <a:bodyPr rtlCol="0" anchor="ctr" wrap="square" lIns="137160" rIns="137160"/>
+          <a:lstStyle/>
+          <a:p>
+            <a:pPr algn="ctr"/>
+            <a:r>
+              <a:rPr sz="6000" b="1" i="0">
+                <a:solidFill>
+                  <a:srgbClr val="0A254E"/>
+                </a:solidFill>
+                <a:latin typeface="Times New Roman"/>
+              </a:rPr>
+              <a:t>57.9%</a:t>
+            </a:r>
+          </a:p>
+          <a:p>
+            <a:pPr algn="ctr"/>
+            <a:r>
+              <a:rPr sz="2100" b="0" i="0">
+                <a:solidFill>
+                  <a:srgbClr val="000000"/>
+                </a:solidFill>
+                <a:latin typeface="Times New Roman"/>
+              </a:rPr>
+              <a:t>of U.S. energy intake comes from ultra-processed foods</a:t>
+            </a:r>
+            <a:r>
+              <a:rPr sz="2100" b="0" i="0" baseline="30000">
+                <a:solidFill>
+                  <a:srgbClr val="000000"/>
+                </a:solidFill>
+                <a:latin typeface="Times New Roman"/>
+              </a:rPr>
+              <a:t>11</a:t>
+            </a:r>
+          </a:p>
+        </p:txBody>
+      </p:sp>
+      <p:sp>
+        <p:nvSpPr>
+          <p:cNvPr id="347" name="Rounded Rectangle 346"/>
+          <p:cNvSpPr/>
+          <p:nvPr/>
+        </p:nvSpPr>
+        <p:spPr>
+          <a:xfrm>
+            <a:off x="27813762" y="23865840"/>
+            <a:ext cx="5250942" cy="2697480"/>
+          </a:xfrm>
+          <a:prstGeom prst="roundRect">
+            <a:avLst>
+              <a:gd name="adj" fmla="val 8000"/>
+            </a:avLst>
+          </a:prstGeom>
+          <a:solidFill>
+            <a:srgbClr val="F2F4F8"/>
+          </a:solidFill>
+          <a:ln>
+            <a:solidFill>
+              <a:srgbClr val="D0D6E0"/>
+            </a:solidFill>
+          </a:ln>
+        </p:spPr>
+        <p:style>
+          <a:lnRef idx="1">
+            <a:schemeClr val="accent1"/>
+          </a:lnRef>
+          <a:fillRef idx="3">
+            <a:schemeClr val="accent1"/>
+          </a:fillRef>
+          <a:effectRef idx="2">
+            <a:schemeClr val="accent1"/>
+          </a:effectRef>
+          <a:fontRef idx="minor">
+            <a:schemeClr val="lt1"/>
+          </a:fontRef>
+        </p:style>
+        <p:txBody>
+          <a:bodyPr rtlCol="0" anchor="ctr" wrap="square" lIns="137160" rIns="137160"/>
+          <a:lstStyle/>
+          <a:p>
+            <a:pPr algn="ctr"/>
+            <a:r>
+              <a:rPr sz="6000" b="1" i="0">
+                <a:solidFill>
+                  <a:srgbClr val="D55E00"/>
+                </a:solidFill>
+                <a:latin typeface="Times New Roman"/>
+              </a:rPr>
+              <a:t>89.7%</a:t>
+            </a:r>
+          </a:p>
+          <a:p>
+            <a:pPr algn="ctr"/>
+            <a:r>
+              <a:rPr sz="2100" b="0" i="0">
+                <a:solidFill>
+                  <a:srgbClr val="000000"/>
+                </a:solidFill>
+                <a:latin typeface="Times New Roman"/>
+              </a:rPr>
+              <a:t>of energy from added sugars comes from ultra-processed foods</a:t>
+            </a:r>
+            <a:r>
+              <a:rPr sz="2100" b="0" i="0" baseline="30000">
+                <a:solidFill>
+                  <a:srgbClr val="000000"/>
+                </a:solidFill>
+                <a:latin typeface="Times New Roman"/>
+              </a:rPr>
+              <a:t>11</a:t>
+            </a:r>
+          </a:p>
+        </p:txBody>
+      </p:sp>
+      <p:sp>
+        <p:nvSpPr>
+          <p:cNvPr id="348" name="Rounded Rectangle 347"/>
+          <p:cNvSpPr/>
+          <p:nvPr/>
+        </p:nvSpPr>
+        <p:spPr>
+          <a:xfrm>
+            <a:off x="22288500" y="26791920"/>
+            <a:ext cx="5250942" cy="2697480"/>
+          </a:xfrm>
+          <a:prstGeom prst="roundRect">
+            <a:avLst>
+              <a:gd name="adj" fmla="val 8000"/>
+            </a:avLst>
+          </a:prstGeom>
+          <a:solidFill>
+            <a:srgbClr val="F2F4F8"/>
+          </a:solidFill>
+          <a:ln>
+            <a:solidFill>
+              <a:srgbClr val="D0D6E0"/>
+            </a:solidFill>
+          </a:ln>
+        </p:spPr>
+        <p:style>
+          <a:lnRef idx="1">
+            <a:schemeClr val="accent1"/>
+          </a:lnRef>
+          <a:fillRef idx="3">
+            <a:schemeClr val="accent1"/>
+          </a:fillRef>
+          <a:effectRef idx="2">
+            <a:schemeClr val="accent1"/>
+          </a:effectRef>
+          <a:fontRef idx="minor">
+            <a:schemeClr val="lt1"/>
+          </a:fontRef>
+        </p:style>
+        <p:txBody>
+          <a:bodyPr rtlCol="0" anchor="ctr" wrap="square" lIns="137160" rIns="137160"/>
+          <a:lstStyle/>
+          <a:p>
+            <a:pPr algn="ctr"/>
+            <a:r>
+              <a:rPr sz="6000" b="1" i="0">
+                <a:solidFill>
+                  <a:srgbClr val="D55E00"/>
+                </a:solidFill>
+                <a:latin typeface="Times New Roman"/>
+              </a:rPr>
+              <a:t>≤10 g</a:t>
+            </a:r>
+          </a:p>
+          <a:p>
+            <a:pPr algn="ctr"/>
+            <a:r>
+              <a:rPr sz="2100" b="0" i="0">
+                <a:solidFill>
+                  <a:srgbClr val="000000"/>
+                </a:solidFill>
+                <a:latin typeface="Times New Roman"/>
+              </a:rPr>
+              <a:t>added sugars per meal under the 2025–2030 Dietary Guidelines</a:t>
+            </a:r>
+            <a:r>
+              <a:rPr sz="2100" b="0" i="0" baseline="30000">
+                <a:solidFill>
+                  <a:srgbClr val="000000"/>
+                </a:solidFill>
+                <a:latin typeface="Times New Roman"/>
+              </a:rPr>
+              <a:t>7</a:t>
+            </a:r>
+          </a:p>
+        </p:txBody>
+      </p:sp>
+      <p:sp>
+        <p:nvSpPr>
+          <p:cNvPr id="349" name="Rounded Rectangle 348"/>
+          <p:cNvSpPr/>
+          <p:nvPr/>
+        </p:nvSpPr>
+        <p:spPr>
+          <a:xfrm>
+            <a:off x="27813762" y="26791920"/>
+            <a:ext cx="5250942" cy="2697480"/>
+          </a:xfrm>
+          <a:prstGeom prst="roundRect">
+            <a:avLst>
+              <a:gd name="adj" fmla="val 8000"/>
+            </a:avLst>
+          </a:prstGeom>
+          <a:solidFill>
+            <a:srgbClr val="F2F4F8"/>
+          </a:solidFill>
+          <a:ln>
+            <a:solidFill>
+              <a:srgbClr val="D0D6E0"/>
+            </a:solidFill>
+          </a:ln>
+        </p:spPr>
+        <p:style>
+          <a:lnRef idx="1">
+            <a:schemeClr val="accent1"/>
+          </a:lnRef>
+          <a:fillRef idx="3">
+            <a:schemeClr val="accent1"/>
+          </a:fillRef>
+          <a:effectRef idx="2">
+            <a:schemeClr val="accent1"/>
+          </a:effectRef>
+          <a:fontRef idx="minor">
+            <a:schemeClr val="lt1"/>
+          </a:fontRef>
+        </p:style>
+        <p:txBody>
+          <a:bodyPr rtlCol="0" anchor="ctr" wrap="square" lIns="137160" rIns="137160"/>
+          <a:lstStyle/>
+          <a:p>
+            <a:pPr algn="ctr"/>
+            <a:r>
+              <a:rPr sz="6000" b="1" i="0">
+                <a:solidFill>
+                  <a:srgbClr val="0A254E"/>
+                </a:solidFill>
+                <a:latin typeface="Times New Roman"/>
+              </a:rPr>
+              <a:t>−38%</a:t>
+            </a:r>
+          </a:p>
+          <a:p>
+            <a:pPr algn="ctr"/>
+            <a:r>
+              <a:rPr sz="2100" b="0" i="0">
+                <a:solidFill>
+                  <a:srgbClr val="000000"/>
+                </a:solidFill>
+                <a:latin typeface="Times New Roman"/>
+              </a:rPr>
+              <a:t>per capita corn sweetener availability, 1999–2023</a:t>
+            </a:r>
+            <a:r>
+              <a:rPr sz="2100" b="0" i="0" baseline="30000">
+                <a:solidFill>
+                  <a:srgbClr val="000000"/>
+                </a:solidFill>
+                <a:latin typeface="Times New Roman"/>
+              </a:rPr>
+              <a:t>10</a:t>
+            </a:r>
+          </a:p>
+        </p:txBody>
+      </p:sp>
+      <p:sp>
+        <p:nvSpPr>
+          <p:cNvPr id="350" name="TextBox 349"/>
+          <p:cNvSpPr txBox="1"/>
+          <p:nvPr/>
+        </p:nvSpPr>
+        <p:spPr>
+          <a:xfrm>
+            <a:off x="22288500" y="29489400"/>
+            <a:ext cx="10776204" cy="457200"/>
+          </a:xfrm>
+          <a:prstGeom prst="rect">
+            <a:avLst/>
+          </a:prstGeom>
+          <a:noFill/>
+        </p:spPr>
+        <p:txBody>
+          <a:bodyPr wrap="square" anchor="t">
+            <a:noAutofit/>
+          </a:bodyPr>
+          <a:lstStyle/>
+          <a:p>
+            <a:pPr algn="ctr"/>
+            <a:r>
+              <a:rPr sz="1800" b="0" i="1">
+                <a:solidFill>
+                  <a:srgbClr val="595959"/>
+                </a:solidFill>
+                <a:latin typeface="Times New Roman"/>
+              </a:rPr>
+              <a:t>UPF data: NHANES 2009–2010</a:t>
+            </a:r>
+          </a:p>
+        </p:txBody>
+      </p:sp>
+      <p:sp>
+        <p:nvSpPr>
+          <p:cNvPr id="351" name="Rounded Rectangle 350"/>
+          <p:cNvSpPr/>
+          <p:nvPr/>
+        </p:nvSpPr>
+        <p:spPr>
+          <a:xfrm>
+            <a:off x="11603736" y="30083760"/>
+            <a:ext cx="21095208" cy="1828800"/>
+          </a:xfrm>
+          <a:prstGeom prst="roundRect">
+            <a:avLst>
+              <a:gd name="adj" fmla="val 12000"/>
+            </a:avLst>
+          </a:prstGeom>
+          <a:solidFill>
+            <a:srgbClr val="0A254E"/>
+          </a:solidFill>
+          <a:ln>
+            <a:noFill/>
+          </a:ln>
+        </p:spPr>
+        <p:style>
+          <a:lnRef idx="1">
+            <a:schemeClr val="accent1"/>
+          </a:lnRef>
+          <a:fillRef idx="3">
+            <a:schemeClr val="accent1"/>
+          </a:fillRef>
+          <a:effectRef idx="2">
+            <a:schemeClr val="accent1"/>
+          </a:effectRef>
+          <a:fontRef idx="minor">
+            <a:schemeClr val="lt1"/>
+          </a:fontRef>
+        </p:style>
+        <p:txBody>
           <a:bodyPr rtlCol="0" anchor="ctr" wrap="square" lIns="365760" rIns="365760"/>
           <a:lstStyle/>
           <a:p>
             <a:pPr algn="ctr"/>
             <a:r>
-              <a:rPr sz="3200" b="1" i="0">
+              <a:rPr sz="3000" b="1" i="0">
                 <a:solidFill>
                   <a:srgbClr val="F2C14E"/>
                 </a:solidFill>
@@ -9158,7 +9765,7 @@
               <a:t>KEY TAKEAWAY  </a:t>
             </a:r>
             <a:r>
-              <a:rPr sz="3200" b="0" i="0">
+              <a:rPr sz="3000" b="0" i="0">
                 <a:solidFill>
                   <a:srgbClr val="FFFFFF"/>
                 </a:solidFill>

</xml_diff>

<commit_message>
HFCS poster: trim to 4 figures, enlarge study results, one-row context tiles
Co-Authored-By: Claude Opus 5.5 <noreply@anthropic.com>
Claude-Session: https://claude.ai/code/session_01GDCp9vaBDB24tAeq3Z16Kb
</commit_message>
<xml_diff>
--- a/HFCS_APHA_Poster_Revised.pptx
+++ b/HFCS_APHA_Poster_Revised.pptx
@@ -7848,7 +7848,7 @@
                 </a:solidFill>
                 <a:latin typeface="Times New Roman"/>
               </a:rPr>
-              <a:t>HFCS appeared in a minority of products, yet its presence in nearly 30,000 items shows it remains embedded in the U.S. food supply. A 6.6% product share is not low exposure: counts are not sales-weighted, and HFCS may cluster in high-consumption foods such as sweetened beverages, desserts, and condiments (Figure 3). HFCS use grew rapidly after the 1970s,</a:t>
+              <a:t>HFCS appeared in a minority of products, yet its presence in nearly 30,000 items shows it remains embedded in the U.S. food supply. A 6.6% product share is not low exposure: counts are not sales-weighted, and HFCS may cluster in high-consumption foods such as sweetened beverages, desserts, and condiments. HFCS use grew rapidly after the 1970s,</a:t>
             </a:r>
             <a:r>
               <a:rPr sz="2500" b="0" i="0" baseline="30000">
@@ -7866,7 +7866,7 @@
                 </a:solidFill>
                 <a:latin typeface="Times New Roman"/>
               </a:rPr>
-              <a:t> and although per capita corn sweetener availability has fallen 38% since its 1999 peak (Figure 5),</a:t>
+              <a:t> and although per capita corn sweetener availability has fallen 38% since its 1999 peak (Figure 4),</a:t>
             </a:r>
             <a:r>
               <a:rPr sz="2500" b="0" i="0" baseline="30000">
@@ -8975,8 +8975,8 @@
         </p:blipFill>
         <p:spPr>
           <a:xfrm>
-            <a:off x="12284504" y="8183879"/>
-            <a:ext cx="8683146" cy="6766560"/>
+            <a:off x="11237976" y="8145586"/>
+            <a:ext cx="10776204" cy="8397627"/>
           </a:xfrm>
           <a:prstGeom prst="rect">
             <a:avLst/>
@@ -8991,7 +8991,7 @@
         </p:nvSpPr>
         <p:spPr>
           <a:xfrm>
-            <a:off x="11237976" y="14996159"/>
+            <a:off x="11237976" y="16596359"/>
             <a:ext cx="10776204" cy="1097280"/>
           </a:xfrm>
           <a:prstGeom prst="rect">
@@ -9043,8 +9043,8 @@
         </p:blipFill>
         <p:spPr>
           <a:xfrm>
-            <a:off x="23466681" y="8183879"/>
-            <a:ext cx="8419840" cy="6766560"/>
+            <a:off x="22442646" y="8138160"/>
+            <a:ext cx="10467910" cy="8412480"/>
           </a:xfrm>
           <a:prstGeom prst="rect">
             <a:avLst/>
@@ -9059,7 +9059,7 @@
         </p:nvSpPr>
         <p:spPr>
           <a:xfrm>
-            <a:off x="22288500" y="14996159"/>
+            <a:off x="22288500" y="16596359"/>
             <a:ext cx="10776204" cy="1097280"/>
           </a:xfrm>
           <a:prstGeom prst="rect">
@@ -9097,7 +9097,7 @@
       </p:sp>
       <p:pic>
         <p:nvPicPr>
-          <p:cNvPr id="339" name="Picture 338" descr="poster_Picture11.png"/>
+          <p:cNvPr id="339" name="Picture 338" descr="fig4_fructose.png"/>
           <p:cNvPicPr>
             <a:picLocks noChangeAspect="1"/>
           </p:cNvPicPr>
@@ -9111,8 +9111,8 @@
         </p:blipFill>
         <p:spPr>
           <a:xfrm>
-            <a:off x="11350693" y="16367759"/>
-            <a:ext cx="10550769" cy="5486400"/>
+            <a:off x="11507070" y="18059400"/>
+            <a:ext cx="10238014" cy="5212080"/>
           </a:xfrm>
           <a:prstGeom prst="rect">
             <a:avLst/>
@@ -9127,7 +9127,7 @@
         </p:nvSpPr>
         <p:spPr>
           <a:xfrm>
-            <a:off x="11237976" y="21899880"/>
+            <a:off x="11237976" y="23317200"/>
             <a:ext cx="10776204" cy="1097280"/>
           </a:xfrm>
           <a:prstGeom prst="rect">
@@ -9149,7 +9149,7 @@
                 </a:solidFill>
                 <a:latin typeface="Times New Roman"/>
               </a:rPr>
-              <a:t>Figure 3. Food Categories Where HFCS Is Commonly Used.</a:t>
+              <a:t>Figure 3. Fructose Content of HFCS and Sucrose.</a:t>
             </a:r>
             <a:r>
               <a:rPr sz="2200" b="0" i="0">
@@ -9158,7 +9158,7 @@
                 </a:solidFill>
                 <a:latin typeface="Times New Roman"/>
               </a:rPr>
-              <a:t> Drawn from the study background</a:t>
+              <a:t> HFCS-42 and HFCS-55 bracket the 50% fructose of table sugar.</a:t>
             </a:r>
             <a:r>
               <a:rPr sz="2200" b="0" i="0" baseline="30000">
@@ -9167,23 +9167,14 @@
                 </a:solidFill>
                 <a:latin typeface="Times New Roman"/>
               </a:rPr>
-              <a:t>1,2</a:t>
-            </a:r>
-            <a:r>
-              <a:rPr sz="2200" b="0" i="0">
-                <a:solidFill>
-                  <a:srgbClr val="000000"/>
-                </a:solidFill>
-                <a:latin typeface="Times New Roman"/>
-              </a:rPr>
-              <a:t>; category-level prevalence was not analyzed.</a:t>
+              <a:t>3</a:t>
             </a:r>
           </a:p>
         </p:txBody>
       </p:sp>
       <p:pic>
         <p:nvPicPr>
-          <p:cNvPr id="341" name="Picture 340" descr="fig4_fructose.png"/>
+          <p:cNvPr id="341" name="Picture 340" descr="fig5_ers.png"/>
           <p:cNvPicPr>
             <a:picLocks noChangeAspect="1"/>
           </p:cNvPicPr>
@@ -9197,8 +9188,8 @@
         </p:blipFill>
         <p:spPr>
           <a:xfrm>
-            <a:off x="22288500" y="16367926"/>
-            <a:ext cx="10776204" cy="5486067"/>
+            <a:off x="22557594" y="18059400"/>
+            <a:ext cx="10238014" cy="5212080"/>
           </a:xfrm>
           <a:prstGeom prst="rect">
             <a:avLst/>
@@ -9213,7 +9204,7 @@
         </p:nvSpPr>
         <p:spPr>
           <a:xfrm>
-            <a:off x="22288500" y="21899880"/>
+            <a:off x="22288500" y="23317200"/>
             <a:ext cx="10776204" cy="1097280"/>
           </a:xfrm>
           <a:prstGeom prst="rect">
@@ -9235,7 +9226,7 @@
                 </a:solidFill>
                 <a:latin typeface="Times New Roman"/>
               </a:rPr>
-              <a:t>Figure 4. Fructose Content of HFCS and Sucrose.</a:t>
+              <a:t>Figure 4. U.S. Per Capita Sweetener Availability, 1999 vs 2023.</a:t>
             </a:r>
             <a:r>
               <a:rPr sz="2200" b="0" i="0">
@@ -9244,7 +9235,7 @@
                 </a:solidFill>
                 <a:latin typeface="Times New Roman"/>
               </a:rPr>
-              <a:t> HFCS-42 and HFCS-55 bracket the 50% fructose of table sugar.</a:t>
+              <a:t> USDA Economic Research Service data; corn sweeteners include HFCS, glucose syrup, and dextrose.</a:t>
             </a:r>
             <a:r>
               <a:rPr sz="2200" b="0" i="0" baseline="30000">
@@ -9253,45 +9244,21 @@
                 </a:solidFill>
                 <a:latin typeface="Times New Roman"/>
               </a:rPr>
-              <a:t>3</a:t>
-            </a:r>
-          </a:p>
-        </p:txBody>
-      </p:sp>
-      <p:pic>
-        <p:nvPicPr>
-          <p:cNvPr id="343" name="Picture 342" descr="fig5_ers.png"/>
-          <p:cNvPicPr>
-            <a:picLocks noChangeAspect="1"/>
-          </p:cNvPicPr>
+              <a:t>10</a:t>
+            </a:r>
+          </a:p>
+        </p:txBody>
+      </p:sp>
+      <p:sp>
+        <p:nvSpPr>
+          <p:cNvPr id="343" name="TextBox 342"/>
+          <p:cNvSpPr txBox="1"/>
           <p:nvPr/>
-        </p:nvPicPr>
-        <p:blipFill>
-          <a:blip r:embed="rId8"/>
-          <a:stretch>
-            <a:fillRect/>
-          </a:stretch>
-        </p:blipFill>
+        </p:nvSpPr>
         <p:spPr>
           <a:xfrm>
-            <a:off x="11596878" y="23271480"/>
-            <a:ext cx="10058400" cy="5120640"/>
-          </a:xfrm>
-          <a:prstGeom prst="rect">
-            <a:avLst/>
-          </a:prstGeom>
-        </p:spPr>
-      </p:pic>
-      <p:sp>
-        <p:nvSpPr>
-          <p:cNvPr id="344" name="TextBox 343"/>
-          <p:cNvSpPr txBox="1"/>
-          <p:nvPr/>
-        </p:nvSpPr>
-        <p:spPr>
-          <a:xfrm>
-            <a:off x="11237976" y="28437840"/>
-            <a:ext cx="10776204" cy="1097280"/>
+            <a:off x="11237976" y="24643080"/>
+            <a:ext cx="21826728" cy="640080"/>
           </a:xfrm>
           <a:prstGeom prst="rect">
             <a:avLst/>
@@ -9304,82 +9271,29 @@
           </a:bodyPr>
           <a:lstStyle/>
           <a:p>
-            <a:pPr algn="l"/>
-            <a:r>
-              <a:rPr sz="2200" b="1" i="0">
-                <a:solidFill>
-                  <a:srgbClr val="000000"/>
-                </a:solidFill>
-                <a:latin typeface="Times New Roman"/>
-              </a:rPr>
-              <a:t>Figure 5. U.S. Per Capita Sweetener Availability, 1999 vs 2023.</a:t>
-            </a:r>
-            <a:r>
-              <a:rPr sz="2200" b="0" i="0">
-                <a:solidFill>
-                  <a:srgbClr val="000000"/>
-                </a:solidFill>
-                <a:latin typeface="Times New Roman"/>
-              </a:rPr>
-              <a:t> USDA Economic Research Service data; corn sweeteners include HFCS, glucose syrup, and dextrose.</a:t>
-            </a:r>
-            <a:r>
-              <a:rPr sz="2200" b="0" i="0" baseline="30000">
-                <a:solidFill>
-                  <a:srgbClr val="000000"/>
-                </a:solidFill>
-                <a:latin typeface="Times New Roman"/>
-              </a:rPr>
-              <a:t>10</a:t>
-            </a:r>
-          </a:p>
-        </p:txBody>
-      </p:sp>
-      <p:sp>
-        <p:nvSpPr>
-          <p:cNvPr id="345" name="TextBox 344"/>
-          <p:cNvSpPr txBox="1"/>
+            <a:pPr algn="ctr"/>
+            <a:r>
+              <a:rPr sz="3200" b="1" i="0">
+                <a:solidFill>
+                  <a:srgbClr val="0A254E"/>
+                </a:solidFill>
+                <a:latin typeface="Times New Roman"/>
+              </a:rPr>
+              <a:t>Public Health Context</a:t>
+            </a:r>
+          </a:p>
+        </p:txBody>
+      </p:sp>
+      <p:sp>
+        <p:nvSpPr>
+          <p:cNvPr id="344" name="Rounded Rectangle 343"/>
+          <p:cNvSpPr/>
           <p:nvPr/>
         </p:nvSpPr>
         <p:spPr>
           <a:xfrm>
-            <a:off x="22288500" y="23134320"/>
-            <a:ext cx="10776204" cy="640080"/>
-          </a:xfrm>
-          <a:prstGeom prst="rect">
-            <a:avLst/>
-          </a:prstGeom>
-          <a:noFill/>
-        </p:spPr>
-        <p:txBody>
-          <a:bodyPr wrap="square" anchor="t">
-            <a:noAutofit/>
-          </a:bodyPr>
-          <a:lstStyle/>
-          <a:p>
-            <a:pPr algn="ctr"/>
-            <a:r>
-              <a:rPr sz="3000" b="1" i="0">
-                <a:solidFill>
-                  <a:srgbClr val="0A254E"/>
-                </a:solidFill>
-                <a:latin typeface="Times New Roman"/>
-              </a:rPr>
-              <a:t>Public Health Context</a:t>
-            </a:r>
-          </a:p>
-        </p:txBody>
-      </p:sp>
-      <p:sp>
-        <p:nvSpPr>
-          <p:cNvPr id="346" name="Rounded Rectangle 345"/>
-          <p:cNvSpPr/>
-          <p:nvPr/>
-        </p:nvSpPr>
-        <p:spPr>
-          <a:xfrm>
-            <a:off x="22288500" y="23865840"/>
-            <a:ext cx="5250942" cy="2697480"/>
+            <a:off x="11237976" y="25374600"/>
+            <a:ext cx="5250942" cy="3246120"/>
           </a:xfrm>
           <a:prstGeom prst="roundRect">
             <a:avLst>
@@ -9427,7 +9341,7 @@
           <a:p>
             <a:pPr algn="ctr"/>
             <a:r>
-              <a:rPr sz="2100" b="0" i="0">
+              <a:rPr sz="2400" b="0" i="0">
                 <a:solidFill>
                   <a:srgbClr val="000000"/>
                 </a:solidFill>
@@ -9436,7 +9350,7 @@
               <a:t>of U.S. energy intake comes from ultra-processed foods</a:t>
             </a:r>
             <a:r>
-              <a:rPr sz="2100" b="0" i="0" baseline="30000">
+              <a:rPr sz="2400" b="0" i="0" baseline="30000">
                 <a:solidFill>
                   <a:srgbClr val="000000"/>
                 </a:solidFill>
@@ -9449,14 +9363,14 @@
       </p:sp>
       <p:sp>
         <p:nvSpPr>
-          <p:cNvPr id="347" name="Rounded Rectangle 346"/>
+          <p:cNvPr id="345" name="Rounded Rectangle 344"/>
           <p:cNvSpPr/>
           <p:nvPr/>
         </p:nvSpPr>
         <p:spPr>
           <a:xfrm>
-            <a:off x="27813762" y="23865840"/>
-            <a:ext cx="5250942" cy="2697480"/>
+            <a:off x="16763238" y="25374600"/>
+            <a:ext cx="5250942" cy="3246120"/>
           </a:xfrm>
           <a:prstGeom prst="roundRect">
             <a:avLst>
@@ -9504,7 +9418,7 @@
           <a:p>
             <a:pPr algn="ctr"/>
             <a:r>
-              <a:rPr sz="2100" b="0" i="0">
+              <a:rPr sz="2400" b="0" i="0">
                 <a:solidFill>
                   <a:srgbClr val="000000"/>
                 </a:solidFill>
@@ -9513,7 +9427,7 @@
               <a:t>of energy from added sugars comes from ultra-processed foods</a:t>
             </a:r>
             <a:r>
-              <a:rPr sz="2100" b="0" i="0" baseline="30000">
+              <a:rPr sz="2400" b="0" i="0" baseline="30000">
                 <a:solidFill>
                   <a:srgbClr val="000000"/>
                 </a:solidFill>
@@ -9526,14 +9440,14 @@
       </p:sp>
       <p:sp>
         <p:nvSpPr>
-          <p:cNvPr id="348" name="Rounded Rectangle 347"/>
+          <p:cNvPr id="346" name="Rounded Rectangle 345"/>
           <p:cNvSpPr/>
           <p:nvPr/>
         </p:nvSpPr>
         <p:spPr>
           <a:xfrm>
-            <a:off x="22288500" y="26791920"/>
-            <a:ext cx="5250942" cy="2697480"/>
+            <a:off x="22288500" y="25374600"/>
+            <a:ext cx="5250942" cy="3246120"/>
           </a:xfrm>
           <a:prstGeom prst="roundRect">
             <a:avLst>
@@ -9571,46 +9485,46 @@
             <a:r>
               <a:rPr sz="6000" b="1" i="0">
                 <a:solidFill>
-                  <a:srgbClr val="D55E00"/>
-                </a:solidFill>
-                <a:latin typeface="Times New Roman"/>
-              </a:rPr>
-              <a:t>≤10 g</a:t>
+                  <a:srgbClr val="0A254E"/>
+                </a:solidFill>
+                <a:latin typeface="Times New Roman"/>
+              </a:rPr>
+              <a:t>21.1%</a:t>
             </a:r>
           </a:p>
           <a:p>
             <a:pPr algn="ctr"/>
             <a:r>
-              <a:rPr sz="2100" b="0" i="0">
+              <a:rPr sz="2400" b="0" i="0">
                 <a:solidFill>
                   <a:srgbClr val="000000"/>
                 </a:solidFill>
                 <a:latin typeface="Times New Roman"/>
               </a:rPr>
-              <a:t>added sugars per meal under the 2025–2030 Dietary Guidelines</a:t>
-            </a:r>
-            <a:r>
-              <a:rPr sz="2100" b="0" i="0" baseline="30000">
+              <a:t>of calories in ultra-processed foods come from added sugars, vs 2.4% in processed foods</a:t>
+            </a:r>
+            <a:r>
+              <a:rPr sz="2400" b="0" i="0" baseline="30000">
                 <a:solidFill>
                   <a:srgbClr val="000000"/>
                 </a:solidFill>
                 <a:latin typeface="Times New Roman"/>
               </a:rPr>
-              <a:t>7</a:t>
-            </a:r>
-          </a:p>
-        </p:txBody>
-      </p:sp>
-      <p:sp>
-        <p:nvSpPr>
-          <p:cNvPr id="349" name="Rounded Rectangle 348"/>
+              <a:t>11</a:t>
+            </a:r>
+          </a:p>
+        </p:txBody>
+      </p:sp>
+      <p:sp>
+        <p:nvSpPr>
+          <p:cNvPr id="347" name="Rounded Rectangle 346"/>
           <p:cNvSpPr/>
           <p:nvPr/>
         </p:nvSpPr>
         <p:spPr>
           <a:xfrm>
-            <a:off x="27813762" y="26791920"/>
-            <a:ext cx="5250942" cy="2697480"/>
+            <a:off x="27813762" y="25374600"/>
+            <a:ext cx="5250942" cy="3246120"/>
           </a:xfrm>
           <a:prstGeom prst="roundRect">
             <a:avLst>
@@ -9648,46 +9562,46 @@
             <a:r>
               <a:rPr sz="6000" b="1" i="0">
                 <a:solidFill>
-                  <a:srgbClr val="0A254E"/>
-                </a:solidFill>
-                <a:latin typeface="Times New Roman"/>
-              </a:rPr>
-              <a:t>−38%</a:t>
+                  <a:srgbClr val="D55E00"/>
+                </a:solidFill>
+                <a:latin typeface="Times New Roman"/>
+              </a:rPr>
+              <a:t>≤10 g</a:t>
             </a:r>
           </a:p>
           <a:p>
             <a:pPr algn="ctr"/>
             <a:r>
-              <a:rPr sz="2100" b="0" i="0">
+              <a:rPr sz="2400" b="0" i="0">
                 <a:solidFill>
                   <a:srgbClr val="000000"/>
                 </a:solidFill>
                 <a:latin typeface="Times New Roman"/>
               </a:rPr>
-              <a:t>per capita corn sweetener availability, 1999–2023</a:t>
-            </a:r>
-            <a:r>
-              <a:rPr sz="2100" b="0" i="0" baseline="30000">
+              <a:t>added sugars per meal under the 2025–2030 Dietary Guidelines</a:t>
+            </a:r>
+            <a:r>
+              <a:rPr sz="2400" b="0" i="0" baseline="30000">
                 <a:solidFill>
                   <a:srgbClr val="000000"/>
                 </a:solidFill>
                 <a:latin typeface="Times New Roman"/>
               </a:rPr>
-              <a:t>10</a:t>
-            </a:r>
-          </a:p>
-        </p:txBody>
-      </p:sp>
-      <p:sp>
-        <p:nvSpPr>
-          <p:cNvPr id="350" name="TextBox 349"/>
+              <a:t>7</a:t>
+            </a:r>
+          </a:p>
+        </p:txBody>
+      </p:sp>
+      <p:sp>
+        <p:nvSpPr>
+          <p:cNvPr id="348" name="TextBox 347"/>
           <p:cNvSpPr txBox="1"/>
           <p:nvPr/>
         </p:nvSpPr>
         <p:spPr>
           <a:xfrm>
-            <a:off x="22288500" y="29489400"/>
-            <a:ext cx="10776204" cy="457200"/>
+            <a:off x="11237976" y="28666440"/>
+            <a:ext cx="21826728" cy="457200"/>
           </a:xfrm>
           <a:prstGeom prst="rect">
             <a:avLst/>
@@ -9708,14 +9622,14 @@
                 </a:solidFill>
                 <a:latin typeface="Times New Roman"/>
               </a:rPr>
-              <a:t>UPF data: NHANES 2009–2010</a:t>
-            </a:r>
-          </a:p>
-        </p:txBody>
-      </p:sp>
-      <p:sp>
-        <p:nvSpPr>
-          <p:cNvPr id="351" name="Rounded Rectangle 350"/>
+              <a:t>Ultra-processed food data: NHANES 2009–2010</a:t>
+            </a:r>
+          </a:p>
+        </p:txBody>
+      </p:sp>
+      <p:sp>
+        <p:nvSpPr>
+          <p:cNvPr id="349" name="Rounded Rectangle 348"/>
           <p:cNvSpPr/>
           <p:nvPr/>
         </p:nvSpPr>

</xml_diff>

<commit_message>
HFCS poster: cite all 24 sources in reading order; full 24-item AMA reference list for QR code
Co-Authored-By: Claude Opus 5.5 <noreply@anthropic.com>
Claude-Session: https://claude.ai/code/session_01GDCp9vaBDB24tAeq3Z16Kb
</commit_message>
<xml_diff>
--- a/HFCS_APHA_Poster_Revised.pptx
+++ b/HFCS_APHA_Poster_Revised.pptx
@@ -7004,7 +7004,7 @@
         <p:spPr>
           <a:xfrm>
             <a:off x="685800" y="14374368"/>
-            <a:ext cx="9427464" cy="7360920"/>
+            <a:ext cx="9427464" cy="8778240"/>
           </a:xfrm>
           <a:prstGeom prst="rect">
             <a:avLst/>
@@ -7130,7 +7130,7 @@
                 </a:solidFill>
                 <a:latin typeface="Times New Roman"/>
               </a:rPr>
-              <a:t> and excess free fructose may affect gut and metabolic health.</a:t>
+              <a:t> and high fructose intake is linked to adverse metabolic effects.</a:t>
             </a:r>
             <a:r>
               <a:rPr sz="2400" b="0" i="0" baseline="30000">
@@ -7148,7 +7148,7 @@
                 </a:solidFill>
                 <a:latin typeface="Times New Roman"/>
               </a:rPr>
-              <a:t> The 2025–2030 Dietary Guidelines state that no amount of added sugars is recommended as part of a healthy diet.</a:t>
+              <a:t> Excess free fructose may affect gut health,</a:t>
             </a:r>
             <a:r>
               <a:rPr sz="2400" b="0" i="0" baseline="30000">
@@ -7158,6 +7158,60 @@
                 <a:latin typeface="Times New Roman"/>
               </a:rPr>
               <a:t>7</a:t>
+            </a:r>
+            <a:r>
+              <a:rPr sz="2400" b="0" i="0">
+                <a:solidFill>
+                  <a:srgbClr val="000000"/>
+                </a:solidFill>
+                <a:latin typeface="Times New Roman"/>
+              </a:rPr>
+              <a:t> and preclinical studies link HFCS to inflammation and tumor growth.</a:t>
+            </a:r>
+            <a:r>
+              <a:rPr sz="2400" b="0" i="0" baseline="30000">
+                <a:solidFill>
+                  <a:srgbClr val="000000"/>
+                </a:solidFill>
+                <a:latin typeface="Times New Roman"/>
+              </a:rPr>
+              <a:t>8</a:t>
+            </a:r>
+            <a:r>
+              <a:rPr sz="2400" b="0" i="0">
+                <a:solidFill>
+                  <a:srgbClr val="000000"/>
+                </a:solidFill>
+                <a:latin typeface="Times New Roman"/>
+              </a:rPr>
+              <a:t> The Dietary Guidelines previously advised limiting added sugars to less than 10% of daily calories</a:t>
+            </a:r>
+            <a:r>
+              <a:rPr sz="2400" b="0" i="0" baseline="30000">
+                <a:solidFill>
+                  <a:srgbClr val="000000"/>
+                </a:solidFill>
+                <a:latin typeface="Times New Roman"/>
+              </a:rPr>
+              <a:t>9</a:t>
+            </a:r>
+            <a:r>
+              <a:rPr sz="2400" b="0" i="0">
+                <a:solidFill>
+                  <a:srgbClr val="000000"/>
+                </a:solidFill>
+                <a:latin typeface="Times New Roman"/>
+              </a:rPr>
+              <a:t>; the 2025–2030 edition states that no amount of added sugars is recommended as part of a healthy diet.</a:t>
+            </a:r>
+            <a:r>
+              <a:rPr sz="2400" b="0" i="0" baseline="30000">
+                <a:solidFill>
+                  <a:srgbClr val="000000"/>
+                </a:solidFill>
+                <a:latin typeface="Times New Roman"/>
+              </a:rPr>
+              <a:t>10</a:t>
             </a:r>
             <a:r>
               <a:rPr sz="2400" b="0" i="0">
@@ -7311,7 +7365,7 @@
         </p:nvSpPr>
         <p:spPr>
           <a:xfrm>
-            <a:off x="685800" y="22009608"/>
+            <a:off x="685800" y="23426928"/>
             <a:ext cx="9427464" cy="868680"/>
           </a:xfrm>
           <a:prstGeom prst="rect">
@@ -7361,8 +7415,8 @@
         </p:nvSpPr>
         <p:spPr>
           <a:xfrm>
-            <a:off x="34006536" y="20729448"/>
-            <a:ext cx="9253728" cy="6126480"/>
+            <a:off x="34006536" y="19815048"/>
+            <a:ext cx="9253728" cy="7132320"/>
           </a:xfrm>
           <a:prstGeom prst="rect">
             <a:avLst/>
@@ -7391,7 +7445,7 @@
               </a:spcAft>
             </a:pPr>
             <a:r>
-              <a:rPr sz="2400" b="1" i="0">
+              <a:rPr sz="2300" b="1" i="0">
                 <a:solidFill>
                   <a:srgbClr val="000000"/>
                 </a:solidFill>
@@ -7410,7 +7464,7 @@
               </a:spcAft>
             </a:pPr>
             <a:r>
-              <a:rPr sz="2400" b="0" i="0">
+              <a:rPr sz="2300" b="0" i="0">
                 <a:solidFill>
                   <a:srgbClr val="000000"/>
                 </a:solidFill>
@@ -7429,7 +7483,7 @@
               </a:spcAft>
             </a:pPr>
             <a:r>
-              <a:rPr sz="2400" b="0" i="0">
+              <a:rPr sz="2300" b="0" i="0">
                 <a:solidFill>
                   <a:srgbClr val="000000"/>
                 </a:solidFill>
@@ -7448,7 +7502,7 @@
               </a:spcAft>
             </a:pPr>
             <a:r>
-              <a:rPr sz="2400" b="0" i="0">
+              <a:rPr sz="2300" b="0" i="0">
                 <a:solidFill>
                   <a:srgbClr val="000000"/>
                 </a:solidFill>
@@ -7467,7 +7521,7 @@
               </a:spcAft>
             </a:pPr>
             <a:r>
-              <a:rPr sz="2400" b="0" i="0">
+              <a:rPr sz="2300" b="0" i="0">
                 <a:solidFill>
                   <a:srgbClr val="000000"/>
                 </a:solidFill>
@@ -7486,7 +7540,7 @@
               </a:spcAft>
             </a:pPr>
             <a:r>
-              <a:rPr sz="2400" b="0" i="0">
+              <a:rPr sz="2300" b="0" i="0">
                 <a:solidFill>
                   <a:srgbClr val="000000"/>
                 </a:solidFill>
@@ -7495,16 +7549,16 @@
               <a:t>• Align monitoring with the 2025–2030 Dietary Guidelines</a:t>
             </a:r>
             <a:r>
-              <a:rPr sz="2400" b="0" i="0" baseline="30000">
-                <a:solidFill>
-                  <a:srgbClr val="000000"/>
-                </a:solidFill>
-                <a:latin typeface="Times New Roman"/>
-              </a:rPr>
-              <a:t>7</a:t>
-            </a:r>
-            <a:r>
-              <a:rPr sz="2400" b="0" i="0">
+              <a:rPr sz="2300" b="0" i="0" baseline="30000">
+                <a:solidFill>
+                  <a:srgbClr val="000000"/>
+                </a:solidFill>
+                <a:latin typeface="Times New Roman"/>
+              </a:rPr>
+              <a:t>10</a:t>
+            </a:r>
+            <a:r>
+              <a:rPr sz="2300" b="0" i="0">
                 <a:solidFill>
                   <a:srgbClr val="000000"/>
                 </a:solidFill>
@@ -7513,13 +7567,41 @@
               <a:t> and added-sugar labeling</a:t>
             </a:r>
             <a:r>
-              <a:rPr sz="2400" b="0" i="0" baseline="30000">
-                <a:solidFill>
-                  <a:srgbClr val="000000"/>
-                </a:solidFill>
-                <a:latin typeface="Times New Roman"/>
-              </a:rPr>
-              <a:t>14</a:t>
+              <a:rPr sz="2300" b="0" i="0" baseline="30000">
+                <a:solidFill>
+                  <a:srgbClr val="000000"/>
+                </a:solidFill>
+                <a:latin typeface="Times New Roman"/>
+              </a:rPr>
+              <a:t>22,23</a:t>
+            </a:r>
+          </a:p>
+          <a:p>
+            <a:pPr algn="l" marL="274320" indent="-274320">
+              <a:lnSpc>
+                <a:spcPct val="100000"/>
+              </a:lnSpc>
+              <a:spcAft>
+                <a:spcPts val="300"/>
+              </a:spcAft>
+            </a:pPr>
+            <a:r>
+              <a:rPr sz="2300" b="0" i="0">
+                <a:solidFill>
+                  <a:srgbClr val="000000"/>
+                </a:solidFill>
+                <a:latin typeface="Times New Roman"/>
+              </a:rPr>
+              <a:t>• Consider disparities in fructose-rich food intake and metabolic syndrome</a:t>
+            </a:r>
+            <a:r>
+              <a:rPr sz="2300" b="0" i="0" baseline="30000">
+                <a:solidFill>
+                  <a:srgbClr val="000000"/>
+                </a:solidFill>
+                <a:latin typeface="Times New Roman"/>
+              </a:rPr>
+              <a:t>24</a:t>
             </a:r>
           </a:p>
           <a:p>
@@ -7532,7 +7614,7 @@
               </a:spcAft>
             </a:pPr>
             <a:r>
-              <a:rPr sz="2400" b="1" i="0">
+              <a:rPr sz="2300" b="1" i="0">
                 <a:solidFill>
                   <a:srgbClr val="000000"/>
                 </a:solidFill>
@@ -7551,7 +7633,7 @@
               </a:spcAft>
             </a:pPr>
             <a:r>
-              <a:rPr sz="2400" b="0" i="0">
+              <a:rPr sz="2300" b="0" i="0">
                 <a:solidFill>
                   <a:srgbClr val="000000"/>
                 </a:solidFill>
@@ -7570,7 +7652,7 @@
               </a:spcAft>
             </a:pPr>
             <a:r>
-              <a:rPr sz="2400" b="0" i="0">
+              <a:rPr sz="2300" b="0" i="0">
                 <a:solidFill>
                   <a:srgbClr val="000000"/>
                 </a:solidFill>
@@ -7589,7 +7671,7 @@
               </a:spcAft>
             </a:pPr>
             <a:r>
-              <a:rPr sz="2400" b="0" i="0">
+              <a:rPr sz="2300" b="0" i="0">
                 <a:solidFill>
                   <a:srgbClr val="000000"/>
                 </a:solidFill>
@@ -7608,7 +7690,7 @@
               </a:spcAft>
             </a:pPr>
             <a:r>
-              <a:rPr sz="2400" b="0" i="0">
+              <a:rPr sz="2300" b="0" i="0">
                 <a:solidFill>
                   <a:srgbClr val="000000"/>
                 </a:solidFill>
@@ -7633,7 +7715,7 @@
         </p:nvSpPr>
         <p:spPr>
           <a:xfrm>
-            <a:off x="34006536" y="19357848"/>
+            <a:off x="34006536" y="18443448"/>
             <a:ext cx="9253728" cy="1371600"/>
           </a:xfrm>
           <a:prstGeom prst="rect">
@@ -7683,7 +7765,7 @@
         </p:nvSpPr>
         <p:spPr>
           <a:xfrm>
-            <a:off x="34006536" y="27130248"/>
+            <a:off x="34006536" y="27221688"/>
             <a:ext cx="9253728" cy="868680"/>
           </a:xfrm>
           <a:prstGeom prst="rect">
@@ -7734,7 +7816,7 @@
         <p:spPr>
           <a:xfrm>
             <a:off x="34006536" y="5458968"/>
-            <a:ext cx="9253728" cy="13624560"/>
+            <a:ext cx="9253728" cy="12710160"/>
           </a:xfrm>
           <a:prstGeom prst="rect">
             <a:avLst/>
@@ -7763,7 +7845,7 @@
               </a:spcAft>
             </a:pPr>
             <a:r>
-              <a:rPr sz="2500" b="1" i="0">
+              <a:rPr sz="2400" b="1" i="0">
                 <a:solidFill>
                   <a:srgbClr val="000000"/>
                 </a:solidFill>
@@ -7786,7 +7868,7 @@
               </a:spcAft>
             </a:pPr>
             <a:r>
-              <a:rPr sz="2500" b="0" i="0">
+              <a:rPr sz="2400" b="0" i="0">
                 <a:solidFill>
                   <a:srgbClr val="000000"/>
                 </a:solidFill>
@@ -7795,7 +7877,7 @@
               <a:t>Of 454,324 products identified, 6,717 were excluded, leaving 447,607 eligible U.S. branded products (Figure 1). HFCS was listed in </a:t>
             </a:r>
             <a:r>
-              <a:rPr sz="2500" b="1" i="0">
+              <a:rPr sz="2400" b="1" i="0">
                 <a:solidFill>
                   <a:srgbClr val="000000"/>
                 </a:solidFill>
@@ -7804,7 +7886,7 @@
               <a:t>29,503 products (6.6%)</a:t>
             </a:r>
             <a:r>
-              <a:rPr sz="2500" b="0" i="0">
+              <a:rPr sz="2400" b="0" i="0">
                 <a:solidFill>
                   <a:srgbClr val="000000"/>
                 </a:solidFill>
@@ -7823,7 +7905,7 @@
               </a:spcAft>
             </a:pPr>
             <a:r>
-              <a:rPr sz="2500" b="1" i="0">
+              <a:rPr sz="2400" b="1" i="0">
                 <a:solidFill>
                   <a:srgbClr val="000000"/>
                 </a:solidFill>
@@ -7842,16 +7924,16 @@
               </a:spcAft>
             </a:pPr>
             <a:r>
-              <a:rPr sz="2500" b="0" i="0">
-                <a:solidFill>
-                  <a:srgbClr val="000000"/>
-                </a:solidFill>
-                <a:latin typeface="Times New Roman"/>
-              </a:rPr>
-              <a:t>HFCS appeared in a minority of products, yet its presence in nearly 30,000 items shows it remains embedded in the U.S. food supply. A 6.6% product share is not low exposure: counts are not sales-weighted, and HFCS may cluster in high-consumption foods such as sweetened beverages, desserts, and condiments. HFCS use grew rapidly after the 1970s,</a:t>
-            </a:r>
-            <a:r>
-              <a:rPr sz="2500" b="0" i="0" baseline="30000">
+              <a:rPr sz="2400" b="0" i="0">
+                <a:solidFill>
+                  <a:srgbClr val="000000"/>
+                </a:solidFill>
+                <a:latin typeface="Times New Roman"/>
+              </a:rPr>
+              <a:t>HFCS appeared in a minority of products, yet its presence in nearly 30,000 items shows it remains embedded in the U.S. food supply. A 6.6% product share is not low exposure: counts are not sales-weighted, and HFCS may cluster in high-consumption foods such as sweetened beverages, desserts, and condiments. HFCS use grew rapidly after the 1970s</a:t>
+            </a:r>
+            <a:r>
+              <a:rPr sz="2400" b="0" i="0" baseline="30000">
                 <a:solidFill>
                   <a:srgbClr val="000000"/>
                 </a:solidFill>
@@ -7860,25 +7942,43 @@
               <a:t>4</a:t>
             </a:r>
             <a:r>
-              <a:rPr sz="2500" b="0" i="0">
-                <a:solidFill>
-                  <a:srgbClr val="000000"/>
-                </a:solidFill>
-                <a:latin typeface="Times New Roman"/>
-              </a:rPr>
-              <a:t> and although per capita corn sweetener availability has fallen 38% since its 1999 peak (Figure 4),</a:t>
-            </a:r>
-            <a:r>
-              <a:rPr sz="2500" b="0" i="0" baseline="30000">
-                <a:solidFill>
-                  <a:srgbClr val="000000"/>
-                </a:solidFill>
-                <a:latin typeface="Times New Roman"/>
-              </a:rPr>
-              <a:t>10</a:t>
-            </a:r>
-            <a:r>
-              <a:rPr sz="2500" b="0" i="0">
+              <a:rPr sz="2400" b="0" i="0">
+                <a:solidFill>
+                  <a:srgbClr val="000000"/>
+                </a:solidFill>
+                <a:latin typeface="Times New Roman"/>
+              </a:rPr>
+              <a:t> and peaked in 1999</a:t>
+            </a:r>
+            <a:r>
+              <a:rPr sz="2400" b="0" i="0" baseline="30000">
+                <a:solidFill>
+                  <a:srgbClr val="000000"/>
+                </a:solidFill>
+                <a:latin typeface="Times New Roman"/>
+              </a:rPr>
+              <a:t>17</a:t>
+            </a:r>
+            <a:r>
+              <a:rPr sz="2400" b="0" i="0">
+                <a:solidFill>
+                  <a:srgbClr val="000000"/>
+                </a:solidFill>
+                <a:latin typeface="Times New Roman"/>
+              </a:rPr>
+              <a:t>; although per capita corn sweetener availability has since fallen 38% (Figure 4),</a:t>
+            </a:r>
+            <a:r>
+              <a:rPr sz="2400" b="0" i="0" baseline="30000">
+                <a:solidFill>
+                  <a:srgbClr val="000000"/>
+                </a:solidFill>
+                <a:latin typeface="Times New Roman"/>
+              </a:rPr>
+              <a:t>15</a:t>
+            </a:r>
+            <a:r>
+              <a:rPr sz="2400" b="0" i="0">
                 <a:solidFill>
                   <a:srgbClr val="000000"/>
                 </a:solidFill>
@@ -7887,16 +7987,16 @@
               <a:t> HFCS remains common. Ultra-processed foods supply 89.7% of energy from added sugars in the U.S. diet,</a:t>
             </a:r>
             <a:r>
-              <a:rPr sz="2500" b="0" i="0" baseline="30000">
-                <a:solidFill>
-                  <a:srgbClr val="000000"/>
-                </a:solidFill>
-                <a:latin typeface="Times New Roman"/>
-              </a:rPr>
-              <a:t>11</a:t>
-            </a:r>
-            <a:r>
-              <a:rPr sz="2500" b="0" i="0">
+              <a:rPr sz="2400" b="0" i="0" baseline="30000">
+                <a:solidFill>
+                  <a:srgbClr val="000000"/>
+                </a:solidFill>
+                <a:latin typeface="Times New Roman"/>
+              </a:rPr>
+              <a:t>16</a:t>
+            </a:r>
+            <a:r>
+              <a:rPr sz="2400" b="0" i="0">
                 <a:solidFill>
                   <a:srgbClr val="000000"/>
                 </a:solidFill>
@@ -7905,16 +8005,16 @@
               <a:t> and sugar-sweetened beverages are linked to weight gain in children and adults.</a:t>
             </a:r>
             <a:r>
-              <a:rPr sz="2500" b="0" i="0" baseline="30000">
-                <a:solidFill>
-                  <a:srgbClr val="000000"/>
-                </a:solidFill>
-                <a:latin typeface="Times New Roman"/>
-              </a:rPr>
-              <a:t>12</a:t>
-            </a:r>
-            <a:r>
-              <a:rPr sz="2500" b="0" i="0">
+              <a:rPr sz="2400" b="0" i="0" baseline="30000">
+                <a:solidFill>
+                  <a:srgbClr val="000000"/>
+                </a:solidFill>
+                <a:latin typeface="Times New Roman"/>
+              </a:rPr>
+              <a:t>18</a:t>
+            </a:r>
+            <a:r>
+              <a:rPr sz="2400" b="0" i="0">
                 <a:solidFill>
                   <a:srgbClr val="000000"/>
                 </a:solidFill>
@@ -7923,16 +8023,16 @@
               <a:t> HFCS and sucrose have similar metabolic effects at equal intake,</a:t>
             </a:r>
             <a:r>
-              <a:rPr sz="2500" b="0" i="0" baseline="30000">
-                <a:solidFill>
-                  <a:srgbClr val="000000"/>
-                </a:solidFill>
-                <a:latin typeface="Times New Roman"/>
-              </a:rPr>
-              <a:t>13</a:t>
-            </a:r>
-            <a:r>
-              <a:rPr sz="2500" b="0" i="0">
+              <a:rPr sz="2400" b="0" i="0" baseline="30000">
+                <a:solidFill>
+                  <a:srgbClr val="000000"/>
+                </a:solidFill>
+                <a:latin typeface="Times New Roman"/>
+              </a:rPr>
+              <a:t>19,20</a:t>
+            </a:r>
+            <a:r>
+              <a:rPr sz="2400" b="0" i="0">
                 <a:solidFill>
                   <a:srgbClr val="000000"/>
                 </a:solidFill>
@@ -7951,7 +8051,7 @@
               </a:spcAft>
             </a:pPr>
             <a:r>
-              <a:rPr sz="2500" b="1" i="0">
+              <a:rPr sz="2400" b="1" i="0">
                 <a:solidFill>
                   <a:srgbClr val="000000"/>
                 </a:solidFill>
@@ -7970,7 +8070,7 @@
               </a:spcAft>
             </a:pPr>
             <a:r>
-              <a:rPr sz="2500" b="0" i="0">
+              <a:rPr sz="2400" b="0" i="0">
                 <a:solidFill>
                   <a:srgbClr val="000000"/>
                 </a:solidFill>
@@ -7989,7 +8089,7 @@
               </a:spcAft>
             </a:pPr>
             <a:r>
-              <a:rPr sz="2500" b="1" i="0">
+              <a:rPr sz="2400" b="1" i="0">
                 <a:solidFill>
                   <a:srgbClr val="000000"/>
                 </a:solidFill>
@@ -8008,7 +8108,7 @@
               </a:spcAft>
             </a:pPr>
             <a:r>
-              <a:rPr sz="2500" b="0" i="0">
+              <a:rPr sz="2400" b="0" i="0">
                 <a:solidFill>
                   <a:srgbClr val="000000"/>
                 </a:solidFill>
@@ -8017,7 +8117,7 @@
               <a:t>• </a:t>
             </a:r>
             <a:r>
-              <a:rPr sz="2500" b="1" i="0">
+              <a:rPr sz="2400" b="1" i="0">
                 <a:solidFill>
                   <a:srgbClr val="000000"/>
                 </a:solidFill>
@@ -8026,7 +8126,7 @@
               <a:t>Presence only:</a:t>
             </a:r>
             <a:r>
-              <a:rPr sz="2500" b="0" i="0">
+              <a:rPr sz="2400" b="0" i="0">
                 <a:solidFill>
                   <a:srgbClr val="000000"/>
                 </a:solidFill>
@@ -8045,7 +8145,7 @@
               </a:spcAft>
             </a:pPr>
             <a:r>
-              <a:rPr sz="2500" b="0" i="0">
+              <a:rPr sz="2400" b="0" i="0">
                 <a:solidFill>
                   <a:srgbClr val="000000"/>
                 </a:solidFill>
@@ -8054,7 +8154,7 @@
               <a:t>• </a:t>
             </a:r>
             <a:r>
-              <a:rPr sz="2500" b="1" i="0">
+              <a:rPr sz="2400" b="1" i="0">
                 <a:solidFill>
                   <a:srgbClr val="000000"/>
                 </a:solidFill>
@@ -8063,13 +8163,22 @@
               <a:t>Industry-supplied data:</a:t>
             </a:r>
             <a:r>
-              <a:rPr sz="2500" b="0" i="0">
+              <a:rPr sz="2400" b="0" i="0">
                 <a:solidFill>
                   <a:srgbClr val="000000"/>
                 </a:solidFill>
                 <a:latin typeface="Times New Roman"/>
               </a:rPr>
               <a:t> quality and completeness vary by contributor</a:t>
+            </a:r>
+            <a:r>
+              <a:rPr sz="2400" b="0" i="0" baseline="30000">
+                <a:solidFill>
+                  <a:srgbClr val="000000"/>
+                </a:solidFill>
+                <a:latin typeface="Times New Roman"/>
+              </a:rPr>
+              <a:t>13,21</a:t>
             </a:r>
           </a:p>
           <a:p>
@@ -8082,7 +8191,7 @@
               </a:spcAft>
             </a:pPr>
             <a:r>
-              <a:rPr sz="2500" b="0" i="0">
+              <a:rPr sz="2400" b="0" i="0">
                 <a:solidFill>
                   <a:srgbClr val="000000"/>
                 </a:solidFill>
@@ -8091,7 +8200,7 @@
               <a:t>• </a:t>
             </a:r>
             <a:r>
-              <a:rPr sz="2500" b="1" i="0">
+              <a:rPr sz="2400" b="1" i="0">
                 <a:solidFill>
                   <a:srgbClr val="000000"/>
                 </a:solidFill>
@@ -8100,7 +8209,7 @@
               <a:t>Search terms:</a:t>
             </a:r>
             <a:r>
-              <a:rPr sz="2500" b="0" i="0">
+              <a:rPr sz="2400" b="0" i="0">
                 <a:solidFill>
                   <a:srgbClr val="000000"/>
                 </a:solidFill>
@@ -8119,7 +8228,7 @@
               </a:spcAft>
             </a:pPr>
             <a:r>
-              <a:rPr sz="2500" b="0" i="0">
+              <a:rPr sz="2400" b="0" i="0">
                 <a:solidFill>
                   <a:srgbClr val="000000"/>
                 </a:solidFill>
@@ -8128,7 +8237,7 @@
               <a:t>• </a:t>
             </a:r>
             <a:r>
-              <a:rPr sz="2500" b="1" i="0">
+              <a:rPr sz="2400" b="1" i="0">
                 <a:solidFill>
                   <a:srgbClr val="000000"/>
                 </a:solidFill>
@@ -8137,7 +8246,7 @@
               <a:t>Item-level records:</a:t>
             </a:r>
             <a:r>
-              <a:rPr sz="2500" b="0" i="0">
+              <a:rPr sz="2400" b="0" i="0">
                 <a:solidFill>
                   <a:srgbClr val="000000"/>
                 </a:solidFill>
@@ -8219,8 +8328,8 @@
           </p:nvPr>
         </p:nvGraphicFramePr>
         <p:xfrm>
-          <a:off x="685800" y="22924008"/>
-          <a:ext cx="9427464" cy="9473184"/>
+          <a:off x="685800" y="24341328"/>
+          <a:ext cx="9427464" cy="8010144"/>
         </p:xfrm>
         <a:graphic>
           <a:graphicData uri="http://schemas.openxmlformats.org/drawingml/2006/table">
@@ -8289,7 +8398,7 @@
                   </a:ext>
                 </a:extLst>
               </a:tr>
-              <a:tr h="2651760">
+              <a:tr h="2103120">
                 <a:tc>
                   <a:txBody>
                     <a:bodyPr wrap="square"/>
@@ -8322,7 +8431,7 @@
                           </a:solidFill>
                           <a:latin typeface="Times New Roman"/>
                         </a:rPr>
-                        <a:t>Retrospective, cross-sectional, descriptive analysis of the USDA FoodData Central (FDC) Global Branded Food Products Database (GBFPD): 400,000+ branded and private-label products, supplied by industry and updated monthly.</a:t>
+                        <a:t>Retrospective, cross-sectional, descriptive analysis of the USDA FoodData Central (FDC) Global Branded Food Products Database (GBFPD)</a:t>
                       </a:r>
                       <a:r>
                         <a:rPr sz="2400" b="0" i="0" baseline="30000">
@@ -8331,7 +8440,25 @@
                           </a:solidFill>
                           <a:latin typeface="Times New Roman"/>
                         </a:rPr>
-                        <a:t>8,9</a:t>
+                        <a:t>11,12</a:t>
+                      </a:r>
+                      <a:r>
+                        <a:rPr sz="2400" b="0" i="0">
+                          <a:solidFill>
+                            <a:srgbClr val="000000"/>
+                          </a:solidFill>
+                          <a:latin typeface="Times New Roman"/>
+                        </a:rPr>
+                        <a:t>: 400,000+ branded and private-label products, supplied by industry and updated monthly.</a:t>
+                      </a:r>
+                      <a:r>
+                        <a:rPr sz="2400" b="0" i="0" baseline="30000">
+                          <a:solidFill>
+                            <a:srgbClr val="000000"/>
+                          </a:solidFill>
+                          <a:latin typeface="Times New Roman"/>
+                        </a:rPr>
+                        <a:t>13</a:t>
                       </a:r>
                       <a:endParaRPr lang="en-US" sz="2400" dirty="0">
                         <a:latin typeface="Times New Roman" panose="02020603050405020304" pitchFamily="18" charset="0"/>
@@ -8347,7 +8474,7 @@
                   </a:ext>
                 </a:extLst>
               </a:tr>
-              <a:tr h="3383280">
+              <a:tr h="2743200">
                 <a:tc>
                   <a:txBody>
                     <a:bodyPr wrap="square"/>
@@ -8380,7 +8507,25 @@
                           </a:solidFill>
                           <a:latin typeface="Times New Roman"/>
                         </a:rPr>
-                        <a:t>FDC published date April 13, 2019 (earliest available) to December 13, 2025 (search date). Trade channels: grocery, convenience, mass merchandising, food service, vending, online, military, child nutrition programs, and none. </a:t>
+                        <a:t>FDC branded foods search</a:t>
+                      </a:r>
+                      <a:r>
+                        <a:rPr sz="2400" b="0" i="0" baseline="30000">
+                          <a:solidFill>
+                            <a:srgbClr val="000000"/>
+                          </a:solidFill>
+                          <a:latin typeface="Times New Roman"/>
+                        </a:rPr>
+                        <a:t>14</a:t>
+                      </a:r>
+                      <a:r>
+                        <a:rPr sz="2400" b="0" i="0">
+                          <a:solidFill>
+                            <a:srgbClr val="000000"/>
+                          </a:solidFill>
+                          <a:latin typeface="Times New Roman"/>
+                        </a:rPr>
+                        <a:t> by published date, April 13, 2019 (earliest available) to December 13, 2025 (search date). Trade channels: grocery, convenience, mass merchandising, food service, vending, online, military, child nutrition programs, and none. </a:t>
                       </a:r>
                       <a:r>
                         <a:rPr sz="2400" b="1" i="0">
@@ -8414,7 +8559,7 @@
                   </a:ext>
                 </a:extLst>
               </a:tr>
-              <a:tr h="1463040">
+              <a:tr h="1280160">
                 <a:tc>
                   <a:txBody>
                     <a:bodyPr wrap="square"/>
@@ -8463,7 +8608,7 @@
                   </a:ext>
                 </a:extLst>
               </a:tr>
-              <a:tr h="1371600">
+              <a:tr h="1280160">
                 <a:tc>
                   <a:txBody>
                     <a:bodyPr wrap="square"/>
@@ -8560,8 +8705,8 @@
         </p:nvSpPr>
         <p:spPr>
           <a:xfrm>
-            <a:off x="36676584" y="28181808"/>
-            <a:ext cx="3913631" cy="3913631"/>
+            <a:off x="36722304" y="28273248"/>
+            <a:ext cx="3822191" cy="3822191"/>
           </a:xfrm>
           <a:prstGeom prst="rect">
             <a:avLst/>
@@ -8613,7 +8758,7 @@
                 </a:solidFill>
                 <a:latin typeface="Times New Roman"/>
               </a:rPr>
-              <a:t>(4.3 × 4.3 in; links to the full AMA reference list)</a:t>
+              <a:t>(4.2 × 4.2 in; links to the full AMA reference list)</a:t>
             </a:r>
           </a:p>
         </p:txBody>
@@ -9244,7 +9389,7 @@
                 </a:solidFill>
                 <a:latin typeface="Times New Roman"/>
               </a:rPr>
-              <a:t>10</a:t>
+              <a:t>15</a:t>
             </a:r>
           </a:p>
         </p:txBody>
@@ -9356,7 +9501,7 @@
                 </a:solidFill>
                 <a:latin typeface="Times New Roman"/>
               </a:rPr>
-              <a:t>11</a:t>
+              <a:t>16</a:t>
             </a:r>
           </a:p>
         </p:txBody>
@@ -9433,7 +9578,7 @@
                 </a:solidFill>
                 <a:latin typeface="Times New Roman"/>
               </a:rPr>
-              <a:t>11</a:t>
+              <a:t>16</a:t>
             </a:r>
           </a:p>
         </p:txBody>
@@ -9510,7 +9655,7 @@
                 </a:solidFill>
                 <a:latin typeface="Times New Roman"/>
               </a:rPr>
-              <a:t>11</a:t>
+              <a:t>16</a:t>
             </a:r>
           </a:p>
         </p:txBody>
@@ -9587,7 +9732,7 @@
                 </a:solidFill>
                 <a:latin typeface="Times New Roman"/>
               </a:rPr>
-              <a:t>7</a:t>
+              <a:t>10</a:t>
             </a:r>
           </a:p>
         </p:txBody>

</xml_diff>

<commit_message>
HFCS poster back to 14 citations; reference document expanded with paper references and further reading (34 total)
Co-Authored-By: Claude Opus 5.5 <noreply@anthropic.com>
Claude-Session: https://claude.ai/code/session_01GDCp9vaBDB24tAeq3Z16Kb
</commit_message>
<xml_diff>
--- a/HFCS_APHA_Poster_Revised.pptx
+++ b/HFCS_APHA_Poster_Revised.pptx
@@ -7004,7 +7004,7 @@
         <p:spPr>
           <a:xfrm>
             <a:off x="685800" y="14374368"/>
-            <a:ext cx="9427464" cy="8778240"/>
+            <a:ext cx="9427464" cy="7360920"/>
           </a:xfrm>
           <a:prstGeom prst="rect">
             <a:avLst/>
@@ -7130,7 +7130,7 @@
                 </a:solidFill>
                 <a:latin typeface="Times New Roman"/>
               </a:rPr>
-              <a:t> and high fructose intake is linked to adverse metabolic effects.</a:t>
+              <a:t> and excess free fructose may affect gut and metabolic health.</a:t>
             </a:r>
             <a:r>
               <a:rPr sz="2400" b="0" i="0" baseline="30000">
@@ -7148,7 +7148,7 @@
                 </a:solidFill>
                 <a:latin typeface="Times New Roman"/>
               </a:rPr>
-              <a:t> Excess free fructose may affect gut health,</a:t>
+              <a:t> The 2025–2030 Dietary Guidelines state that no amount of added sugars is recommended as part of a healthy diet.</a:t>
             </a:r>
             <a:r>
               <a:rPr sz="2400" b="0" i="0" baseline="30000">
@@ -7158,60 +7158,6 @@
                 <a:latin typeface="Times New Roman"/>
               </a:rPr>
               <a:t>7</a:t>
-            </a:r>
-            <a:r>
-              <a:rPr sz="2400" b="0" i="0">
-                <a:solidFill>
-                  <a:srgbClr val="000000"/>
-                </a:solidFill>
-                <a:latin typeface="Times New Roman"/>
-              </a:rPr>
-              <a:t> and preclinical studies link HFCS to inflammation and tumor growth.</a:t>
-            </a:r>
-            <a:r>
-              <a:rPr sz="2400" b="0" i="0" baseline="30000">
-                <a:solidFill>
-                  <a:srgbClr val="000000"/>
-                </a:solidFill>
-                <a:latin typeface="Times New Roman"/>
-              </a:rPr>
-              <a:t>8</a:t>
-            </a:r>
-            <a:r>
-              <a:rPr sz="2400" b="0" i="0">
-                <a:solidFill>
-                  <a:srgbClr val="000000"/>
-                </a:solidFill>
-                <a:latin typeface="Times New Roman"/>
-              </a:rPr>
-              <a:t> The Dietary Guidelines previously advised limiting added sugars to less than 10% of daily calories</a:t>
-            </a:r>
-            <a:r>
-              <a:rPr sz="2400" b="0" i="0" baseline="30000">
-                <a:solidFill>
-                  <a:srgbClr val="000000"/>
-                </a:solidFill>
-                <a:latin typeface="Times New Roman"/>
-              </a:rPr>
-              <a:t>9</a:t>
-            </a:r>
-            <a:r>
-              <a:rPr sz="2400" b="0" i="0">
-                <a:solidFill>
-                  <a:srgbClr val="000000"/>
-                </a:solidFill>
-                <a:latin typeface="Times New Roman"/>
-              </a:rPr>
-              <a:t>; the 2025–2030 edition states that no amount of added sugars is recommended as part of a healthy diet.</a:t>
-            </a:r>
-            <a:r>
-              <a:rPr sz="2400" b="0" i="0" baseline="30000">
-                <a:solidFill>
-                  <a:srgbClr val="000000"/>
-                </a:solidFill>
-                <a:latin typeface="Times New Roman"/>
-              </a:rPr>
-              <a:t>10</a:t>
             </a:r>
             <a:r>
               <a:rPr sz="2400" b="0" i="0">
@@ -7365,7 +7311,7 @@
         </p:nvSpPr>
         <p:spPr>
           <a:xfrm>
-            <a:off x="685800" y="23426928"/>
+            <a:off x="685800" y="22009608"/>
             <a:ext cx="9427464" cy="868680"/>
           </a:xfrm>
           <a:prstGeom prst="rect">
@@ -7415,8 +7361,8 @@
         </p:nvSpPr>
         <p:spPr>
           <a:xfrm>
-            <a:off x="34006536" y="19815048"/>
-            <a:ext cx="9253728" cy="7132320"/>
+            <a:off x="34006536" y="20729448"/>
+            <a:ext cx="9253728" cy="6126480"/>
           </a:xfrm>
           <a:prstGeom prst="rect">
             <a:avLst/>
@@ -7445,7 +7391,7 @@
               </a:spcAft>
             </a:pPr>
             <a:r>
-              <a:rPr sz="2300" b="1" i="0">
+              <a:rPr sz="2400" b="1" i="0">
                 <a:solidFill>
                   <a:srgbClr val="000000"/>
                 </a:solidFill>
@@ -7464,7 +7410,7 @@
               </a:spcAft>
             </a:pPr>
             <a:r>
-              <a:rPr sz="2300" b="0" i="0">
+              <a:rPr sz="2400" b="0" i="0">
                 <a:solidFill>
                   <a:srgbClr val="000000"/>
                 </a:solidFill>
@@ -7483,7 +7429,7 @@
               </a:spcAft>
             </a:pPr>
             <a:r>
-              <a:rPr sz="2300" b="0" i="0">
+              <a:rPr sz="2400" b="0" i="0">
                 <a:solidFill>
                   <a:srgbClr val="000000"/>
                 </a:solidFill>
@@ -7502,7 +7448,7 @@
               </a:spcAft>
             </a:pPr>
             <a:r>
-              <a:rPr sz="2300" b="0" i="0">
+              <a:rPr sz="2400" b="0" i="0">
                 <a:solidFill>
                   <a:srgbClr val="000000"/>
                 </a:solidFill>
@@ -7521,7 +7467,7 @@
               </a:spcAft>
             </a:pPr>
             <a:r>
-              <a:rPr sz="2300" b="0" i="0">
+              <a:rPr sz="2400" b="0" i="0">
                 <a:solidFill>
                   <a:srgbClr val="000000"/>
                 </a:solidFill>
@@ -7540,7 +7486,7 @@
               </a:spcAft>
             </a:pPr>
             <a:r>
-              <a:rPr sz="2300" b="0" i="0">
+              <a:rPr sz="2400" b="0" i="0">
                 <a:solidFill>
                   <a:srgbClr val="000000"/>
                 </a:solidFill>
@@ -7549,16 +7495,16 @@
               <a:t>• Align monitoring with the 2025–2030 Dietary Guidelines</a:t>
             </a:r>
             <a:r>
-              <a:rPr sz="2300" b="0" i="0" baseline="30000">
+              <a:rPr sz="2400" b="0" i="0" baseline="30000">
                 <a:solidFill>
                   <a:srgbClr val="000000"/>
                 </a:solidFill>
                 <a:latin typeface="Times New Roman"/>
               </a:rPr>
-              <a:t>10</a:t>
-            </a:r>
-            <a:r>
-              <a:rPr sz="2300" b="0" i="0">
+              <a:t>7</a:t>
+            </a:r>
+            <a:r>
+              <a:rPr sz="2400" b="0" i="0">
                 <a:solidFill>
                   <a:srgbClr val="000000"/>
                 </a:solidFill>
@@ -7567,13 +7513,32 @@
               <a:t> and added-sugar labeling</a:t>
             </a:r>
             <a:r>
-              <a:rPr sz="2300" b="0" i="0" baseline="30000">
+              <a:rPr sz="2400" b="0" i="0" baseline="30000">
                 <a:solidFill>
                   <a:srgbClr val="000000"/>
                 </a:solidFill>
                 <a:latin typeface="Times New Roman"/>
               </a:rPr>
-              <a:t>22,23</a:t>
+              <a:t>14</a:t>
+            </a:r>
+          </a:p>
+          <a:p>
+            <a:pPr marL="0" indent="0" algn="just">
+              <a:lnSpc>
+                <a:spcPct val="100000"/>
+              </a:lnSpc>
+              <a:spcAft>
+                <a:spcPts val="300"/>
+              </a:spcAft>
+            </a:pPr>
+            <a:r>
+              <a:rPr sz="2400" b="1" i="0">
+                <a:solidFill>
+                  <a:srgbClr val="000000"/>
+                </a:solidFill>
+                <a:latin typeface="Times New Roman"/>
+              </a:rPr>
+              <a:t>Future Work</a:t>
             </a:r>
           </a:p>
           <a:p>
@@ -7586,41 +7551,13 @@
               </a:spcAft>
             </a:pPr>
             <a:r>
-              <a:rPr sz="2300" b="0" i="0">
+              <a:rPr sz="2400" b="0" i="0">
                 <a:solidFill>
                   <a:srgbClr val="000000"/>
                 </a:solidFill>
                 <a:latin typeface="Times New Roman"/>
               </a:rPr>
-              <a:t>• Consider disparities in fructose-rich food intake and metabolic syndrome</a:t>
-            </a:r>
-            <a:r>
-              <a:rPr sz="2300" b="0" i="0" baseline="30000">
-                <a:solidFill>
-                  <a:srgbClr val="000000"/>
-                </a:solidFill>
-                <a:latin typeface="Times New Roman"/>
-              </a:rPr>
-              <a:t>24</a:t>
-            </a:r>
-          </a:p>
-          <a:p>
-            <a:pPr marL="0" indent="0" algn="just">
-              <a:lnSpc>
-                <a:spcPct val="100000"/>
-              </a:lnSpc>
-              <a:spcAft>
-                <a:spcPts val="300"/>
-              </a:spcAft>
-            </a:pPr>
-            <a:r>
-              <a:rPr sz="2300" b="1" i="0">
-                <a:solidFill>
-                  <a:srgbClr val="000000"/>
-                </a:solidFill>
-                <a:latin typeface="Times New Roman"/>
-              </a:rPr>
-              <a:t>Future Work</a:t>
+              <a:t>• Link ingredient data to sales-weighted or scanner data to estimate exposure</a:t>
             </a:r>
           </a:p>
           <a:p>
@@ -7633,13 +7570,13 @@
               </a:spcAft>
             </a:pPr>
             <a:r>
-              <a:rPr sz="2300" b="0" i="0">
+              <a:rPr sz="2400" b="0" i="0">
                 <a:solidFill>
                   <a:srgbClr val="000000"/>
                 </a:solidFill>
                 <a:latin typeface="Times New Roman"/>
               </a:rPr>
-              <a:t>• Link ingredient data to sales-weighted or scanner data to estimate exposure</a:t>
+              <a:t>• Stratify prevalence by food category and trade channel</a:t>
             </a:r>
           </a:p>
           <a:p>
@@ -7652,13 +7589,13 @@
               </a:spcAft>
             </a:pPr>
             <a:r>
-              <a:rPr sz="2300" b="0" i="0">
+              <a:rPr sz="2400" b="0" i="0">
                 <a:solidFill>
                   <a:srgbClr val="000000"/>
                 </a:solidFill>
                 <a:latin typeface="Times New Roman"/>
               </a:rPr>
-              <a:t>• Stratify prevalence by food category and trade channel</a:t>
+              <a:t>• Compare HFCS with other added sugars in the same database</a:t>
             </a:r>
           </a:p>
           <a:p>
@@ -7671,26 +7608,7 @@
               </a:spcAft>
             </a:pPr>
             <a:r>
-              <a:rPr sz="2300" b="0" i="0">
-                <a:solidFill>
-                  <a:srgbClr val="000000"/>
-                </a:solidFill>
-                <a:latin typeface="Times New Roman"/>
-              </a:rPr>
-              <a:t>• Compare HFCS with other added sugars in the same database</a:t>
-            </a:r>
-          </a:p>
-          <a:p>
-            <a:pPr algn="l" marL="274320" indent="-274320">
-              <a:lnSpc>
-                <a:spcPct val="100000"/>
-              </a:lnSpc>
-              <a:spcAft>
-                <a:spcPts val="300"/>
-              </a:spcAft>
-            </a:pPr>
-            <a:r>
-              <a:rPr sz="2300" b="0" i="0">
+              <a:rPr sz="2400" b="0" i="0">
                 <a:solidFill>
                   <a:srgbClr val="000000"/>
                 </a:solidFill>
@@ -7715,7 +7633,7 @@
         </p:nvSpPr>
         <p:spPr>
           <a:xfrm>
-            <a:off x="34006536" y="18443448"/>
+            <a:off x="34006536" y="19357848"/>
             <a:ext cx="9253728" cy="1371600"/>
           </a:xfrm>
           <a:prstGeom prst="rect">
@@ -7765,7 +7683,7 @@
         </p:nvSpPr>
         <p:spPr>
           <a:xfrm>
-            <a:off x="34006536" y="27221688"/>
+            <a:off x="34006536" y="27130248"/>
             <a:ext cx="9253728" cy="868680"/>
           </a:xfrm>
           <a:prstGeom prst="rect">
@@ -7816,7 +7734,7 @@
         <p:spPr>
           <a:xfrm>
             <a:off x="34006536" y="5458968"/>
-            <a:ext cx="9253728" cy="12710160"/>
+            <a:ext cx="9253728" cy="13624560"/>
           </a:xfrm>
           <a:prstGeom prst="rect">
             <a:avLst/>
@@ -7845,7 +7763,7 @@
               </a:spcAft>
             </a:pPr>
             <a:r>
-              <a:rPr sz="2400" b="1" i="0">
+              <a:rPr sz="2500" b="1" i="0">
                 <a:solidFill>
                   <a:srgbClr val="000000"/>
                 </a:solidFill>
@@ -7868,7 +7786,7 @@
               </a:spcAft>
             </a:pPr>
             <a:r>
-              <a:rPr sz="2400" b="0" i="0">
+              <a:rPr sz="2500" b="0" i="0">
                 <a:solidFill>
                   <a:srgbClr val="000000"/>
                 </a:solidFill>
@@ -7877,7 +7795,7 @@
               <a:t>Of 454,324 products identified, 6,717 were excluded, leaving 447,607 eligible U.S. branded products (Figure 1). HFCS was listed in </a:t>
             </a:r>
             <a:r>
-              <a:rPr sz="2400" b="1" i="0">
+              <a:rPr sz="2500" b="1" i="0">
                 <a:solidFill>
                   <a:srgbClr val="000000"/>
                 </a:solidFill>
@@ -7886,7 +7804,7 @@
               <a:t>29,503 products (6.6%)</a:t>
             </a:r>
             <a:r>
-              <a:rPr sz="2400" b="0" i="0">
+              <a:rPr sz="2500" b="0" i="0">
                 <a:solidFill>
                   <a:srgbClr val="000000"/>
                 </a:solidFill>
@@ -7905,7 +7823,7 @@
               </a:spcAft>
             </a:pPr>
             <a:r>
-              <a:rPr sz="2400" b="1" i="0">
+              <a:rPr sz="2500" b="1" i="0">
                 <a:solidFill>
                   <a:srgbClr val="000000"/>
                 </a:solidFill>
@@ -7924,16 +7842,16 @@
               </a:spcAft>
             </a:pPr>
             <a:r>
-              <a:rPr sz="2400" b="0" i="0">
+              <a:rPr sz="2500" b="0" i="0">
                 <a:solidFill>
                   <a:srgbClr val="000000"/>
                 </a:solidFill>
                 <a:latin typeface="Times New Roman"/>
               </a:rPr>
-              <a:t>HFCS appeared in a minority of products, yet its presence in nearly 30,000 items shows it remains embedded in the U.S. food supply. A 6.6% product share is not low exposure: counts are not sales-weighted, and HFCS may cluster in high-consumption foods such as sweetened beverages, desserts, and condiments. HFCS use grew rapidly after the 1970s</a:t>
-            </a:r>
-            <a:r>
-              <a:rPr sz="2400" b="0" i="0" baseline="30000">
+              <a:t>HFCS appeared in a minority of products, yet its presence in nearly 30,000 items shows it remains embedded in the U.S. food supply. A 6.6% product share is not low exposure: counts are not sales-weighted, and HFCS may cluster in high-consumption foods such as sweetened beverages, desserts, and condiments. HFCS use grew rapidly after the 1970s,</a:t>
+            </a:r>
+            <a:r>
+              <a:rPr sz="2500" b="0" i="0" baseline="30000">
                 <a:solidFill>
                   <a:srgbClr val="000000"/>
                 </a:solidFill>
@@ -7942,97 +7860,79 @@
               <a:t>4</a:t>
             </a:r>
             <a:r>
-              <a:rPr sz="2400" b="0" i="0">
+              <a:rPr sz="2500" b="0" i="0">
                 <a:solidFill>
                   <a:srgbClr val="000000"/>
                 </a:solidFill>
                 <a:latin typeface="Times New Roman"/>
               </a:rPr>
-              <a:t> and peaked in 1999</a:t>
-            </a:r>
-            <a:r>
-              <a:rPr sz="2400" b="0" i="0" baseline="30000">
+              <a:t> and although per capita corn sweetener availability has fallen 38% since its 1999 peak (Figure 4),</a:t>
+            </a:r>
+            <a:r>
+              <a:rPr sz="2500" b="0" i="0" baseline="30000">
                 <a:solidFill>
                   <a:srgbClr val="000000"/>
                 </a:solidFill>
                 <a:latin typeface="Times New Roman"/>
               </a:rPr>
-              <a:t>17</a:t>
-            </a:r>
-            <a:r>
-              <a:rPr sz="2400" b="0" i="0">
+              <a:t>10</a:t>
+            </a:r>
+            <a:r>
+              <a:rPr sz="2500" b="0" i="0">
                 <a:solidFill>
                   <a:srgbClr val="000000"/>
                 </a:solidFill>
                 <a:latin typeface="Times New Roman"/>
               </a:rPr>
-              <a:t>; although per capita corn sweetener availability has since fallen 38% (Figure 4),</a:t>
-            </a:r>
-            <a:r>
-              <a:rPr sz="2400" b="0" i="0" baseline="30000">
+              <a:t> HFCS remains common. Ultra-processed foods supply 89.7% of energy from added sugars in the U.S. diet,</a:t>
+            </a:r>
+            <a:r>
+              <a:rPr sz="2500" b="0" i="0" baseline="30000">
                 <a:solidFill>
                   <a:srgbClr val="000000"/>
                 </a:solidFill>
                 <a:latin typeface="Times New Roman"/>
               </a:rPr>
-              <a:t>15</a:t>
-            </a:r>
-            <a:r>
-              <a:rPr sz="2400" b="0" i="0">
+              <a:t>11</a:t>
+            </a:r>
+            <a:r>
+              <a:rPr sz="2500" b="0" i="0">
                 <a:solidFill>
                   <a:srgbClr val="000000"/>
                 </a:solidFill>
                 <a:latin typeface="Times New Roman"/>
               </a:rPr>
-              <a:t> HFCS remains common. Ultra-processed foods supply 89.7% of energy from added sugars in the U.S. diet,</a:t>
-            </a:r>
-            <a:r>
-              <a:rPr sz="2400" b="0" i="0" baseline="30000">
+              <a:t> and sugar-sweetened beverages are linked to weight gain in children and adults.</a:t>
+            </a:r>
+            <a:r>
+              <a:rPr sz="2500" b="0" i="0" baseline="30000">
                 <a:solidFill>
                   <a:srgbClr val="000000"/>
                 </a:solidFill>
                 <a:latin typeface="Times New Roman"/>
               </a:rPr>
-              <a:t>16</a:t>
-            </a:r>
-            <a:r>
-              <a:rPr sz="2400" b="0" i="0">
+              <a:t>12</a:t>
+            </a:r>
+            <a:r>
+              <a:rPr sz="2500" b="0" i="0">
                 <a:solidFill>
                   <a:srgbClr val="000000"/>
                 </a:solidFill>
                 <a:latin typeface="Times New Roman"/>
               </a:rPr>
-              <a:t> and sugar-sweetened beverages are linked to weight gain in children and adults.</a:t>
-            </a:r>
-            <a:r>
-              <a:rPr sz="2400" b="0" i="0" baseline="30000">
+              <a:t> HFCS and sucrose have similar metabolic effects at equal intake,</a:t>
+            </a:r>
+            <a:r>
+              <a:rPr sz="2500" b="0" i="0" baseline="30000">
                 <a:solidFill>
                   <a:srgbClr val="000000"/>
                 </a:solidFill>
                 <a:latin typeface="Times New Roman"/>
               </a:rPr>
-              <a:t>18</a:t>
-            </a:r>
-            <a:r>
-              <a:rPr sz="2400" b="0" i="0">
-                <a:solidFill>
-                  <a:srgbClr val="000000"/>
-                </a:solidFill>
-                <a:latin typeface="Times New Roman"/>
-              </a:rPr>
-              <a:t> HFCS and sucrose have similar metabolic effects at equal intake,</a:t>
-            </a:r>
-            <a:r>
-              <a:rPr sz="2400" b="0" i="0" baseline="30000">
-                <a:solidFill>
-                  <a:srgbClr val="000000"/>
-                </a:solidFill>
-                <a:latin typeface="Times New Roman"/>
-              </a:rPr>
-              <a:t>19,20</a:t>
-            </a:r>
-            <a:r>
-              <a:rPr sz="2400" b="0" i="0">
+              <a:t>13</a:t>
+            </a:r>
+            <a:r>
+              <a:rPr sz="2500" b="0" i="0">
                 <a:solidFill>
                   <a:srgbClr val="000000"/>
                 </a:solidFill>
@@ -8051,7 +7951,7 @@
               </a:spcAft>
             </a:pPr>
             <a:r>
-              <a:rPr sz="2400" b="1" i="0">
+              <a:rPr sz="2500" b="1" i="0">
                 <a:solidFill>
                   <a:srgbClr val="000000"/>
                 </a:solidFill>
@@ -8070,7 +7970,7 @@
               </a:spcAft>
             </a:pPr>
             <a:r>
-              <a:rPr sz="2400" b="0" i="0">
+              <a:rPr sz="2500" b="0" i="0">
                 <a:solidFill>
                   <a:srgbClr val="000000"/>
                 </a:solidFill>
@@ -8089,7 +7989,7 @@
               </a:spcAft>
             </a:pPr>
             <a:r>
-              <a:rPr sz="2400" b="1" i="0">
+              <a:rPr sz="2500" b="1" i="0">
                 <a:solidFill>
                   <a:srgbClr val="000000"/>
                 </a:solidFill>
@@ -8108,7 +8008,7 @@
               </a:spcAft>
             </a:pPr>
             <a:r>
-              <a:rPr sz="2400" b="0" i="0">
+              <a:rPr sz="2500" b="0" i="0">
                 <a:solidFill>
                   <a:srgbClr val="000000"/>
                 </a:solidFill>
@@ -8117,7 +8017,7 @@
               <a:t>• </a:t>
             </a:r>
             <a:r>
-              <a:rPr sz="2400" b="1" i="0">
+              <a:rPr sz="2500" b="1" i="0">
                 <a:solidFill>
                   <a:srgbClr val="000000"/>
                 </a:solidFill>
@@ -8126,7 +8026,7 @@
               <a:t>Presence only:</a:t>
             </a:r>
             <a:r>
-              <a:rPr sz="2400" b="0" i="0">
+              <a:rPr sz="2500" b="0" i="0">
                 <a:solidFill>
                   <a:srgbClr val="000000"/>
                 </a:solidFill>
@@ -8145,7 +8045,7 @@
               </a:spcAft>
             </a:pPr>
             <a:r>
-              <a:rPr sz="2400" b="0" i="0">
+              <a:rPr sz="2500" b="0" i="0">
                 <a:solidFill>
                   <a:srgbClr val="000000"/>
                 </a:solidFill>
@@ -8154,7 +8054,7 @@
               <a:t>• </a:t>
             </a:r>
             <a:r>
-              <a:rPr sz="2400" b="1" i="0">
+              <a:rPr sz="2500" b="1" i="0">
                 <a:solidFill>
                   <a:srgbClr val="000000"/>
                 </a:solidFill>
@@ -8163,22 +8063,13 @@
               <a:t>Industry-supplied data:</a:t>
             </a:r>
             <a:r>
-              <a:rPr sz="2400" b="0" i="0">
+              <a:rPr sz="2500" b="0" i="0">
                 <a:solidFill>
                   <a:srgbClr val="000000"/>
                 </a:solidFill>
                 <a:latin typeface="Times New Roman"/>
               </a:rPr>
               <a:t> quality and completeness vary by contributor</a:t>
-            </a:r>
-            <a:r>
-              <a:rPr sz="2400" b="0" i="0" baseline="30000">
-                <a:solidFill>
-                  <a:srgbClr val="000000"/>
-                </a:solidFill>
-                <a:latin typeface="Times New Roman"/>
-              </a:rPr>
-              <a:t>13,21</a:t>
             </a:r>
           </a:p>
           <a:p>
@@ -8191,7 +8082,7 @@
               </a:spcAft>
             </a:pPr>
             <a:r>
-              <a:rPr sz="2400" b="0" i="0">
+              <a:rPr sz="2500" b="0" i="0">
                 <a:solidFill>
                   <a:srgbClr val="000000"/>
                 </a:solidFill>
@@ -8200,7 +8091,7 @@
               <a:t>• </a:t>
             </a:r>
             <a:r>
-              <a:rPr sz="2400" b="1" i="0">
+              <a:rPr sz="2500" b="1" i="0">
                 <a:solidFill>
                   <a:srgbClr val="000000"/>
                 </a:solidFill>
@@ -8209,7 +8100,7 @@
               <a:t>Search terms:</a:t>
             </a:r>
             <a:r>
-              <a:rPr sz="2400" b="0" i="0">
+              <a:rPr sz="2500" b="0" i="0">
                 <a:solidFill>
                   <a:srgbClr val="000000"/>
                 </a:solidFill>
@@ -8228,7 +8119,7 @@
               </a:spcAft>
             </a:pPr>
             <a:r>
-              <a:rPr sz="2400" b="0" i="0">
+              <a:rPr sz="2500" b="0" i="0">
                 <a:solidFill>
                   <a:srgbClr val="000000"/>
                 </a:solidFill>
@@ -8237,7 +8128,7 @@
               <a:t>• </a:t>
             </a:r>
             <a:r>
-              <a:rPr sz="2400" b="1" i="0">
+              <a:rPr sz="2500" b="1" i="0">
                 <a:solidFill>
                   <a:srgbClr val="000000"/>
                 </a:solidFill>
@@ -8246,7 +8137,7 @@
               <a:t>Item-level records:</a:t>
             </a:r>
             <a:r>
-              <a:rPr sz="2400" b="0" i="0">
+              <a:rPr sz="2500" b="0" i="0">
                 <a:solidFill>
                   <a:srgbClr val="000000"/>
                 </a:solidFill>
@@ -8328,8 +8219,8 @@
           </p:nvPr>
         </p:nvGraphicFramePr>
         <p:xfrm>
-          <a:off x="685800" y="24341328"/>
-          <a:ext cx="9427464" cy="8010144"/>
+          <a:off x="685800" y="22924008"/>
+          <a:ext cx="9427464" cy="9473184"/>
         </p:xfrm>
         <a:graphic>
           <a:graphicData uri="http://schemas.openxmlformats.org/drawingml/2006/table">
@@ -8398,7 +8289,7 @@
                   </a:ext>
                 </a:extLst>
               </a:tr>
-              <a:tr h="2103120">
+              <a:tr h="2651760">
                 <a:tc>
                   <a:txBody>
                     <a:bodyPr wrap="square"/>
@@ -8431,7 +8322,7 @@
                           </a:solidFill>
                           <a:latin typeface="Times New Roman"/>
                         </a:rPr>
-                        <a:t>Retrospective, cross-sectional, descriptive analysis of the USDA FoodData Central (FDC) Global Branded Food Products Database (GBFPD)</a:t>
+                        <a:t>Retrospective, cross-sectional, descriptive analysis of the USDA FoodData Central (FDC) Global Branded Food Products Database (GBFPD): 400,000+ branded and private-label products, supplied by industry and updated monthly.</a:t>
                       </a:r>
                       <a:r>
                         <a:rPr sz="2400" b="0" i="0" baseline="30000">
@@ -8440,25 +8331,7 @@
                           </a:solidFill>
                           <a:latin typeface="Times New Roman"/>
                         </a:rPr>
-                        <a:t>11,12</a:t>
-                      </a:r>
-                      <a:r>
-                        <a:rPr sz="2400" b="0" i="0">
-                          <a:solidFill>
-                            <a:srgbClr val="000000"/>
-                          </a:solidFill>
-                          <a:latin typeface="Times New Roman"/>
-                        </a:rPr>
-                        <a:t>: 400,000+ branded and private-label products, supplied by industry and updated monthly.</a:t>
-                      </a:r>
-                      <a:r>
-                        <a:rPr sz="2400" b="0" i="0" baseline="30000">
-                          <a:solidFill>
-                            <a:srgbClr val="000000"/>
-                          </a:solidFill>
-                          <a:latin typeface="Times New Roman"/>
-                        </a:rPr>
-                        <a:t>13</a:t>
+                        <a:t>8,9</a:t>
                       </a:r>
                       <a:endParaRPr lang="en-US" sz="2400" dirty="0">
                         <a:latin typeface="Times New Roman" panose="02020603050405020304" pitchFamily="18" charset="0"/>
@@ -8474,7 +8347,7 @@
                   </a:ext>
                 </a:extLst>
               </a:tr>
-              <a:tr h="2743200">
+              <a:tr h="3383280">
                 <a:tc>
                   <a:txBody>
                     <a:bodyPr wrap="square"/>
@@ -8507,25 +8380,7 @@
                           </a:solidFill>
                           <a:latin typeface="Times New Roman"/>
                         </a:rPr>
-                        <a:t>FDC branded foods search</a:t>
-                      </a:r>
-                      <a:r>
-                        <a:rPr sz="2400" b="0" i="0" baseline="30000">
-                          <a:solidFill>
-                            <a:srgbClr val="000000"/>
-                          </a:solidFill>
-                          <a:latin typeface="Times New Roman"/>
-                        </a:rPr>
-                        <a:t>14</a:t>
-                      </a:r>
-                      <a:r>
-                        <a:rPr sz="2400" b="0" i="0">
-                          <a:solidFill>
-                            <a:srgbClr val="000000"/>
-                          </a:solidFill>
-                          <a:latin typeface="Times New Roman"/>
-                        </a:rPr>
-                        <a:t> by published date, April 13, 2019 (earliest available) to December 13, 2025 (search date). Trade channels: grocery, convenience, mass merchandising, food service, vending, online, military, child nutrition programs, and none. </a:t>
+                        <a:t>FDC published date April 13, 2019 (earliest available) to December 13, 2025 (search date). Trade channels: grocery, convenience, mass merchandising, food service, vending, online, military, child nutrition programs, and none. </a:t>
                       </a:r>
                       <a:r>
                         <a:rPr sz="2400" b="1" i="0">
@@ -8559,7 +8414,7 @@
                   </a:ext>
                 </a:extLst>
               </a:tr>
-              <a:tr h="1280160">
+              <a:tr h="1463040">
                 <a:tc>
                   <a:txBody>
                     <a:bodyPr wrap="square"/>
@@ -8608,7 +8463,7 @@
                   </a:ext>
                 </a:extLst>
               </a:tr>
-              <a:tr h="1280160">
+              <a:tr h="1371600">
                 <a:tc>
                   <a:txBody>
                     <a:bodyPr wrap="square"/>
@@ -8705,8 +8560,8 @@
         </p:nvSpPr>
         <p:spPr>
           <a:xfrm>
-            <a:off x="36722304" y="28273248"/>
-            <a:ext cx="3822191" cy="3822191"/>
+            <a:off x="36676584" y="28181808"/>
+            <a:ext cx="3913631" cy="3913631"/>
           </a:xfrm>
           <a:prstGeom prst="rect">
             <a:avLst/>
@@ -8758,7 +8613,7 @@
                 </a:solidFill>
                 <a:latin typeface="Times New Roman"/>
               </a:rPr>
-              <a:t>(4.2 × 4.2 in; links to the full AMA reference list)</a:t>
+              <a:t>(4.3 × 4.3 in; links to the full AMA reference list)</a:t>
             </a:r>
           </a:p>
         </p:txBody>
@@ -9389,7 +9244,7 @@
                 </a:solidFill>
                 <a:latin typeface="Times New Roman"/>
               </a:rPr>
-              <a:t>15</a:t>
+              <a:t>10</a:t>
             </a:r>
           </a:p>
         </p:txBody>
@@ -9501,7 +9356,7 @@
                 </a:solidFill>
                 <a:latin typeface="Times New Roman"/>
               </a:rPr>
-              <a:t>16</a:t>
+              <a:t>11</a:t>
             </a:r>
           </a:p>
         </p:txBody>
@@ -9578,7 +9433,7 @@
                 </a:solidFill>
                 <a:latin typeface="Times New Roman"/>
               </a:rPr>
-              <a:t>16</a:t>
+              <a:t>11</a:t>
             </a:r>
           </a:p>
         </p:txBody>
@@ -9655,7 +9510,7 @@
                 </a:solidFill>
                 <a:latin typeface="Times New Roman"/>
               </a:rPr>
-              <a:t>16</a:t>
+              <a:t>11</a:t>
             </a:r>
           </a:p>
         </p:txBody>
@@ -9732,7 +9587,7 @@
                 </a:solidFill>
                 <a:latin typeface="Times New Roman"/>
               </a:rPr>
-              <a:t>10</a:t>
+              <a:t>7</a:t>
             </a:r>
           </a:p>
         </p:txBody>

</xml_diff>

<commit_message>
Add author line (Roberts, Mazonde, Shobayo) and department to HFCS poster, reference lists, and paper
Co-Authored-By: Claude Opus 5.5 <noreply@anthropic.com>
Claude-Session: https://claude.ai/code/session_01GDCp9vaBDB24tAeq3Z16Kb
</commit_message>
<xml_diff>
--- a/HFCS_APHA_Poster_Revised.pptx
+++ b/HFCS_APHA_Poster_Revised.pptx
@@ -6623,7 +6623,7 @@
                 </a:solidFill>
                 <a:latin typeface="Times New Roman"/>
               </a:rPr>
-              <a:t>[Author Name, Credentials; Author Name, Credentials; Author Name, Credentials]</a:t>
+              <a:t>Miebaka F. Roberts; Chelsea R. Mazonde, MPH; Ifeoluwanimi P. Shobayo, MSPH</a:t>
             </a:r>
           </a:p>
           <a:p>
@@ -6639,7 +6639,7 @@
                 </a:solidFill>
                 <a:latin typeface="Times New Roman"/>
               </a:rPr>
-              <a:t>[Department], Liberty University</a:t>
+              <a:t>Department of Public and Community Health, Liberty University</a:t>
             </a:r>
           </a:p>
         </p:txBody>

</xml_diff>